<commit_message>
docs(style): finalize Woven Flightpath brand assets
Summary:
- Embed the Flightpath mark in Devpost SVGs and refresh raster exports.
- Update the product gallery screenshots and hackathon pitch deck.

Rationale:
- Keep every public artifact portable and consistent with the product UI.
- Preserve readable layouts across browser, image, and slide formats.

Tests:
- npm run check
- xmllint, PPTX overflow test, and visual review of all nine slides
</commit_message>
<xml_diff>
--- a/docs/Woven-Hackathon-Pitch.pptx
+++ b/docs/Woven-Hackathon-Pitch.pptx
@@ -2,21 +2,21 @@
 <file path=ppt/presentation.xml><?xml version="1.0" encoding="utf-8"?>
 <p:presentation xmlns:p="http://schemas.openxmlformats.org/presentationml/2006/main">
   <p:sldMasterIdLst>
-    <p:sldMasterId xmlns:r="http://schemas.openxmlformats.org/officeDocument/2006/relationships" id="2147483648" r:id="Rb82f4fb37656493c"/>
+    <p:sldMasterId xmlns:r="http://schemas.openxmlformats.org/officeDocument/2006/relationships" id="2147483648" r:id="Rc93c364e42da464f"/>
   </p:sldMasterIdLst>
   <p:notesMasterIdLst>
-    <p:notesMasterId xmlns:r="http://schemas.openxmlformats.org/officeDocument/2006/relationships" r:id="Reaf217983c29466d"/>
+    <p:notesMasterId xmlns:r="http://schemas.openxmlformats.org/officeDocument/2006/relationships" r:id="Rfd85ba31c960496f"/>
   </p:notesMasterIdLst>
   <p:sldIdLst>
-    <p:sldId xmlns:r="http://schemas.openxmlformats.org/officeDocument/2006/relationships" id="256" r:id="R4f18ace45bbc4689"/>
-    <p:sldId xmlns:r="http://schemas.openxmlformats.org/officeDocument/2006/relationships" id="257" r:id="R2625f8c7e4f24e34"/>
-    <p:sldId xmlns:r="http://schemas.openxmlformats.org/officeDocument/2006/relationships" id="258" r:id="R8a24fbdd071e4538"/>
-    <p:sldId xmlns:r="http://schemas.openxmlformats.org/officeDocument/2006/relationships" id="259" r:id="R908bb7450eac4bba"/>
-    <p:sldId xmlns:r="http://schemas.openxmlformats.org/officeDocument/2006/relationships" id="260" r:id="R70abc0f91dd84462"/>
-    <p:sldId xmlns:r="http://schemas.openxmlformats.org/officeDocument/2006/relationships" id="261" r:id="R31ae825fc2ee4f35"/>
-    <p:sldId xmlns:r="http://schemas.openxmlformats.org/officeDocument/2006/relationships" id="262" r:id="R437c1b49705848ae"/>
-    <p:sldId xmlns:r="http://schemas.openxmlformats.org/officeDocument/2006/relationships" id="263" r:id="R8e187a183b1c4026"/>
-    <p:sldId xmlns:r="http://schemas.openxmlformats.org/officeDocument/2006/relationships" id="264" r:id="R40a1cb49afe94302"/>
+    <p:sldId xmlns:r="http://schemas.openxmlformats.org/officeDocument/2006/relationships" id="256" r:id="R8d254256f3bb4b72"/>
+    <p:sldId xmlns:r="http://schemas.openxmlformats.org/officeDocument/2006/relationships" id="257" r:id="R66c4ab50d04b4f23"/>
+    <p:sldId xmlns:r="http://schemas.openxmlformats.org/officeDocument/2006/relationships" id="258" r:id="Rfd11a6a7866746ae"/>
+    <p:sldId xmlns:r="http://schemas.openxmlformats.org/officeDocument/2006/relationships" id="259" r:id="R44109ed6262749a4"/>
+    <p:sldId xmlns:r="http://schemas.openxmlformats.org/officeDocument/2006/relationships" id="260" r:id="Re696fabd930c450c"/>
+    <p:sldId xmlns:r="http://schemas.openxmlformats.org/officeDocument/2006/relationships" id="261" r:id="R434d400806714b70"/>
+    <p:sldId xmlns:r="http://schemas.openxmlformats.org/officeDocument/2006/relationships" id="262" r:id="R121481306528463c"/>
+    <p:sldId xmlns:r="http://schemas.openxmlformats.org/officeDocument/2006/relationships" id="263" r:id="R134a87dca8a1473c"/>
+    <p:sldId xmlns:r="http://schemas.openxmlformats.org/officeDocument/2006/relationships" id="264" r:id="R6bc8eef9e20b4f03"/>
   </p:sldIdLst>
   <p:sldSz cx="15240000" cy="8572500"/>
   <p:notesSz cx="6858000" cy="9144000"/>
@@ -1293,7 +1293,7 @@
   </p:cSld>
   <p:clrMap bg1="lt1" tx1="dk1" bg2="lt2" tx2="dk2" accent1="accent1" accent2="accent2" accent3="accent3" accent4="accent4" accent5="accent5" accent6="accent6" hlink="hlink" folHlink="folHlink"/>
   <p:sldLayoutIdLst>
-    <p:sldLayoutId xmlns:r="http://schemas.openxmlformats.org/officeDocument/2006/relationships" id="2147483649" r:id="R9440987ace004395"/>
+    <p:sldLayoutId xmlns:r="http://schemas.openxmlformats.org/officeDocument/2006/relationships" id="2147483649" r:id="R63ea19c7d0164621"/>
   </p:sldLayoutIdLst>
   <p:txStyles>
     <p:titleStyle>
@@ -1841,7 +1841,7 @@
           <p:nvPr/>
         </p:nvPicPr>
         <p:blipFill>
-          <a:blip xmlns:r="http://schemas.openxmlformats.org/officeDocument/2006/relationships" xmlns:a="http://schemas.openxmlformats.org/drawingml/2006/main" r:embed="Rb8e4f870dca14ec2"/>
+          <a:blip xmlns:r="http://schemas.openxmlformats.org/officeDocument/2006/relationships" xmlns:a="http://schemas.openxmlformats.org/drawingml/2006/main" r:embed="R518f8e1e769543be"/>
           <a:srcRect xmlns:a="http://schemas.openxmlformats.org/drawingml/2006/main" l="0" t="0" r="0" b="0"/>
           <a:stretch xmlns:a="http://schemas.openxmlformats.org/drawingml/2006/main">
             <a:fillRect l="0" t="0" r="0" b="0"/>
@@ -1873,7 +1873,7 @@
     <p:bg>
       <p:bgPr>
         <a:solidFill xmlns:a="http://schemas.openxmlformats.org/drawingml/2006/main">
-          <a:srgbClr val="F0EADF"/>
+          <a:srgbClr val="F4EEE4"/>
         </a:solidFill>
       </p:bgPr>
     </p:bg>
@@ -1924,7 +1924,7 @@
               <a:buNone/>
               <a:defRPr sz="1350" b="1">
                 <a:solidFill>
-                  <a:srgbClr val="6F746F"/>
+                  <a:srgbClr val="6D7974"/>
                 </a:solidFill>
                 <a:latin typeface="Menlo"/>
                 <a:ea typeface="Menlo"/>
@@ -1934,7 +1934,7 @@
             <a:r>
               <a:rPr sz="1350" b="1">
                 <a:solidFill>
-                  <a:srgbClr val="6F746F"/>
+                  <a:srgbClr val="6D7974"/>
                 </a:solidFill>
                 <a:latin typeface="Menlo"/>
                 <a:ea typeface="Menlo"/>
@@ -1986,7 +1986,7 @@
               <a:buNone/>
               <a:defRPr sz="4650" b="1">
                 <a:solidFill>
-                  <a:srgbClr val="17231F"/>
+                  <a:srgbClr val="0E4B3B"/>
                 </a:solidFill>
                 <a:latin typeface="Georgia"/>
                 <a:ea typeface="Georgia"/>
@@ -1996,7 +1996,7 @@
             <a:r>
               <a:rPr sz="4650" b="1">
                 <a:solidFill>
-                  <a:srgbClr val="17231F"/>
+                  <a:srgbClr val="0E4B3B"/>
                 </a:solidFill>
                 <a:latin typeface="Georgia"/>
                 <a:ea typeface="Georgia"/>
@@ -2094,7 +2094,7 @@
           <a:noFill xmlns:a="http://schemas.openxmlformats.org/drawingml/2006/main"/>
           <a:ln xmlns:a="http://schemas.openxmlformats.org/drawingml/2006/main" w="47625">
             <a:solidFill>
-              <a:srgbClr val="FF6B45"/>
+              <a:srgbClr val="B7F522"/>
             </a:solidFill>
             <a:prstDash val="solid"/>
           </a:ln>
@@ -2138,7 +2138,7 @@
               <a:buNone/>
               <a:defRPr sz="1650" b="1">
                 <a:solidFill>
-                  <a:srgbClr val="6F746F"/>
+                  <a:srgbClr val="6D7974"/>
                 </a:solidFill>
                 <a:latin typeface="Menlo"/>
                 <a:ea typeface="Menlo"/>
@@ -2148,7 +2148,7 @@
             <a:r>
               <a:rPr sz="1650" b="1">
                 <a:solidFill>
-                  <a:srgbClr val="6F746F"/>
+                  <a:srgbClr val="6D7974"/>
                 </a:solidFill>
                 <a:latin typeface="Menlo"/>
                 <a:ea typeface="Menlo"/>
@@ -2197,7 +2197,7 @@
               <a:buNone/>
               <a:defRPr sz="2250" b="1">
                 <a:solidFill>
-                  <a:srgbClr val="17231F"/>
+                  <a:srgbClr val="0E4B3B"/>
                 </a:solidFill>
                 <a:latin typeface="Avenir Next"/>
                 <a:ea typeface="Avenir Next"/>
@@ -2207,7 +2207,7 @@
             <a:r>
               <a:rPr sz="2250" b="1">
                 <a:solidFill>
-                  <a:srgbClr val="17231F"/>
+                  <a:srgbClr val="0E4B3B"/>
                 </a:solidFill>
                 <a:latin typeface="Avenir Next"/>
                 <a:ea typeface="Avenir Next"/>
@@ -2259,7 +2259,7 @@
               <a:buNone/>
               <a:defRPr sz="1800">
                 <a:solidFill>
-                  <a:srgbClr val="6F746F"/>
+                  <a:srgbClr val="6D7974"/>
                 </a:solidFill>
                 <a:latin typeface="Avenir Next"/>
                 <a:ea typeface="Avenir Next"/>
@@ -2269,7 +2269,7 @@
             <a:r>
               <a:rPr sz="1800">
                 <a:solidFill>
-                  <a:srgbClr val="6F746F"/>
+                  <a:srgbClr val="6D7974"/>
                 </a:solidFill>
                 <a:latin typeface="Avenir Next"/>
                 <a:ea typeface="Avenir Next"/>
@@ -2349,7 +2349,7 @@
               <a:buNone/>
               <a:defRPr sz="1650" b="1">
                 <a:solidFill>
-                  <a:srgbClr val="6F746F"/>
+                  <a:srgbClr val="6D7974"/>
                 </a:solidFill>
                 <a:latin typeface="Menlo"/>
                 <a:ea typeface="Menlo"/>
@@ -2359,7 +2359,7 @@
             <a:r>
               <a:rPr sz="1650" b="1">
                 <a:solidFill>
-                  <a:srgbClr val="6F746F"/>
+                  <a:srgbClr val="6D7974"/>
                 </a:solidFill>
                 <a:latin typeface="Menlo"/>
                 <a:ea typeface="Menlo"/>
@@ -2408,7 +2408,7 @@
               <a:buNone/>
               <a:defRPr sz="2250" b="1">
                 <a:solidFill>
-                  <a:srgbClr val="17231F"/>
+                  <a:srgbClr val="0E4B3B"/>
                 </a:solidFill>
                 <a:latin typeface="Avenir Next"/>
                 <a:ea typeface="Avenir Next"/>
@@ -2418,7 +2418,7 @@
             <a:r>
               <a:rPr sz="2250" b="1">
                 <a:solidFill>
-                  <a:srgbClr val="17231F"/>
+                  <a:srgbClr val="0E4B3B"/>
                 </a:solidFill>
                 <a:latin typeface="Avenir Next"/>
                 <a:ea typeface="Avenir Next"/>
@@ -2470,7 +2470,7 @@
               <a:buNone/>
               <a:defRPr sz="1800">
                 <a:solidFill>
-                  <a:srgbClr val="6F746F"/>
+                  <a:srgbClr val="6D7974"/>
                 </a:solidFill>
                 <a:latin typeface="Avenir Next"/>
                 <a:ea typeface="Avenir Next"/>
@@ -2480,7 +2480,7 @@
             <a:r>
               <a:rPr sz="1800">
                 <a:solidFill>
-                  <a:srgbClr val="6F746F"/>
+                  <a:srgbClr val="6D7974"/>
                 </a:solidFill>
                 <a:latin typeface="Avenir Next"/>
                 <a:ea typeface="Avenir Next"/>
@@ -2560,7 +2560,7 @@
               <a:buNone/>
               <a:defRPr sz="1650" b="1">
                 <a:solidFill>
-                  <a:srgbClr val="6F746F"/>
+                  <a:srgbClr val="6D7974"/>
                 </a:solidFill>
                 <a:latin typeface="Menlo"/>
                 <a:ea typeface="Menlo"/>
@@ -2570,7 +2570,7 @@
             <a:r>
               <a:rPr sz="1650" b="1">
                 <a:solidFill>
-                  <a:srgbClr val="6F746F"/>
+                  <a:srgbClr val="6D7974"/>
                 </a:solidFill>
                 <a:latin typeface="Menlo"/>
                 <a:ea typeface="Menlo"/>
@@ -2619,7 +2619,7 @@
               <a:buNone/>
               <a:defRPr sz="2250" b="1">
                 <a:solidFill>
-                  <a:srgbClr val="17231F"/>
+                  <a:srgbClr val="0E4B3B"/>
                 </a:solidFill>
                 <a:latin typeface="Avenir Next"/>
                 <a:ea typeface="Avenir Next"/>
@@ -2629,7 +2629,7 @@
             <a:r>
               <a:rPr sz="2250" b="1">
                 <a:solidFill>
-                  <a:srgbClr val="17231F"/>
+                  <a:srgbClr val="0E4B3B"/>
                 </a:solidFill>
                 <a:latin typeface="Avenir Next"/>
                 <a:ea typeface="Avenir Next"/>
@@ -2681,7 +2681,7 @@
               <a:buNone/>
               <a:defRPr sz="1800">
                 <a:solidFill>
-                  <a:srgbClr val="6F746F"/>
+                  <a:srgbClr val="6D7974"/>
                 </a:solidFill>
                 <a:latin typeface="Avenir Next"/>
                 <a:ea typeface="Avenir Next"/>
@@ -2691,7 +2691,7 @@
             <a:r>
               <a:rPr sz="1800">
                 <a:solidFill>
-                  <a:srgbClr val="6F746F"/>
+                  <a:srgbClr val="6D7974"/>
                 </a:solidFill>
                 <a:latin typeface="Avenir Next"/>
                 <a:ea typeface="Avenir Next"/>
@@ -2740,7 +2740,7 @@
               <a:buNone/>
               <a:defRPr sz="1200" b="1">
                 <a:solidFill>
-                  <a:srgbClr val="6F746F"/>
+                  <a:srgbClr val="6D7974"/>
                 </a:solidFill>
                 <a:latin typeface="Menlo"/>
                 <a:ea typeface="Menlo"/>
@@ -2750,7 +2750,7 @@
             <a:r>
               <a:rPr sz="1200" b="1">
                 <a:solidFill>
-                  <a:srgbClr val="6F746F"/>
+                  <a:srgbClr val="6D7974"/>
                 </a:solidFill>
                 <a:latin typeface="Menlo"/>
                 <a:ea typeface="Menlo"/>
@@ -2799,7 +2799,7 @@
               <a:buNone/>
               <a:defRPr sz="1350" b="1">
                 <a:solidFill>
-                  <a:srgbClr val="6F746F"/>
+                  <a:srgbClr val="6D7974"/>
                 </a:solidFill>
                 <a:latin typeface="Menlo"/>
                 <a:ea typeface="Menlo"/>
@@ -2809,7 +2809,7 @@
             <a:r>
               <a:rPr sz="1350" b="1">
                 <a:solidFill>
-                  <a:srgbClr val="6F746F"/>
+                  <a:srgbClr val="6D7974"/>
                 </a:solidFill>
                 <a:latin typeface="Menlo"/>
                 <a:ea typeface="Menlo"/>
@@ -2836,7 +2836,7 @@
     <p:bg>
       <p:bgPr>
         <a:solidFill xmlns:a="http://schemas.openxmlformats.org/drawingml/2006/main">
-          <a:srgbClr val="17231F"/>
+          <a:srgbClr val="0E4B3B"/>
         </a:solidFill>
       </p:bgPr>
     </p:bg>
@@ -2887,7 +2887,7 @@
               <a:buNone/>
               <a:defRPr sz="1350" b="1">
                 <a:solidFill>
-                  <a:srgbClr val="FF6B45"/>
+                  <a:srgbClr val="B7F522"/>
                 </a:solidFill>
                 <a:latin typeface="Menlo"/>
                 <a:ea typeface="Menlo"/>
@@ -2897,7 +2897,7 @@
             <a:r>
               <a:rPr sz="1350" b="1">
                 <a:solidFill>
-                  <a:srgbClr val="FF6B45"/>
+                  <a:srgbClr val="B7F522"/>
                 </a:solidFill>
                 <a:latin typeface="Menlo"/>
                 <a:ea typeface="Menlo"/>
@@ -3077,7 +3077,7 @@
             <a:avLst/>
           </a:prstGeom>
           <a:solidFill xmlns:a="http://schemas.openxmlformats.org/drawingml/2006/main">
-            <a:srgbClr val="FF6B45"/>
+            <a:srgbClr val="B7F522"/>
           </a:solidFill>
           <a:ln xmlns:a="http://schemas.openxmlformats.org/drawingml/2006/main" w="0">
             <a:noFill/>
@@ -3123,7 +3123,7 @@
               <a:buNone/>
               <a:defRPr sz="1125" b="1">
                 <a:solidFill>
-                  <a:srgbClr val="A4B5AE"/>
+                  <a:srgbClr val="DCECE5"/>
                 </a:solidFill>
                 <a:latin typeface="Menlo"/>
                 <a:ea typeface="Menlo"/>
@@ -3133,7 +3133,7 @@
             <a:r>
               <a:rPr sz="1125" b="1">
                 <a:solidFill>
-                  <a:srgbClr val="A4B5AE"/>
+                  <a:srgbClr val="DCECE5"/>
                 </a:solidFill>
                 <a:latin typeface="Menlo"/>
                 <a:ea typeface="Menlo"/>
@@ -3241,7 +3241,7 @@
               <a:buNone/>
               <a:defRPr sz="1125" b="1">
                 <a:solidFill>
-                  <a:srgbClr val="A4B5AE"/>
+                  <a:srgbClr val="DCECE5"/>
                 </a:solidFill>
                 <a:latin typeface="Menlo"/>
                 <a:ea typeface="Menlo"/>
@@ -3251,7 +3251,7 @@
             <a:r>
               <a:rPr sz="1125" b="1">
                 <a:solidFill>
-                  <a:srgbClr val="A4B5AE"/>
+                  <a:srgbClr val="DCECE5"/>
                 </a:solidFill>
                 <a:latin typeface="Menlo"/>
                 <a:ea typeface="Menlo"/>
@@ -3359,7 +3359,7 @@
               <a:buNone/>
               <a:defRPr sz="1125" b="1">
                 <a:solidFill>
-                  <a:srgbClr val="A4B5AE"/>
+                  <a:srgbClr val="DCECE5"/>
                 </a:solidFill>
                 <a:latin typeface="Menlo"/>
                 <a:ea typeface="Menlo"/>
@@ -3369,7 +3369,7 @@
             <a:r>
               <a:rPr sz="1125" b="1">
                 <a:solidFill>
-                  <a:srgbClr val="A4B5AE"/>
+                  <a:srgbClr val="DCECE5"/>
                 </a:solidFill>
                 <a:latin typeface="Menlo"/>
                 <a:ea typeface="Menlo"/>
@@ -3477,7 +3477,7 @@
               <a:buNone/>
               <a:defRPr sz="1125" b="1">
                 <a:solidFill>
-                  <a:srgbClr val="A4B5AE"/>
+                  <a:srgbClr val="DCECE5"/>
                 </a:solidFill>
                 <a:latin typeface="Menlo"/>
                 <a:ea typeface="Menlo"/>
@@ -3487,7 +3487,7 @@
             <a:r>
               <a:rPr sz="1125" b="1">
                 <a:solidFill>
-                  <a:srgbClr val="A4B5AE"/>
+                  <a:srgbClr val="DCECE5"/>
                 </a:solidFill>
                 <a:latin typeface="Menlo"/>
                 <a:ea typeface="Menlo"/>
@@ -3595,7 +3595,7 @@
               <a:buNone/>
               <a:defRPr sz="2100" b="1">
                 <a:solidFill>
-                  <a:srgbClr val="FF6B45"/>
+                  <a:srgbClr val="B7F522"/>
                 </a:solidFill>
                 <a:latin typeface="Menlo"/>
                 <a:ea typeface="Menlo"/>
@@ -3605,7 +3605,7 @@
             <a:r>
               <a:rPr sz="2100" b="1">
                 <a:solidFill>
-                  <a:srgbClr val="FF6B45"/>
+                  <a:srgbClr val="B7F522"/>
                 </a:solidFill>
                 <a:latin typeface="Menlo"/>
                 <a:ea typeface="Menlo"/>
@@ -3654,7 +3654,7 @@
               <a:buNone/>
               <a:defRPr sz="1200" b="1">
                 <a:solidFill>
-                  <a:srgbClr val="A4B5AE"/>
+                  <a:srgbClr val="DCECE5"/>
                 </a:solidFill>
                 <a:latin typeface="Menlo"/>
                 <a:ea typeface="Menlo"/>
@@ -3664,7 +3664,7 @@
             <a:r>
               <a:rPr sz="1200" b="1">
                 <a:solidFill>
-                  <a:srgbClr val="A4B5AE"/>
+                  <a:srgbClr val="DCECE5"/>
                 </a:solidFill>
                 <a:latin typeface="Menlo"/>
                 <a:ea typeface="Menlo"/>
@@ -3713,7 +3713,7 @@
               <a:buNone/>
               <a:defRPr sz="1350" b="1">
                 <a:solidFill>
-                  <a:srgbClr val="A4B5AE"/>
+                  <a:srgbClr val="DCECE5"/>
                 </a:solidFill>
                 <a:latin typeface="Menlo"/>
                 <a:ea typeface="Menlo"/>
@@ -3723,7 +3723,7 @@
             <a:r>
               <a:rPr sz="1350" b="1">
                 <a:solidFill>
-                  <a:srgbClr val="A4B5AE"/>
+                  <a:srgbClr val="DCECE5"/>
                 </a:solidFill>
                 <a:latin typeface="Menlo"/>
                 <a:ea typeface="Menlo"/>
@@ -3750,7 +3750,7 @@
     <p:bg>
       <p:bgPr>
         <a:solidFill xmlns:a="http://schemas.openxmlformats.org/drawingml/2006/main">
-          <a:srgbClr val="F0EADF"/>
+          <a:srgbClr val="F4EEE4"/>
         </a:solidFill>
       </p:bgPr>
     </p:bg>
@@ -3801,7 +3801,7 @@
               <a:buNone/>
               <a:defRPr sz="1350" b="1">
                 <a:solidFill>
-                  <a:srgbClr val="6F746F"/>
+                  <a:srgbClr val="6D7974"/>
                 </a:solidFill>
                 <a:latin typeface="Menlo"/>
                 <a:ea typeface="Menlo"/>
@@ -3811,7 +3811,7 @@
             <a:r>
               <a:rPr sz="1350" b="1">
                 <a:solidFill>
-                  <a:srgbClr val="6F746F"/>
+                  <a:srgbClr val="6D7974"/>
                 </a:solidFill>
                 <a:latin typeface="Menlo"/>
                 <a:ea typeface="Menlo"/>
@@ -3863,7 +3863,7 @@
               <a:buNone/>
               <a:defRPr sz="4650" b="1">
                 <a:solidFill>
-                  <a:srgbClr val="17231F"/>
+                  <a:srgbClr val="0E4B3B"/>
                 </a:solidFill>
                 <a:latin typeface="Georgia"/>
                 <a:ea typeface="Georgia"/>
@@ -3873,7 +3873,7 @@
             <a:r>
               <a:rPr sz="4650" b="1">
                 <a:solidFill>
-                  <a:srgbClr val="17231F"/>
+                  <a:srgbClr val="0E4B3B"/>
                 </a:solidFill>
                 <a:latin typeface="Georgia"/>
                 <a:ea typeface="Georgia"/>
@@ -3922,7 +3922,7 @@
               <a:buNone/>
               <a:defRPr sz="4350" b="1">
                 <a:solidFill>
-                  <a:srgbClr val="17231F"/>
+                  <a:srgbClr val="0E4B3B"/>
                 </a:solidFill>
                 <a:latin typeface="Georgia"/>
                 <a:ea typeface="Georgia"/>
@@ -3932,7 +3932,7 @@
             <a:r>
               <a:rPr sz="4350" b="1">
                 <a:solidFill>
-                  <a:srgbClr val="17231F"/>
+                  <a:srgbClr val="0E4B3B"/>
                 </a:solidFill>
                 <a:latin typeface="Georgia"/>
                 <a:ea typeface="Georgia"/>
@@ -3981,7 +3981,7 @@
               <a:buNone/>
               <a:defRPr sz="1800">
                 <a:solidFill>
-                  <a:srgbClr val="6F746F"/>
+                  <a:srgbClr val="6D7974"/>
                 </a:solidFill>
                 <a:latin typeface="Avenir Next"/>
                 <a:ea typeface="Avenir Next"/>
@@ -3991,7 +3991,7 @@
             <a:r>
               <a:rPr sz="1800">
                 <a:solidFill>
-                  <a:srgbClr val="6F746F"/>
+                  <a:srgbClr val="6D7974"/>
                 </a:solidFill>
                 <a:latin typeface="Avenir Next"/>
                 <a:ea typeface="Avenir Next"/>
@@ -4040,7 +4040,7 @@
               <a:buNone/>
               <a:defRPr sz="4350" b="1">
                 <a:solidFill>
-                  <a:srgbClr val="17231F"/>
+                  <a:srgbClr val="0E4B3B"/>
                 </a:solidFill>
                 <a:latin typeface="Georgia"/>
                 <a:ea typeface="Georgia"/>
@@ -4050,7 +4050,7 @@
             <a:r>
               <a:rPr sz="4350" b="1">
                 <a:solidFill>
-                  <a:srgbClr val="17231F"/>
+                  <a:srgbClr val="0E4B3B"/>
                 </a:solidFill>
                 <a:latin typeface="Georgia"/>
                 <a:ea typeface="Georgia"/>
@@ -4099,7 +4099,7 @@
               <a:buNone/>
               <a:defRPr sz="1800">
                 <a:solidFill>
-                  <a:srgbClr val="6F746F"/>
+                  <a:srgbClr val="6D7974"/>
                 </a:solidFill>
                 <a:latin typeface="Avenir Next"/>
                 <a:ea typeface="Avenir Next"/>
@@ -4109,7 +4109,7 @@
             <a:r>
               <a:rPr sz="1800">
                 <a:solidFill>
-                  <a:srgbClr val="6F746F"/>
+                  <a:srgbClr val="6D7974"/>
                 </a:solidFill>
                 <a:latin typeface="Avenir Next"/>
                 <a:ea typeface="Avenir Next"/>
@@ -4217,7 +4217,7 @@
               <a:buNone/>
               <a:defRPr sz="1800">
                 <a:solidFill>
-                  <a:srgbClr val="6F746F"/>
+                  <a:srgbClr val="6D7974"/>
                 </a:solidFill>
                 <a:latin typeface="Avenir Next"/>
                 <a:ea typeface="Avenir Next"/>
@@ -4227,7 +4227,7 @@
             <a:r>
               <a:rPr sz="1800">
                 <a:solidFill>
-                  <a:srgbClr val="6F746F"/>
+                  <a:srgbClr val="6D7974"/>
                 </a:solidFill>
                 <a:latin typeface="Avenir Next"/>
                 <a:ea typeface="Avenir Next"/>
@@ -4286,7 +4286,7 @@
           <p:nvPr/>
         </p:nvPicPr>
         <p:blipFill>
-          <a:blip xmlns:r="http://schemas.openxmlformats.org/officeDocument/2006/relationships" xmlns:a="http://schemas.openxmlformats.org/drawingml/2006/main" r:embed="R6c44a7b0ae5b4b19"/>
+          <a:blip xmlns:r="http://schemas.openxmlformats.org/officeDocument/2006/relationships" xmlns:a="http://schemas.openxmlformats.org/drawingml/2006/main" r:embed="R3a3f835612ee409b"/>
           <a:stretch xmlns:a="http://schemas.openxmlformats.org/drawingml/2006/main"/>
         </p:blipFill>
         <p:spPr>
@@ -4337,7 +4337,7 @@
               <a:buNone/>
               <a:defRPr sz="1200" b="1">
                 <a:solidFill>
-                  <a:srgbClr val="6F746F"/>
+                  <a:srgbClr val="6D7974"/>
                 </a:solidFill>
                 <a:latin typeface="Menlo"/>
                 <a:ea typeface="Menlo"/>
@@ -4347,7 +4347,7 @@
             <a:r>
               <a:rPr sz="1200" b="1">
                 <a:solidFill>
-                  <a:srgbClr val="6F746F"/>
+                  <a:srgbClr val="6D7974"/>
                 </a:solidFill>
                 <a:latin typeface="Menlo"/>
                 <a:ea typeface="Menlo"/>
@@ -4396,7 +4396,7 @@
               <a:buNone/>
               <a:defRPr sz="1350" b="1">
                 <a:solidFill>
-                  <a:srgbClr val="6F746F"/>
+                  <a:srgbClr val="6D7974"/>
                 </a:solidFill>
                 <a:latin typeface="Menlo"/>
                 <a:ea typeface="Menlo"/>
@@ -4406,7 +4406,7 @@
             <a:r>
               <a:rPr sz="1350" b="1">
                 <a:solidFill>
-                  <a:srgbClr val="6F746F"/>
+                  <a:srgbClr val="6D7974"/>
                 </a:solidFill>
                 <a:latin typeface="Menlo"/>
                 <a:ea typeface="Menlo"/>
@@ -4448,7 +4448,7 @@
           <p:nvPr/>
         </p:nvPicPr>
         <p:blipFill>
-          <a:blip xmlns:r="http://schemas.openxmlformats.org/officeDocument/2006/relationships" xmlns:a="http://schemas.openxmlformats.org/drawingml/2006/main" r:embed="R237701425c0e481e"/>
+          <a:blip xmlns:r="http://schemas.openxmlformats.org/officeDocument/2006/relationships" xmlns:a="http://schemas.openxmlformats.org/drawingml/2006/main" r:embed="Raa545504ff6c40b8"/>
           <a:srcRect xmlns:a="http://schemas.openxmlformats.org/drawingml/2006/main" l="0" t="0" r="0" b="0"/>
           <a:stretch xmlns:a="http://schemas.openxmlformats.org/drawingml/2006/main">
             <a:fillRect l="0" t="0" r="0" b="0"/>
@@ -4480,7 +4480,7 @@
     <p:bg>
       <p:bgPr>
         <a:solidFill xmlns:a="http://schemas.openxmlformats.org/drawingml/2006/main">
-          <a:srgbClr val="F0EADF"/>
+          <a:srgbClr val="F4EEE4"/>
         </a:solidFill>
       </p:bgPr>
     </p:bg>
@@ -4531,7 +4531,7 @@
               <a:buNone/>
               <a:defRPr sz="1350" b="1">
                 <a:solidFill>
-                  <a:srgbClr val="6F746F"/>
+                  <a:srgbClr val="6D7974"/>
                 </a:solidFill>
                 <a:latin typeface="Menlo"/>
                 <a:ea typeface="Menlo"/>
@@ -4541,7 +4541,7 @@
             <a:r>
               <a:rPr sz="1350" b="1">
                 <a:solidFill>
-                  <a:srgbClr val="6F746F"/>
+                  <a:srgbClr val="6D7974"/>
                 </a:solidFill>
                 <a:latin typeface="Menlo"/>
                 <a:ea typeface="Menlo"/>
@@ -4593,7 +4593,7 @@
               <a:buNone/>
               <a:defRPr sz="4650" b="1">
                 <a:solidFill>
-                  <a:srgbClr val="17231F"/>
+                  <a:srgbClr val="0E4B3B"/>
                 </a:solidFill>
                 <a:latin typeface="Georgia"/>
                 <a:ea typeface="Georgia"/>
@@ -4603,7 +4603,7 @@
             <a:r>
               <a:rPr sz="4650" b="1">
                 <a:solidFill>
-                  <a:srgbClr val="17231F"/>
+                  <a:srgbClr val="0E4B3B"/>
                 </a:solidFill>
                 <a:latin typeface="Georgia"/>
                 <a:ea typeface="Georgia"/>
@@ -4655,7 +4655,7 @@
               <a:buNone/>
               <a:defRPr sz="3150" b="1">
                 <a:solidFill>
-                  <a:srgbClr val="17231F"/>
+                  <a:srgbClr val="0E4B3B"/>
                 </a:solidFill>
                 <a:latin typeface="Georgia"/>
                 <a:ea typeface="Georgia"/>
@@ -4665,7 +4665,7 @@
             <a:r>
               <a:rPr sz="3150" b="1">
                 <a:solidFill>
-                  <a:srgbClr val="17231F"/>
+                  <a:srgbClr val="0E4B3B"/>
                 </a:solidFill>
                 <a:latin typeface="Georgia"/>
                 <a:ea typeface="Georgia"/>
@@ -4682,7 +4682,7 @@
               <a:buNone/>
               <a:defRPr sz="3150" b="1">
                 <a:solidFill>
-                  <a:srgbClr val="17231F"/>
+                  <a:srgbClr val="0E4B3B"/>
                 </a:solidFill>
                 <a:latin typeface="Georgia"/>
                 <a:ea typeface="Georgia"/>
@@ -4692,7 +4692,7 @@
             <a:r>
               <a:rPr sz="3150" b="1">
                 <a:solidFill>
-                  <a:srgbClr val="17231F"/>
+                  <a:srgbClr val="0E4B3B"/>
                 </a:solidFill>
                 <a:latin typeface="Georgia"/>
                 <a:ea typeface="Georgia"/>
@@ -4728,7 +4728,7 @@
             </a:avLst>
           </a:prstGeom>
           <a:solidFill xmlns:a="http://schemas.openxmlformats.org/drawingml/2006/main">
-            <a:srgbClr val="1434CB"/>
+            <a:srgbClr val="1545E8"/>
           </a:solidFill>
           <a:ln xmlns:a="http://schemas.openxmlformats.org/drawingml/2006/main" w="0">
             <a:noFill/>
@@ -4836,7 +4836,7 @@
               <a:buNone/>
               <a:defRPr sz="1800">
                 <a:solidFill>
-                  <a:srgbClr val="6F746F"/>
+                  <a:srgbClr val="6D7974"/>
                 </a:solidFill>
                 <a:latin typeface="Avenir Next"/>
                 <a:ea typeface="Avenir Next"/>
@@ -4846,7 +4846,7 @@
             <a:r>
               <a:rPr sz="1800">
                 <a:solidFill>
-                  <a:srgbClr val="6F746F"/>
+                  <a:srgbClr val="6D7974"/>
                 </a:solidFill>
                 <a:latin typeface="Avenir Next"/>
                 <a:ea typeface="Avenir Next"/>
@@ -4905,7 +4905,7 @@
           <p:nvPr/>
         </p:nvPicPr>
         <p:blipFill>
-          <a:blip xmlns:r="http://schemas.openxmlformats.org/officeDocument/2006/relationships" xmlns:a="http://schemas.openxmlformats.org/drawingml/2006/main" r:embed="R7f0414c3ab474154"/>
+          <a:blip xmlns:r="http://schemas.openxmlformats.org/officeDocument/2006/relationships" xmlns:a="http://schemas.openxmlformats.org/drawingml/2006/main" r:embed="R13b74459dc7b44eb"/>
           <a:stretch xmlns:a="http://schemas.openxmlformats.org/drawingml/2006/main"/>
         </p:blipFill>
         <p:spPr>
@@ -4956,7 +4956,7 @@
               <a:buNone/>
               <a:defRPr sz="1200" b="1">
                 <a:solidFill>
-                  <a:srgbClr val="6F746F"/>
+                  <a:srgbClr val="6D7974"/>
                 </a:solidFill>
                 <a:latin typeface="Menlo"/>
                 <a:ea typeface="Menlo"/>
@@ -4966,7 +4966,7 @@
             <a:r>
               <a:rPr sz="1200" b="1">
                 <a:solidFill>
-                  <a:srgbClr val="6F746F"/>
+                  <a:srgbClr val="6D7974"/>
                 </a:solidFill>
                 <a:latin typeface="Menlo"/>
                 <a:ea typeface="Menlo"/>
@@ -5015,7 +5015,7 @@
               <a:buNone/>
               <a:defRPr sz="1350" b="1">
                 <a:solidFill>
-                  <a:srgbClr val="6F746F"/>
+                  <a:srgbClr val="6D7974"/>
                 </a:solidFill>
                 <a:latin typeface="Menlo"/>
                 <a:ea typeface="Menlo"/>
@@ -5025,7 +5025,7 @@
             <a:r>
               <a:rPr sz="1350" b="1">
                 <a:solidFill>
-                  <a:srgbClr val="6F746F"/>
+                  <a:srgbClr val="6D7974"/>
                 </a:solidFill>
                 <a:latin typeface="Menlo"/>
                 <a:ea typeface="Menlo"/>
@@ -5052,7 +5052,7 @@
     <p:bg>
       <p:bgPr>
         <a:solidFill xmlns:a="http://schemas.openxmlformats.org/drawingml/2006/main">
-          <a:srgbClr val="17231F"/>
+          <a:srgbClr val="0E4B3B"/>
         </a:solidFill>
       </p:bgPr>
     </p:bg>
@@ -5103,7 +5103,7 @@
               <a:buNone/>
               <a:defRPr sz="1350" b="1">
                 <a:solidFill>
-                  <a:srgbClr val="FF6B45"/>
+                  <a:srgbClr val="B7F522"/>
                 </a:solidFill>
                 <a:latin typeface="Menlo"/>
                 <a:ea typeface="Menlo"/>
@@ -5113,7 +5113,7 @@
             <a:r>
               <a:rPr sz="1350" b="1">
                 <a:solidFill>
-                  <a:srgbClr val="FF6B45"/>
+                  <a:srgbClr val="B7F522"/>
                 </a:solidFill>
                 <a:latin typeface="Menlo"/>
                 <a:ea typeface="Menlo"/>
@@ -5224,7 +5224,7 @@
               <a:buNone/>
               <a:defRPr sz="1125" b="1">
                 <a:solidFill>
-                  <a:srgbClr val="FF6B45"/>
+                  <a:srgbClr val="B7F522"/>
                 </a:solidFill>
                 <a:latin typeface="Menlo"/>
                 <a:ea typeface="Menlo"/>
@@ -5234,7 +5234,7 @@
             <a:r>
               <a:rPr sz="1125" b="1">
                 <a:solidFill>
-                  <a:srgbClr val="FF6B45"/>
+                  <a:srgbClr val="B7F522"/>
                 </a:solidFill>
                 <a:latin typeface="Menlo"/>
                 <a:ea typeface="Menlo"/>
@@ -5342,7 +5342,7 @@
               <a:buNone/>
               <a:defRPr sz="1125" b="1">
                 <a:solidFill>
-                  <a:srgbClr val="FF6B45"/>
+                  <a:srgbClr val="B7F522"/>
                 </a:solidFill>
                 <a:latin typeface="Menlo"/>
                 <a:ea typeface="Menlo"/>
@@ -5352,7 +5352,7 @@
             <a:r>
               <a:rPr sz="1125" b="1">
                 <a:solidFill>
-                  <a:srgbClr val="FF6B45"/>
+                  <a:srgbClr val="B7F522"/>
                 </a:solidFill>
                 <a:latin typeface="Menlo"/>
                 <a:ea typeface="Menlo"/>
@@ -5460,7 +5460,7 @@
               <a:buNone/>
               <a:defRPr sz="1125" b="1">
                 <a:solidFill>
-                  <a:srgbClr val="FF6B45"/>
+                  <a:srgbClr val="B7F522"/>
                 </a:solidFill>
                 <a:latin typeface="Menlo"/>
                 <a:ea typeface="Menlo"/>
@@ -5470,7 +5470,7 @@
             <a:r>
               <a:rPr sz="1125" b="1">
                 <a:solidFill>
-                  <a:srgbClr val="FF6B45"/>
+                  <a:srgbClr val="B7F522"/>
                 </a:solidFill>
                 <a:latin typeface="Menlo"/>
                 <a:ea typeface="Menlo"/>
@@ -5578,7 +5578,7 @@
               <a:buNone/>
               <a:defRPr sz="1125" b="1">
                 <a:solidFill>
-                  <a:srgbClr val="FF6B45"/>
+                  <a:srgbClr val="B7F522"/>
                 </a:solidFill>
                 <a:latin typeface="Menlo"/>
                 <a:ea typeface="Menlo"/>
@@ -5588,7 +5588,7 @@
             <a:r>
               <a:rPr sz="1125" b="1">
                 <a:solidFill>
-                  <a:srgbClr val="FF6B45"/>
+                  <a:srgbClr val="B7F522"/>
                 </a:solidFill>
                 <a:latin typeface="Menlo"/>
                 <a:ea typeface="Menlo"/>
@@ -5706,7 +5706,7 @@
           <p:nvPr/>
         </p:nvPicPr>
         <p:blipFill>
-          <a:blip xmlns:r="http://schemas.openxmlformats.org/officeDocument/2006/relationships" xmlns:a="http://schemas.openxmlformats.org/drawingml/2006/main" r:embed="R0dc64458363143f5"/>
+          <a:blip xmlns:r="http://schemas.openxmlformats.org/officeDocument/2006/relationships" xmlns:a="http://schemas.openxmlformats.org/drawingml/2006/main" r:embed="R2fa4a6fe333c46ff"/>
           <a:stretch xmlns:a="http://schemas.openxmlformats.org/drawingml/2006/main"/>
         </p:blipFill>
         <p:spPr>
@@ -5760,7 +5760,7 @@
               <a:buNone/>
               <a:defRPr sz="1050" b="1">
                 <a:solidFill>
-                  <a:srgbClr val="A4B5AE"/>
+                  <a:srgbClr val="DCECE5"/>
                 </a:solidFill>
                 <a:latin typeface="Menlo"/>
                 <a:ea typeface="Menlo"/>
@@ -5770,7 +5770,7 @@
             <a:r>
               <a:rPr sz="1050" b="1">
                 <a:solidFill>
-                  <a:srgbClr val="A4B5AE"/>
+                  <a:srgbClr val="DCECE5"/>
                 </a:solidFill>
                 <a:latin typeface="Menlo"/>
                 <a:ea typeface="Menlo"/>
@@ -5787,7 +5787,7 @@
               <a:buNone/>
               <a:defRPr sz="1050" b="1">
                 <a:solidFill>
-                  <a:srgbClr val="A4B5AE"/>
+                  <a:srgbClr val="DCECE5"/>
                 </a:solidFill>
                 <a:latin typeface="Menlo"/>
                 <a:ea typeface="Menlo"/>
@@ -5797,7 +5797,7 @@
             <a:r>
               <a:rPr sz="1050" b="1">
                 <a:solidFill>
-                  <a:srgbClr val="A4B5AE"/>
+                  <a:srgbClr val="DCECE5"/>
                 </a:solidFill>
                 <a:latin typeface="Menlo"/>
                 <a:ea typeface="Menlo"/>
@@ -5846,7 +5846,7 @@
               <a:buNone/>
               <a:defRPr sz="1200" b="1">
                 <a:solidFill>
-                  <a:srgbClr val="A4B5AE"/>
+                  <a:srgbClr val="DCECE5"/>
                 </a:solidFill>
                 <a:latin typeface="Menlo"/>
                 <a:ea typeface="Menlo"/>
@@ -5856,7 +5856,7 @@
             <a:r>
               <a:rPr sz="1200" b="1">
                 <a:solidFill>
-                  <a:srgbClr val="A4B5AE"/>
+                  <a:srgbClr val="DCECE5"/>
                 </a:solidFill>
                 <a:latin typeface="Menlo"/>
                 <a:ea typeface="Menlo"/>
@@ -5905,7 +5905,7 @@
               <a:buNone/>
               <a:defRPr sz="1350" b="1">
                 <a:solidFill>
-                  <a:srgbClr val="A4B5AE"/>
+                  <a:srgbClr val="DCECE5"/>
                 </a:solidFill>
                 <a:latin typeface="Menlo"/>
                 <a:ea typeface="Menlo"/>
@@ -5915,7 +5915,7 @@
             <a:r>
               <a:rPr sz="1350" b="1">
                 <a:solidFill>
-                  <a:srgbClr val="A4B5AE"/>
+                  <a:srgbClr val="DCECE5"/>
                 </a:solidFill>
                 <a:latin typeface="Menlo"/>
                 <a:ea typeface="Menlo"/>
@@ -5942,7 +5942,7 @@
     <p:bg>
       <p:bgPr>
         <a:solidFill xmlns:a="http://schemas.openxmlformats.org/drawingml/2006/main">
-          <a:srgbClr val="F0EADF"/>
+          <a:srgbClr val="F4EEE4"/>
         </a:solidFill>
       </p:bgPr>
     </p:bg>
@@ -5993,7 +5993,7 @@
               <a:buNone/>
               <a:defRPr sz="1350" b="1">
                 <a:solidFill>
-                  <a:srgbClr val="6F746F"/>
+                  <a:srgbClr val="6D7974"/>
                 </a:solidFill>
                 <a:latin typeface="Menlo"/>
                 <a:ea typeface="Menlo"/>
@@ -6003,7 +6003,7 @@
             <a:r>
               <a:rPr sz="1350" b="1">
                 <a:solidFill>
-                  <a:srgbClr val="6F746F"/>
+                  <a:srgbClr val="6D7974"/>
                 </a:solidFill>
                 <a:latin typeface="Menlo"/>
                 <a:ea typeface="Menlo"/>
@@ -6055,7 +6055,7 @@
               <a:buNone/>
               <a:defRPr sz="4650" b="1">
                 <a:solidFill>
-                  <a:srgbClr val="17231F"/>
+                  <a:srgbClr val="0E4B3B"/>
                 </a:solidFill>
                 <a:latin typeface="Georgia"/>
                 <a:ea typeface="Georgia"/>
@@ -6065,7 +6065,7 @@
             <a:r>
               <a:rPr sz="4650" b="1">
                 <a:solidFill>
-                  <a:srgbClr val="17231F"/>
+                  <a:srgbClr val="0E4B3B"/>
                 </a:solidFill>
                 <a:latin typeface="Georgia"/>
                 <a:ea typeface="Georgia"/>
@@ -6114,7 +6114,7 @@
               <a:buNone/>
               <a:defRPr sz="1800" b="1">
                 <a:solidFill>
-                  <a:srgbClr val="6F746F"/>
+                  <a:srgbClr val="6D7974"/>
                 </a:solidFill>
                 <a:latin typeface="Menlo"/>
                 <a:ea typeface="Menlo"/>
@@ -6124,7 +6124,7 @@
             <a:r>
               <a:rPr sz="1800" b="1">
                 <a:solidFill>
-                  <a:srgbClr val="6F746F"/>
+                  <a:srgbClr val="6D7974"/>
                 </a:solidFill>
                 <a:latin typeface="Menlo"/>
                 <a:ea typeface="Menlo"/>
@@ -6160,7 +6160,7 @@
           <a:noFill xmlns:a="http://schemas.openxmlformats.org/drawingml/2006/main"/>
           <a:ln xmlns:a="http://schemas.openxmlformats.org/drawingml/2006/main" w="57150">
             <a:solidFill>
-              <a:srgbClr val="FF6B45"/>
+              <a:srgbClr val="B7F522"/>
             </a:solidFill>
             <a:prstDash val="solid"/>
           </a:ln>
@@ -6207,7 +6207,7 @@
               <a:buNone/>
               <a:defRPr sz="2550" b="1">
                 <a:solidFill>
-                  <a:srgbClr val="17231F"/>
+                  <a:srgbClr val="0E4B3B"/>
                 </a:solidFill>
                 <a:latin typeface="Georgia"/>
                 <a:ea typeface="Georgia"/>
@@ -6217,7 +6217,7 @@
             <a:r>
               <a:rPr sz="2550" b="1">
                 <a:solidFill>
-                  <a:srgbClr val="17231F"/>
+                  <a:srgbClr val="0E4B3B"/>
                 </a:solidFill>
                 <a:latin typeface="Georgia"/>
                 <a:ea typeface="Georgia"/>
@@ -6269,7 +6269,7 @@
               <a:buNone/>
               <a:defRPr sz="1800">
                 <a:solidFill>
-                  <a:srgbClr val="6F746F"/>
+                  <a:srgbClr val="6D7974"/>
                 </a:solidFill>
                 <a:latin typeface="Avenir Next"/>
                 <a:ea typeface="Avenir Next"/>
@@ -6279,7 +6279,7 @@
             <a:r>
               <a:rPr sz="1800">
                 <a:solidFill>
-                  <a:srgbClr val="6F746F"/>
+                  <a:srgbClr val="6D7974"/>
                 </a:solidFill>
                 <a:latin typeface="Avenir Next"/>
                 <a:ea typeface="Avenir Next"/>
@@ -6328,7 +6328,7 @@
               <a:buNone/>
               <a:defRPr sz="1800" b="1">
                 <a:solidFill>
-                  <a:srgbClr val="6F746F"/>
+                  <a:srgbClr val="6D7974"/>
                 </a:solidFill>
                 <a:latin typeface="Menlo"/>
                 <a:ea typeface="Menlo"/>
@@ -6338,7 +6338,7 @@
             <a:r>
               <a:rPr sz="1800" b="1">
                 <a:solidFill>
-                  <a:srgbClr val="6F746F"/>
+                  <a:srgbClr val="6D7974"/>
                 </a:solidFill>
                 <a:latin typeface="Menlo"/>
                 <a:ea typeface="Menlo"/>
@@ -6421,7 +6421,7 @@
               <a:buNone/>
               <a:defRPr sz="2550" b="1">
                 <a:solidFill>
-                  <a:srgbClr val="17231F"/>
+                  <a:srgbClr val="0E4B3B"/>
                 </a:solidFill>
                 <a:latin typeface="Georgia"/>
                 <a:ea typeface="Georgia"/>
@@ -6431,7 +6431,7 @@
             <a:r>
               <a:rPr sz="2550" b="1">
                 <a:solidFill>
-                  <a:srgbClr val="17231F"/>
+                  <a:srgbClr val="0E4B3B"/>
                 </a:solidFill>
                 <a:latin typeface="Georgia"/>
                 <a:ea typeface="Georgia"/>
@@ -6483,7 +6483,7 @@
               <a:buNone/>
               <a:defRPr sz="1800">
                 <a:solidFill>
-                  <a:srgbClr val="6F746F"/>
+                  <a:srgbClr val="6D7974"/>
                 </a:solidFill>
                 <a:latin typeface="Avenir Next"/>
                 <a:ea typeface="Avenir Next"/>
@@ -6493,7 +6493,7 @@
             <a:r>
               <a:rPr sz="1800">
                 <a:solidFill>
-                  <a:srgbClr val="6F746F"/>
+                  <a:srgbClr val="6D7974"/>
                 </a:solidFill>
                 <a:latin typeface="Avenir Next"/>
                 <a:ea typeface="Avenir Next"/>
@@ -6542,7 +6542,7 @@
               <a:buNone/>
               <a:defRPr sz="1800" b="1">
                 <a:solidFill>
-                  <a:srgbClr val="FF6B45"/>
+                  <a:srgbClr val="B7F522"/>
                 </a:solidFill>
                 <a:latin typeface="Menlo"/>
                 <a:ea typeface="Menlo"/>
@@ -6552,7 +6552,7 @@
             <a:r>
               <a:rPr sz="1800" b="1">
                 <a:solidFill>
-                  <a:srgbClr val="FF6B45"/>
+                  <a:srgbClr val="B7F522"/>
                 </a:solidFill>
                 <a:latin typeface="Menlo"/>
                 <a:ea typeface="Menlo"/>
@@ -6635,7 +6635,7 @@
               <a:buNone/>
               <a:defRPr sz="2550" b="1">
                 <a:solidFill>
-                  <a:srgbClr val="17231F"/>
+                  <a:srgbClr val="0E4B3B"/>
                 </a:solidFill>
                 <a:latin typeface="Georgia"/>
                 <a:ea typeface="Georgia"/>
@@ -6645,7 +6645,7 @@
             <a:r>
               <a:rPr sz="2550" b="1">
                 <a:solidFill>
-                  <a:srgbClr val="17231F"/>
+                  <a:srgbClr val="0E4B3B"/>
                 </a:solidFill>
                 <a:latin typeface="Georgia"/>
                 <a:ea typeface="Georgia"/>
@@ -6697,7 +6697,7 @@
               <a:buNone/>
               <a:defRPr sz="1800">
                 <a:solidFill>
-                  <a:srgbClr val="6F746F"/>
+                  <a:srgbClr val="6D7974"/>
                 </a:solidFill>
                 <a:latin typeface="Avenir Next"/>
                 <a:ea typeface="Avenir Next"/>
@@ -6707,7 +6707,7 @@
             <a:r>
               <a:rPr sz="1800">
                 <a:solidFill>
-                  <a:srgbClr val="6F746F"/>
+                  <a:srgbClr val="6D7974"/>
                 </a:solidFill>
                 <a:latin typeface="Avenir Next"/>
                 <a:ea typeface="Avenir Next"/>
@@ -6789,7 +6789,7 @@
               <a:buNone/>
               <a:defRPr sz="1950" b="1">
                 <a:solidFill>
-                  <a:srgbClr val="17231F"/>
+                  <a:srgbClr val="0E4B3B"/>
                 </a:solidFill>
                 <a:latin typeface="Avenir Next"/>
                 <a:ea typeface="Avenir Next"/>
@@ -6799,7 +6799,7 @@
             <a:r>
               <a:rPr sz="1950" b="1">
                 <a:solidFill>
-                  <a:srgbClr val="17231F"/>
+                  <a:srgbClr val="0E4B3B"/>
                 </a:solidFill>
                 <a:latin typeface="Avenir Next"/>
                 <a:ea typeface="Avenir Next"/>
@@ -6848,7 +6848,7 @@
               <a:buNone/>
               <a:defRPr sz="1200" b="1">
                 <a:solidFill>
-                  <a:srgbClr val="6F746F"/>
+                  <a:srgbClr val="6D7974"/>
                 </a:solidFill>
                 <a:latin typeface="Menlo"/>
                 <a:ea typeface="Menlo"/>
@@ -6858,7 +6858,7 @@
             <a:r>
               <a:rPr sz="1200" b="1">
                 <a:solidFill>
-                  <a:srgbClr val="6F746F"/>
+                  <a:srgbClr val="6D7974"/>
                 </a:solidFill>
                 <a:latin typeface="Menlo"/>
                 <a:ea typeface="Menlo"/>
@@ -6907,7 +6907,7 @@
               <a:buNone/>
               <a:defRPr sz="1350" b="1">
                 <a:solidFill>
-                  <a:srgbClr val="6F746F"/>
+                  <a:srgbClr val="6D7974"/>
                 </a:solidFill>
                 <a:latin typeface="Menlo"/>
                 <a:ea typeface="Menlo"/>
@@ -6917,7 +6917,7 @@
             <a:r>
               <a:rPr sz="1350" b="1">
                 <a:solidFill>
-                  <a:srgbClr val="6F746F"/>
+                  <a:srgbClr val="6D7974"/>
                 </a:solidFill>
                 <a:latin typeface="Menlo"/>
                 <a:ea typeface="Menlo"/>
@@ -6944,7 +6944,7 @@
     <p:bg>
       <p:bgPr>
         <a:solidFill xmlns:a="http://schemas.openxmlformats.org/drawingml/2006/main">
-          <a:srgbClr val="17231F"/>
+          <a:srgbClr val="0E4B3B"/>
         </a:solidFill>
       </p:bgPr>
     </p:bg>
@@ -6995,7 +6995,7 @@
               <a:buNone/>
               <a:defRPr sz="1350" b="1">
                 <a:solidFill>
-                  <a:srgbClr val="FF6B45"/>
+                  <a:srgbClr val="B7F522"/>
                 </a:solidFill>
                 <a:latin typeface="Menlo"/>
                 <a:ea typeface="Menlo"/>
@@ -7005,7 +7005,7 @@
             <a:r>
               <a:rPr sz="1350" b="1">
                 <a:solidFill>
-                  <a:srgbClr val="FF6B45"/>
+                  <a:srgbClr val="B7F522"/>
                 </a:solidFill>
                 <a:latin typeface="Menlo"/>
                 <a:ea typeface="Menlo"/>
@@ -7173,7 +7173,7 @@
               <a:buNone/>
               <a:defRPr sz="2100" b="1">
                 <a:solidFill>
-                  <a:srgbClr val="FF6B45"/>
+                  <a:srgbClr val="B7F522"/>
                 </a:solidFill>
                 <a:latin typeface="Avenir Next"/>
                 <a:ea typeface="Avenir Next"/>
@@ -7183,7 +7183,7 @@
             <a:r>
               <a:rPr sz="2100" b="1">
                 <a:solidFill>
-                  <a:srgbClr val="FF6B45"/>
+                  <a:srgbClr val="B7F522"/>
                 </a:solidFill>
                 <a:latin typeface="Avenir Next"/>
                 <a:ea typeface="Avenir Next"/>
@@ -7235,7 +7235,7 @@
               <a:buNone/>
               <a:defRPr sz="2025" b="1">
                 <a:solidFill>
-                  <a:srgbClr val="D8D0C4"/>
+                  <a:srgbClr val="DCECE5"/>
                 </a:solidFill>
                 <a:latin typeface="Menlo"/>
                 <a:ea typeface="Menlo"/>
@@ -7245,7 +7245,7 @@
             <a:r>
               <a:rPr sz="2025" b="1">
                 <a:solidFill>
-                  <a:srgbClr val="D8D0C4"/>
+                  <a:srgbClr val="DCECE5"/>
                 </a:solidFill>
                 <a:latin typeface="Menlo"/>
                 <a:ea typeface="Menlo"/>
@@ -7262,7 +7262,7 @@
               <a:buNone/>
               <a:defRPr sz="2025" b="1">
                 <a:solidFill>
-                  <a:srgbClr val="D8D0C4"/>
+                  <a:srgbClr val="DCECE5"/>
                 </a:solidFill>
                 <a:latin typeface="Menlo"/>
                 <a:ea typeface="Menlo"/>
@@ -7272,7 +7272,7 @@
             <a:r>
               <a:rPr sz="2025" b="1">
                 <a:solidFill>
-                  <a:srgbClr val="D8D0C4"/>
+                  <a:srgbClr val="DCECE5"/>
                 </a:solidFill>
                 <a:latin typeface="Menlo"/>
                 <a:ea typeface="Menlo"/>
@@ -7289,7 +7289,7 @@
               <a:buNone/>
               <a:defRPr sz="2025" b="1">
                 <a:solidFill>
-                  <a:srgbClr val="D8D0C4"/>
+                  <a:srgbClr val="DCECE5"/>
                 </a:solidFill>
                 <a:latin typeface="Menlo"/>
                 <a:ea typeface="Menlo"/>
@@ -7299,7 +7299,7 @@
             <a:r>
               <a:rPr sz="2025" b="1">
                 <a:solidFill>
-                  <a:srgbClr val="D8D0C4"/>
+                  <a:srgbClr val="DCECE5"/>
                 </a:solidFill>
                 <a:latin typeface="Menlo"/>
                 <a:ea typeface="Menlo"/>
@@ -7358,7 +7358,7 @@
           <p:nvPr/>
         </p:nvPicPr>
         <p:blipFill>
-          <a:blip xmlns:r="http://schemas.openxmlformats.org/officeDocument/2006/relationships" xmlns:a="http://schemas.openxmlformats.org/drawingml/2006/main" r:embed="Rc064fc1f5f3c430c"/>
+          <a:blip xmlns:r="http://schemas.openxmlformats.org/officeDocument/2006/relationships" xmlns:a="http://schemas.openxmlformats.org/drawingml/2006/main" r:embed="Rc63ab80ad15a43e0"/>
           <a:stretch xmlns:a="http://schemas.openxmlformats.org/drawingml/2006/main"/>
         </p:blipFill>
         <p:spPr>
@@ -7409,7 +7409,7 @@
               <a:buNone/>
               <a:defRPr sz="1200" b="1">
                 <a:solidFill>
-                  <a:srgbClr val="FF6B45"/>
+                  <a:srgbClr val="B7F522"/>
                 </a:solidFill>
                 <a:latin typeface="Menlo"/>
                 <a:ea typeface="Menlo"/>
@@ -7419,7 +7419,7 @@
             <a:r>
               <a:rPr sz="1200" b="1">
                 <a:solidFill>
-                  <a:srgbClr val="FF6B45"/>
+                  <a:srgbClr val="B7F522"/>
                 </a:solidFill>
                 <a:latin typeface="Menlo"/>
                 <a:ea typeface="Menlo"/>
@@ -7468,7 +7468,7 @@
               <a:buNone/>
               <a:defRPr sz="1200" b="1">
                 <a:solidFill>
-                  <a:srgbClr val="A4B5AE"/>
+                  <a:srgbClr val="DCECE5"/>
                 </a:solidFill>
                 <a:latin typeface="Menlo"/>
                 <a:ea typeface="Menlo"/>
@@ -7478,7 +7478,7 @@
             <a:r>
               <a:rPr sz="1200" b="1">
                 <a:solidFill>
-                  <a:srgbClr val="A4B5AE"/>
+                  <a:srgbClr val="DCECE5"/>
                 </a:solidFill>
                 <a:latin typeface="Menlo"/>
                 <a:ea typeface="Menlo"/>
@@ -7527,7 +7527,7 @@
               <a:buNone/>
               <a:defRPr sz="1350" b="1">
                 <a:solidFill>
-                  <a:srgbClr val="A4B5AE"/>
+                  <a:srgbClr val="DCECE5"/>
                 </a:solidFill>
                 <a:latin typeface="Menlo"/>
                 <a:ea typeface="Menlo"/>
@@ -7537,7 +7537,7 @@
             <a:r>
               <a:rPr sz="1350" b="1">
                 <a:solidFill>
-                  <a:srgbClr val="A4B5AE"/>
+                  <a:srgbClr val="DCECE5"/>
                 </a:solidFill>
                 <a:latin typeface="Menlo"/>
                 <a:ea typeface="Menlo"/>

</xml_diff>

<commit_message>
docs(style): polish Woven pitch screenshots
Refresh the final judge deck with the latest buyer and merchant product captures while preserving the verified eleven-slide narrative and planned-identity labeling.
</commit_message>
<xml_diff>
--- a/docs/Woven-Hackathon-Pitch.pptx
+++ b/docs/Woven-Hackathon-Pitch.pptx
@@ -2,23 +2,23 @@
 <file path=ppt/presentation.xml><?xml version="1.0" encoding="utf-8"?>
 <p:presentation xmlns:p="http://schemas.openxmlformats.org/presentationml/2006/main">
   <p:sldMasterIdLst>
-    <p:sldMasterId xmlns:r="http://schemas.openxmlformats.org/officeDocument/2006/relationships" id="2147483648" r:id="Rfdd70b2d0eb640ea"/>
+    <p:sldMasterId xmlns:r="http://schemas.openxmlformats.org/officeDocument/2006/relationships" id="2147483648" r:id="R68a0510b5c074beb"/>
   </p:sldMasterIdLst>
   <p:notesMasterIdLst>
-    <p:notesMasterId xmlns:r="http://schemas.openxmlformats.org/officeDocument/2006/relationships" r:id="Rd94d24f1179f4038"/>
+    <p:notesMasterId xmlns:r="http://schemas.openxmlformats.org/officeDocument/2006/relationships" r:id="Rf9928dd6c9a04bd2"/>
   </p:notesMasterIdLst>
   <p:sldIdLst>
-    <p:sldId xmlns:r="http://schemas.openxmlformats.org/officeDocument/2006/relationships" id="256" r:id="R2bfccfe80b304a7c"/>
-    <p:sldId xmlns:r="http://schemas.openxmlformats.org/officeDocument/2006/relationships" id="257" r:id="R178dfa31bb7d4269"/>
-    <p:sldId xmlns:r="http://schemas.openxmlformats.org/officeDocument/2006/relationships" id="258" r:id="R56812137f54c4342"/>
-    <p:sldId xmlns:r="http://schemas.openxmlformats.org/officeDocument/2006/relationships" id="259" r:id="Rcce94e1e0fab4348"/>
-    <p:sldId xmlns:r="http://schemas.openxmlformats.org/officeDocument/2006/relationships" id="260" r:id="Rb77869934b2b4de1"/>
-    <p:sldId xmlns:r="http://schemas.openxmlformats.org/officeDocument/2006/relationships" id="261" r:id="R6ae9a51c77174f8f"/>
-    <p:sldId xmlns:r="http://schemas.openxmlformats.org/officeDocument/2006/relationships" id="262" r:id="R3f718b01b8784c59"/>
-    <p:sldId xmlns:r="http://schemas.openxmlformats.org/officeDocument/2006/relationships" id="263" r:id="R7ae926f952e241a5"/>
-    <p:sldId xmlns:r="http://schemas.openxmlformats.org/officeDocument/2006/relationships" id="264" r:id="Rb1696b5a38e04c10"/>
-    <p:sldId xmlns:r="http://schemas.openxmlformats.org/officeDocument/2006/relationships" id="265" r:id="Rf1ffd916467540e4"/>
-    <p:sldId xmlns:r="http://schemas.openxmlformats.org/officeDocument/2006/relationships" id="266" r:id="Rc7301704a3aa4726"/>
+    <p:sldId xmlns:r="http://schemas.openxmlformats.org/officeDocument/2006/relationships" id="256" r:id="R0decddf6a35947c4"/>
+    <p:sldId xmlns:r="http://schemas.openxmlformats.org/officeDocument/2006/relationships" id="257" r:id="Rbb4c27554b7f424e"/>
+    <p:sldId xmlns:r="http://schemas.openxmlformats.org/officeDocument/2006/relationships" id="258" r:id="R1cebdef5fc064b88"/>
+    <p:sldId xmlns:r="http://schemas.openxmlformats.org/officeDocument/2006/relationships" id="259" r:id="R8ff12b12200d4eb7"/>
+    <p:sldId xmlns:r="http://schemas.openxmlformats.org/officeDocument/2006/relationships" id="260" r:id="R054cc70841b14097"/>
+    <p:sldId xmlns:r="http://schemas.openxmlformats.org/officeDocument/2006/relationships" id="261" r:id="Rabbf44ddb3734ac5"/>
+    <p:sldId xmlns:r="http://schemas.openxmlformats.org/officeDocument/2006/relationships" id="262" r:id="R04c0a818d091424b"/>
+    <p:sldId xmlns:r="http://schemas.openxmlformats.org/officeDocument/2006/relationships" id="263" r:id="R91f342426f8e4a28"/>
+    <p:sldId xmlns:r="http://schemas.openxmlformats.org/officeDocument/2006/relationships" id="264" r:id="R4a1e1fa7c16e4f7a"/>
+    <p:sldId xmlns:r="http://schemas.openxmlformats.org/officeDocument/2006/relationships" id="265" r:id="Rccf0164c366e467a"/>
+    <p:sldId xmlns:r="http://schemas.openxmlformats.org/officeDocument/2006/relationships" id="266" r:id="R8afa91bf4bb64a53"/>
   </p:sldIdLst>
   <p:sldSz cx="15240000" cy="8572500"/>
   <p:notesSz cx="6858000" cy="9144000"/>
@@ -1485,7 +1485,7 @@
   </p:cSld>
   <p:clrMap bg1="lt1" tx1="dk1" bg2="lt2" tx2="dk2" accent1="accent1" accent2="accent2" accent3="accent3" accent4="accent4" accent5="accent5" accent6="accent6" hlink="hlink" folHlink="folHlink"/>
   <p:sldLayoutIdLst>
-    <p:sldLayoutId xmlns:r="http://schemas.openxmlformats.org/officeDocument/2006/relationships" id="2147483649" r:id="R521b3641302342b1"/>
+    <p:sldLayoutId xmlns:r="http://schemas.openxmlformats.org/officeDocument/2006/relationships" id="2147483649" r:id="Rf952ab71b1574858"/>
   </p:sldLayoutIdLst>
   <p:txStyles>
     <p:titleStyle>
@@ -2425,14 +2425,14 @@
       </p:sp>
       <p:pic>
         <p:nvPicPr>
-          <p:cNvPr id="17" name=""/>
+          <p:cNvPr id="18" name=""/>
           <p:cNvPicPr>
             <a:picLocks xmlns:a="http://schemas.openxmlformats.org/drawingml/2006/main" noChangeAspect="1"/>
           </p:cNvPicPr>
           <p:nvPr/>
         </p:nvPicPr>
         <p:blipFill>
-          <a:blip xmlns:r="http://schemas.openxmlformats.org/officeDocument/2006/relationships" xmlns:a="http://schemas.openxmlformats.org/drawingml/2006/main" r:embed="R982966bbc874459b"/>
+          <a:blip xmlns:r="http://schemas.openxmlformats.org/officeDocument/2006/relationships" xmlns:a="http://schemas.openxmlformats.org/drawingml/2006/main" r:embed="R6927022f668944f0"/>
           <a:stretch xmlns:a="http://schemas.openxmlformats.org/drawingml/2006/main"/>
         </p:blipFill>
         <p:spPr>
@@ -2622,6 +2622,31 @@
           </a:p>
         </p:txBody>
       </p:sp>
+      <p:pic>
+        <p:nvPicPr>
+          <p:cNvPr id="22" name=""/>
+          <p:cNvPicPr>
+            <a:picLocks xmlns:a="http://schemas.openxmlformats.org/drawingml/2006/main" noChangeAspect="1"/>
+          </p:cNvPicPr>
+          <p:nvPr/>
+        </p:nvPicPr>
+        <p:blipFill>
+          <a:blip xmlns:r="http://schemas.openxmlformats.org/officeDocument/2006/relationships" xmlns:a="http://schemas.openxmlformats.org/drawingml/2006/main" r:embed="Rd1d0da75597c4e87"/>
+          <a:srcRect xmlns:a="http://schemas.openxmlformats.org/drawingml/2006/main" l="0" t="0" r="0" b="0"/>
+          <a:stretch xmlns:a="http://schemas.openxmlformats.org/drawingml/2006/main">
+            <a:fillRect l="0" t="0" r="0" b="0"/>
+          </a:stretch>
+        </p:blipFill>
+        <p:spPr>
+          <a:xfrm xmlns:a="http://schemas.openxmlformats.org/drawingml/2006/main">
+            <a:off x="7715250" y="2477691"/>
+            <a:ext cx="6667500" cy="3750469"/>
+          </a:xfrm>
+          <a:prstGeom xmlns:a="http://schemas.openxmlformats.org/drawingml/2006/main" prst="roundRect">
+            <a:avLst/>
+          </a:prstGeom>
+        </p:spPr>
+      </p:pic>
     </p:spTree>
     <p:extLst>
       <p:ext uri="{BB962C8B-B14F-4D97-AF65-F5344CB8AC3E}">
@@ -2653,7 +2678,7 @@
           <p:nvPr/>
         </p:nvPicPr>
         <p:blipFill>
-          <a:blip xmlns:r="http://schemas.openxmlformats.org/officeDocument/2006/relationships" xmlns:a="http://schemas.openxmlformats.org/drawingml/2006/main" r:embed="Raca72cacdcfe4a26"/>
+          <a:blip xmlns:r="http://schemas.openxmlformats.org/officeDocument/2006/relationships" xmlns:a="http://schemas.openxmlformats.org/drawingml/2006/main" r:embed="R9909b5a239234798"/>
           <a:srcRect xmlns:a="http://schemas.openxmlformats.org/drawingml/2006/main" l="0" t="0" r="0" b="0"/>
           <a:stretch xmlns:a="http://schemas.openxmlformats.org/drawingml/2006/main">
             <a:fillRect l="0" t="0" r="0" b="0"/>
@@ -3111,7 +3136,7 @@
           <p:nvPr/>
         </p:nvPicPr>
         <p:blipFill>
-          <a:blip xmlns:r="http://schemas.openxmlformats.org/officeDocument/2006/relationships" xmlns:a="http://schemas.openxmlformats.org/drawingml/2006/main" r:embed="R6ca6cfb145b04e6c"/>
+          <a:blip xmlns:r="http://schemas.openxmlformats.org/officeDocument/2006/relationships" xmlns:a="http://schemas.openxmlformats.org/drawingml/2006/main" r:embed="R0ec13a034f654de9"/>
           <a:stretch xmlns:a="http://schemas.openxmlformats.org/drawingml/2006/main"/>
         </p:blipFill>
         <p:spPr>
@@ -4758,7 +4783,7 @@
           <p:nvPr/>
         </p:nvPicPr>
         <p:blipFill>
-          <a:blip xmlns:r="http://schemas.openxmlformats.org/officeDocument/2006/relationships" xmlns:a="http://schemas.openxmlformats.org/drawingml/2006/main" r:embed="Rf8dbf73363c04e97"/>
+          <a:blip xmlns:r="http://schemas.openxmlformats.org/officeDocument/2006/relationships" xmlns:a="http://schemas.openxmlformats.org/drawingml/2006/main" r:embed="R32925bf3c169406a"/>
           <a:stretch xmlns:a="http://schemas.openxmlformats.org/drawingml/2006/main"/>
         </p:blipFill>
         <p:spPr>
@@ -7437,7 +7462,7 @@
           <p:nvPr/>
         </p:nvPicPr>
         <p:blipFill>
-          <a:blip xmlns:r="http://schemas.openxmlformats.org/officeDocument/2006/relationships" xmlns:a="http://schemas.openxmlformats.org/drawingml/2006/main" r:embed="Rf3b93ab8cd4c41ef"/>
+          <a:blip xmlns:r="http://schemas.openxmlformats.org/officeDocument/2006/relationships" xmlns:a="http://schemas.openxmlformats.org/drawingml/2006/main" r:embed="Ra2ccd8e92fed4c21"/>
           <a:stretch xmlns:a="http://schemas.openxmlformats.org/drawingml/2006/main"/>
         </p:blipFill>
         <p:spPr>
@@ -8087,7 +8112,7 @@
           <p:nvPr/>
         </p:nvPicPr>
         <p:blipFill>
-          <a:blip xmlns:r="http://schemas.openxmlformats.org/officeDocument/2006/relationships" xmlns:a="http://schemas.openxmlformats.org/drawingml/2006/main" r:embed="Re5524c358c254334"/>
+          <a:blip xmlns:r="http://schemas.openxmlformats.org/officeDocument/2006/relationships" xmlns:a="http://schemas.openxmlformats.org/drawingml/2006/main" r:embed="Re4b6b5bc752e42e0"/>
           <a:stretch xmlns:a="http://schemas.openxmlformats.org/drawingml/2006/main"/>
         </p:blipFill>
         <p:spPr>

</xml_diff>

<commit_message>
fullstack(chore): ship Woven 0.1.1 submission package
Summary:
- Add the verified judge deck, stage fallback frames, and slide assets.
- Use a cache-safe local plugin launcher and sync the 0.1.1 version.
- Align installation, demo, brand, Devpost, and handover guidance.

Rationale:
- Keep the live pitch usable when the MCP host or stage server fails.
- Make local plugin installation reproducible without weakening trust copy.

Tests:
- npm run check
- Six-tool stdio MCP smoke test
- PowerPoint overflow check and visual review of all 11 slides
</commit_message>
<xml_diff>
--- a/docs/Woven-Hackathon-Pitch.pptx
+++ b/docs/Woven-Hackathon-Pitch.pptx
@@ -2,23 +2,23 @@
 <file path=ppt/presentation.xml><?xml version="1.0" encoding="utf-8"?>
 <p:presentation xmlns:p="http://schemas.openxmlformats.org/presentationml/2006/main">
   <p:sldMasterIdLst>
-    <p:sldMasterId xmlns:r="http://schemas.openxmlformats.org/officeDocument/2006/relationships" id="2147483648" r:id="R68a0510b5c074beb"/>
+    <p:sldMasterId xmlns:r="http://schemas.openxmlformats.org/officeDocument/2006/relationships" id="2147483648" r:id="Rbd7b917bceef459a"/>
   </p:sldMasterIdLst>
   <p:notesMasterIdLst>
-    <p:notesMasterId xmlns:r="http://schemas.openxmlformats.org/officeDocument/2006/relationships" r:id="Rf9928dd6c9a04bd2"/>
+    <p:notesMasterId xmlns:r="http://schemas.openxmlformats.org/officeDocument/2006/relationships" r:id="Reb6cee3a506b43cf"/>
   </p:notesMasterIdLst>
   <p:sldIdLst>
-    <p:sldId xmlns:r="http://schemas.openxmlformats.org/officeDocument/2006/relationships" id="256" r:id="R0decddf6a35947c4"/>
-    <p:sldId xmlns:r="http://schemas.openxmlformats.org/officeDocument/2006/relationships" id="257" r:id="Rbb4c27554b7f424e"/>
-    <p:sldId xmlns:r="http://schemas.openxmlformats.org/officeDocument/2006/relationships" id="258" r:id="R1cebdef5fc064b88"/>
-    <p:sldId xmlns:r="http://schemas.openxmlformats.org/officeDocument/2006/relationships" id="259" r:id="R8ff12b12200d4eb7"/>
-    <p:sldId xmlns:r="http://schemas.openxmlformats.org/officeDocument/2006/relationships" id="260" r:id="R054cc70841b14097"/>
-    <p:sldId xmlns:r="http://schemas.openxmlformats.org/officeDocument/2006/relationships" id="261" r:id="Rabbf44ddb3734ac5"/>
-    <p:sldId xmlns:r="http://schemas.openxmlformats.org/officeDocument/2006/relationships" id="262" r:id="R04c0a818d091424b"/>
-    <p:sldId xmlns:r="http://schemas.openxmlformats.org/officeDocument/2006/relationships" id="263" r:id="R91f342426f8e4a28"/>
-    <p:sldId xmlns:r="http://schemas.openxmlformats.org/officeDocument/2006/relationships" id="264" r:id="R4a1e1fa7c16e4f7a"/>
-    <p:sldId xmlns:r="http://schemas.openxmlformats.org/officeDocument/2006/relationships" id="265" r:id="Rccf0164c366e467a"/>
-    <p:sldId xmlns:r="http://schemas.openxmlformats.org/officeDocument/2006/relationships" id="266" r:id="R8afa91bf4bb64a53"/>
+    <p:sldId xmlns:r="http://schemas.openxmlformats.org/officeDocument/2006/relationships" id="256" r:id="R5326ca9495684228"/>
+    <p:sldId xmlns:r="http://schemas.openxmlformats.org/officeDocument/2006/relationships" id="257" r:id="R7129933df5f84180"/>
+    <p:sldId xmlns:r="http://schemas.openxmlformats.org/officeDocument/2006/relationships" id="258" r:id="Ree048974157b4473"/>
+    <p:sldId xmlns:r="http://schemas.openxmlformats.org/officeDocument/2006/relationships" id="259" r:id="Rfbc0c85f698f4fa6"/>
+    <p:sldId xmlns:r="http://schemas.openxmlformats.org/officeDocument/2006/relationships" id="260" r:id="R4aba994753af4d4e"/>
+    <p:sldId xmlns:r="http://schemas.openxmlformats.org/officeDocument/2006/relationships" id="261" r:id="R1293d76b0bb24c15"/>
+    <p:sldId xmlns:r="http://schemas.openxmlformats.org/officeDocument/2006/relationships" id="262" r:id="R7b5ce42f81a54f6f"/>
+    <p:sldId xmlns:r="http://schemas.openxmlformats.org/officeDocument/2006/relationships" id="263" r:id="R42e87175a6a34fd9"/>
+    <p:sldId xmlns:r="http://schemas.openxmlformats.org/officeDocument/2006/relationships" id="264" r:id="R37dfb12e7e61470d"/>
+    <p:sldId xmlns:r="http://schemas.openxmlformats.org/officeDocument/2006/relationships" id="265" r:id="R43bbd7ed52b947d6"/>
+    <p:sldId xmlns:r="http://schemas.openxmlformats.org/officeDocument/2006/relationships" id="266" r:id="R6026b644a94e4a72"/>
   </p:sldIdLst>
   <p:sldSz cx="15240000" cy="8572500"/>
   <p:notesSz cx="6858000" cy="9144000"/>
@@ -452,7 +452,17 @@
           <a:lstStyle xmlns:a="http://schemas.openxmlformats.org/drawingml/2006/main"/>
           <a:p xmlns:a="http://schemas.openxmlformats.org/drawingml/2006/main">
             <a:r>
-              <a:t>Open with the core idea: shopping should start and finish in the conversation where the need was expressed. Woven turns one request into a complete cart, then keeps the final purchase visibly human.</a:t>
+              <a:t>TIME 0:00–0:12</a:t>
+            </a:r>
+          </a:p>
+          <a:p xmlns:a="http://schemas.openxmlformats.org/drawingml/2006/main">
+            <a:r>
+              <a:t>NARRATIVE JOB</a:t>
+            </a:r>
+          </a:p>
+          <a:p xmlns:a="http://schemas.openxmlformats.org/drawingml/2006/main">
+            <a:r>
+              <a:t>Establish that shopping should start and finish in the conversation where the need was expressed.</a:t>
             </a:r>
           </a:p>
           <a:p xmlns:a="http://schemas.openxmlformats.org/drawingml/2006/main">
@@ -462,22 +472,67 @@
           </a:p>
           <a:p xmlns:a="http://schemas.openxmlformats.org/drawingml/2006/main">
             <a:r>
+              <a:t>SAY</a:t>
+            </a:r>
+          </a:p>
+          <a:p xmlns:a="http://schemas.openxmlformats.org/drawingml/2006/main">
+            <a:r>
+              <a:t>“We already ask ChatGPT what to buy. But actually buying still means opening tabs, checking compatibility, finding stock, and rebuilding everything at checkout. We built Woven to finish that process.”</a:t>
+            </a:r>
+          </a:p>
+          <a:p xmlns:a="http://schemas.openxmlformats.org/drawingml/2006/main">
+            <a:r>
+              <a:t/>
+            </a:r>
+          </a:p>
+          <a:p xmlns:a="http://schemas.openxmlformats.org/drawingml/2006/main">
+            <a:r>
+              <a:t>STAGE CUE</a:t>
+            </a:r>
+          </a:p>
+          <a:p xmlns:a="http://schemas.openxmlformats.org/drawingml/2006/main">
+            <a:r>
+              <a:t>Hold this slide for the full opening. The Flightpath hero is illustrative brand artwork; the working product proof begins on slide 3.</a:t>
+            </a:r>
+          </a:p>
+          <a:p xmlns:a="http://schemas.openxmlformats.org/drawingml/2006/main">
+            <a:r>
+              <a:t/>
+            </a:r>
+          </a:p>
+          <a:p xmlns:a="http://schemas.openxmlformats.org/drawingml/2006/main">
+            <a:r>
+              <a:t>TRANSITION</a:t>
+            </a:r>
+          </a:p>
+          <a:p xmlns:a="http://schemas.openxmlformats.org/drawingml/2006/main">
+            <a:r>
+              <a:t>“The hard part is not finding a product. It is completing the whole mission.”</a:t>
+            </a:r>
+          </a:p>
+          <a:p xmlns:a="http://schemas.openxmlformats.org/drawingml/2006/main">
+            <a:r>
+              <a:t/>
+            </a:r>
+          </a:p>
+          <a:p xmlns:a="http://schemas.openxmlformats.org/drawingml/2006/main">
+            <a:r>
               <a:t>[Sources]</a:t>
             </a:r>
           </a:p>
           <a:p xmlns:a="http://schemas.openxmlformats.org/drawingml/2006/main">
             <a:r>
-              <a:t>- SCRIPT.md — Opening</a:t>
-            </a:r>
-          </a:p>
-          <a:p xmlns:a="http://schemas.openxmlformats.org/drawingml/2006/main">
-            <a:r>
-              <a:t>- docs/assets/screenshots/buyer-overview.png</a:t>
-            </a:r>
-          </a:p>
-          <a:p xmlns:a="http://schemas.openxmlformats.org/drawingml/2006/main">
-            <a:r>
-              <a:t>- docs/BRAND_GUIDE.md — Product voice and visual system</a:t>
+              <a:t>- script.md — 0:00–0:12 opening</a:t>
+            </a:r>
+          </a:p>
+          <a:p xmlns:a="http://schemas.openxmlformats.org/drawingml/2006/main">
+            <a:r>
+              <a:t>- docs/assets/brand/woven-hero-flightpath.png</a:t>
+            </a:r>
+          </a:p>
+          <a:p xmlns:a="http://schemas.openxmlformats.org/drawingml/2006/main">
+            <a:r>
+              <a:t>- docs/BRAND_GUIDE.md — Product promise and visual system</a:t>
             </a:r>
           </a:p>
         </p:txBody>
@@ -547,7 +602,12 @@
           <a:lstStyle xmlns:a="http://schemas.openxmlformats.org/drawingml/2006/main"/>
           <a:p xmlns:a="http://schemas.openxmlformats.org/drawingml/2006/main">
             <a:r>
-              <a:t>Use this in technical Q&amp;A. The ChatGPT or Codex host invokes Woven's MCP tools. The one-service backend owns cart construction, mandate binding, confirmation, order state and the simulated authorization adapter. The browser demo is a second transport over the same backend.</a:t>
+              <a:t>USE IN TECHNICAL Q&amp;A — ARCHITECTURE</a:t>
+            </a:r>
+          </a:p>
+          <a:p xmlns:a="http://schemas.openxmlformats.org/drawingml/2006/main">
+            <a:r>
+              <a:t>The ChatGPT or Codex host invokes Woven’s MCP tools. One Node.js service owns cart construction, checkout mandate binding, confirmation, order state, merchant operations, and the simulated Visa adapter. The browser demo is a second transport over the same backend, not a separate product.</a:t>
             </a:r>
           </a:p>
           <a:p xmlns:a="http://schemas.openxmlformats.org/drawingml/2006/main">
@@ -557,6 +617,21 @@
           </a:p>
           <a:p xmlns:a="http://schemas.openxmlformats.org/drawingml/2006/main">
             <a:r>
+              <a:t>POINT TO</a:t>
+            </a:r>
+          </a:p>
+          <a:p xmlns:a="http://schemas.openxmlformats.org/drawingml/2006/main">
+            <a:r>
+              <a:t>MCP and HTTP transports. Mission and cart engine. Checkout guard. Node SQLite atomic inventory and order transaction. Simulated Visa boundary.</a:t>
+            </a:r>
+          </a:p>
+          <a:p xmlns:a="http://schemas.openxmlformats.org/drawingml/2006/main">
+            <a:r>
+              <a:t/>
+            </a:r>
+          </a:p>
+          <a:p xmlns:a="http://schemas.openxmlformats.org/drawingml/2006/main">
+            <a:r>
               <a:t>[Sources]</a:t>
             </a:r>
           </a:p>
@@ -568,6 +643,11 @@
           <a:p xmlns:a="http://schemas.openxmlformats.org/drawingml/2006/main">
             <a:r>
               <a:t>- docs/architecture.md — System architecture and trust boundaries</a:t>
+            </a:r>
+          </a:p>
+          <a:p xmlns:a="http://schemas.openxmlformats.org/drawingml/2006/main">
+            <a:r>
+              <a:t>- docs/HANDOVER.md — One-service product invariant</a:t>
             </a:r>
           </a:p>
         </p:txBody>
@@ -637,7 +717,12 @@
           <a:lstStyle xmlns:a="http://schemas.openxmlformats.org/drawingml/2006/main"/>
           <a:p xmlns:a="http://schemas.openxmlformats.org/drawingml/2006/main">
             <a:r>
-              <a:t>Use this in trust and safety Q&amp;A. Current controls bind merchant, cart version, amount, expiry, nonce and idempotency key; recheck price and stock; keep the confirmation nonce outside model-visible tool arguments; and simulate reversals on downstream order failure. Identity is a planned pre-checkout control and is not implemented.</a:t>
+              <a:t>USE IN TRUST AND SAFETY Q&amp;A</a:t>
+            </a:r>
+          </a:p>
+          <a:p xmlns:a="http://schemas.openxmlformats.org/drawingml/2006/main">
+            <a:r>
+              <a:t>Current controls bind merchant, cart version, amount, expiry, nonce, and idempotency key; recheck price and stock; keep the confirmation nonce outside model-visible tool arguments; and simulate reversal after downstream merchant failure. Identity is a planned pre-checkout control and is not implemented.</a:t>
             </a:r>
           </a:p>
           <a:p xmlns:a="http://schemas.openxmlformats.org/drawingml/2006/main">
@@ -647,6 +732,21 @@
           </a:p>
           <a:p xmlns:a="http://schemas.openxmlformats.org/drawingml/2006/main">
             <a:r>
+              <a:t>JUDGE ANSWER</a:t>
+            </a:r>
+          </a:p>
+          <a:p xmlns:a="http://schemas.openxmlformats.org/drawingml/2006/main">
+            <a:r>
+              <a:t>“The model never gets the final yes. It can recommend, but only the widget receives the private confirmation value, and only a direct user action can consume it for the exact displayed terms.”</a:t>
+            </a:r>
+          </a:p>
+          <a:p xmlns:a="http://schemas.openxmlformats.org/drawingml/2006/main">
+            <a:r>
+              <a:t/>
+            </a:r>
+          </a:p>
+          <a:p xmlns:a="http://schemas.openxmlformats.org/drawingml/2006/main">
+            <a:r>
               <a:t>[Sources]</a:t>
             </a:r>
           </a:p>
@@ -657,7 +757,7 @@
           </a:p>
           <a:p xmlns:a="http://schemas.openxmlformats.org/drawingml/2006/main">
             <a:r>
-              <a:t>- docs/architecture.md — Mandate, confirmation and failure state machine</a:t>
+              <a:t>- docs/architecture.md — Mandate, nonce, idempotency, and reversal state machine</a:t>
             </a:r>
           </a:p>
           <a:p xmlns:a="http://schemas.openxmlformats.org/drawingml/2006/main">
@@ -732,7 +832,17 @@
           <a:lstStyle xmlns:a="http://schemas.openxmlformats.org/drawingml/2006/main"/>
           <a:p xmlns:a="http://schemas.openxmlformats.org/drawingml/2006/main">
             <a:r>
-              <a:t>Search can discover products, but the buyer still has to compare tabs, verify compatibility, reconstruct a single-store cart, and re-enter the decision at checkout. The friction is not finding an item; it is completing the mission.</a:t>
+              <a:t>TIME 0:12–0:30</a:t>
+            </a:r>
+          </a:p>
+          <a:p xmlns:a="http://schemas.openxmlformats.org/drawingml/2006/main">
+            <a:r>
+              <a:t>NARRATIVE JOB</a:t>
+            </a:r>
+          </a:p>
+          <a:p xmlns:a="http://schemas.openxmlformats.org/drawingml/2006/main">
+            <a:r>
+              <a:t>Make the unfinished work after search concrete.</a:t>
             </a:r>
           </a:p>
           <a:p xmlns:a="http://schemas.openxmlformats.org/drawingml/2006/main">
@@ -742,17 +852,67 @@
           </a:p>
           <a:p xmlns:a="http://schemas.openxmlformats.org/drawingml/2006/main">
             <a:r>
+              <a:t>SAY</a:t>
+            </a:r>
+          </a:p>
+          <a:p xmlns:a="http://schemas.openxmlformats.org/drawingml/2006/main">
+            <a:r>
+              <a:t>“Imagine flying tonight and needing a charger for three devices. Search can recommend individual products, but it does not guarantee that everything works together, fits your budget, is available today, and can be collected from one place.”</a:t>
+            </a:r>
+          </a:p>
+          <a:p xmlns:a="http://schemas.openxmlformats.org/drawingml/2006/main">
+            <a:r>
+              <a:t/>
+            </a:r>
+          </a:p>
+          <a:p xmlns:a="http://schemas.openxmlformats.org/drawingml/2006/main">
+            <a:r>
+              <a:t>POINT TO</a:t>
+            </a:r>
+          </a:p>
+          <a:p xmlns:a="http://schemas.openxmlformats.org/drawingml/2006/main">
+            <a:r>
+              <a:t>Compare products. Check compatibility. Find one store. The user still has to rebuild the cart at checkout.</a:t>
+            </a:r>
+          </a:p>
+          <a:p xmlns:a="http://schemas.openxmlformats.org/drawingml/2006/main">
+            <a:r>
+              <a:t/>
+            </a:r>
+          </a:p>
+          <a:p xmlns:a="http://schemas.openxmlformats.org/drawingml/2006/main">
+            <a:r>
+              <a:t>TRANSITION</a:t>
+            </a:r>
+          </a:p>
+          <a:p xmlns:a="http://schemas.openxmlformats.org/drawingml/2006/main">
+            <a:r>
+              <a:t>“Woven resolves those constraints together.”</a:t>
+            </a:r>
+          </a:p>
+          <a:p xmlns:a="http://schemas.openxmlformats.org/drawingml/2006/main">
+            <a:r>
+              <a:t/>
+            </a:r>
+          </a:p>
+          <a:p xmlns:a="http://schemas.openxmlformats.org/drawingml/2006/main">
+            <a:r>
               <a:t>[Sources]</a:t>
             </a:r>
           </a:p>
           <a:p xmlns:a="http://schemas.openxmlformats.org/drawingml/2006/main">
             <a:r>
-              <a:t>- SCRIPT.md — The problem</a:t>
+              <a:t>- script.md — 0:12–0:30 problem framing</a:t>
             </a:r>
           </a:p>
           <a:p xmlns:a="http://schemas.openxmlformats.org/drawingml/2006/main">
             <a:r>
               <a:t>- docs/PRD.md — Primary persona and canonical mission</a:t>
+            </a:r>
+          </a:p>
+          <a:p xmlns:a="http://schemas.openxmlformats.org/drawingml/2006/main">
+            <a:r>
+              <a:t>- README.md — Product search versus Woven</a:t>
             </a:r>
           </a:p>
         </p:txBody>
@@ -822,7 +982,17 @@
           <a:lstStyle xmlns:a="http://schemas.openxmlformats.org/drawingml/2006/main"/>
           <a:p xmlns:a="http://schemas.openxmlformats.org/drawingml/2006/main">
             <a:r>
-              <a:t>The result is deliberately cart-level: one merchant and pickup point, four compatible components, S$133 total, and pickup today. Every item works with the others; the buyer does not have to rebuild the answer.</a:t>
+              <a:t>TIME 0:30–0:48</a:t>
+            </a:r>
+          </a:p>
+          <a:p xmlns:a="http://schemas.openxmlformats.org/drawingml/2006/main">
+            <a:r>
+              <a:t>NARRATIVE JOB</a:t>
+            </a:r>
+          </a:p>
+          <a:p xmlns:a="http://schemas.openxmlformats.org/drawingml/2006/main">
+            <a:r>
+              <a:t>Reveal Woven’s cart-level difference before switching to the product.</a:t>
             </a:r>
           </a:p>
           <a:p xmlns:a="http://schemas.openxmlformats.org/drawingml/2006/main">
@@ -832,12 +1002,57 @@
           </a:p>
           <a:p xmlns:a="http://schemas.openxmlformats.org/drawingml/2006/main">
             <a:r>
+              <a:t>SAY</a:t>
+            </a:r>
+          </a:p>
+          <a:p xmlns:a="http://schemas.openxmlformats.org/drawingml/2006/main">
+            <a:r>
+              <a:t>“Woven understands the complete request, eliminates incompatible combinations, and creates ready-to-buy carts. Every cart comes from one merchant and one location, with an explanation of why every component works.”</a:t>
+            </a:r>
+          </a:p>
+          <a:p xmlns:a="http://schemas.openxmlformats.org/drawingml/2006/main">
+            <a:r>
+              <a:t/>
+            </a:r>
+          </a:p>
+          <a:p xmlns:a="http://schemas.openxmlformats.org/drawingml/2006/main">
+            <a:r>
+              <a:t>POINT TO</a:t>
+            </a:r>
+          </a:p>
+          <a:p xmlns:a="http://schemas.openxmlformats.org/drawingml/2006/main">
+            <a:r>
+              <a:t>One merchant and pickup point. Four compatible components. S$133 total. Pickup today.</a:t>
+            </a:r>
+          </a:p>
+          <a:p xmlns:a="http://schemas.openxmlformats.org/drawingml/2006/main">
+            <a:r>
+              <a:t/>
+            </a:r>
+          </a:p>
+          <a:p xmlns:a="http://schemas.openxmlformats.org/drawingml/2006/main">
+            <a:r>
+              <a:t>TRANSITION</a:t>
+            </a:r>
+          </a:p>
+          <a:p xmlns:a="http://schemas.openxmlformats.org/drawingml/2006/main">
+            <a:r>
+              <a:t>“Let me show you.”</a:t>
+            </a:r>
+          </a:p>
+          <a:p xmlns:a="http://schemas.openxmlformats.org/drawingml/2006/main">
+            <a:r>
+              <a:t/>
+            </a:r>
+          </a:p>
+          <a:p xmlns:a="http://schemas.openxmlformats.org/drawingml/2006/main">
+            <a:r>
               <a:t>[Sources]</a:t>
             </a:r>
           </a:p>
           <a:p xmlns:a="http://schemas.openxmlformats.org/drawingml/2006/main">
             <a:r>
-              <a:t>- SCRIPT.md — Product reveal</a:t>
+              <a:t>- script.md — 0:30–0:48 product reveal</a:t>
             </a:r>
           </a:p>
           <a:p xmlns:a="http://schemas.openxmlformats.org/drawingml/2006/main">
@@ -847,7 +1062,7 @@
           </a:p>
           <a:p xmlns:a="http://schemas.openxmlformats.org/drawingml/2006/main">
             <a:r>
-              <a:t>- docs/PRD.md — Cart requirements</a:t>
+              <a:t>- docs/PRD.md — Complete-cart requirements</a:t>
             </a:r>
           </a:p>
         </p:txBody>
@@ -917,7 +1132,17 @@
           <a:lstStyle xmlns:a="http://schemas.openxmlformats.org/drawingml/2006/main"/>
           <a:p xmlns:a="http://schemas.openxmlformats.org/drawingml/2006/main">
             <a:r>
-              <a:t>Switch to the working app now. Use the canonical Tokyo request. Show the three complete carts, then open ByteRoute and point out the charger, cables, destination adapter, one pickup location, seeded demo stock, and S$133 total. Do not explain the ranking algorithm unless asked.</a:t>
+              <a:t>TIME 0:48–1:30</a:t>
+            </a:r>
+          </a:p>
+          <a:p xmlns:a="http://schemas.openxmlformats.org/drawingml/2006/main">
+            <a:r>
+              <a:t>NARRATIVE JOB</a:t>
+            </a:r>
+          </a:p>
+          <a:p xmlns:a="http://schemas.openxmlformats.org/drawingml/2006/main">
+            <a:r>
+              <a:t>Hand off to the working MCP App or the /demo fallback and let the result prove the value.</a:t>
             </a:r>
           </a:p>
           <a:p xmlns:a="http://schemas.openxmlformats.org/drawingml/2006/main">
@@ -927,22 +1152,92 @@
           </a:p>
           <a:p xmlns:a="http://schemas.openxmlformats.org/drawingml/2006/main">
             <a:r>
+              <a:t>ENTER OR REVEAL</a:t>
+            </a:r>
+          </a:p>
+          <a:p xmlns:a="http://schemas.openxmlformats.org/drawingml/2006/main">
+            <a:r>
+              <a:t>“I fly to Tokyo tonight. Build a charging kit for my MacBook Air, iPhone and AirPods under S$150, with pickup today.”</a:t>
+            </a:r>
+          </a:p>
+          <a:p xmlns:a="http://schemas.openxmlformats.org/drawingml/2006/main">
+            <a:r>
+              <a:t/>
+            </a:r>
+          </a:p>
+          <a:p xmlns:a="http://schemas.openxmlformats.org/drawingml/2006/main">
+            <a:r>
+              <a:t>DEMO ACTIONS</a:t>
+            </a:r>
+          </a:p>
+          <a:p xmlns:a="http://schemas.openxmlformats.org/drawingml/2006/main">
+            <a:r>
+              <a:t>1. Show the three ranked, one-merchant carts.</a:t>
+            </a:r>
+          </a:p>
+          <a:p xmlns:a="http://schemas.openxmlformats.org/drawingml/2006/main">
+            <a:r>
+              <a:t>2. Select ByteRoute.</a:t>
+            </a:r>
+          </a:p>
+          <a:p xmlns:a="http://schemas.openxmlformats.org/drawingml/2006/main">
+            <a:r>
+              <a:t>3. Point to charger wattage and voltage, both required cables, the Japan adapter, one pickup location, seeded demo stock, and the S$133 total.</a:t>
+            </a:r>
+          </a:p>
+          <a:p xmlns:a="http://schemas.openxmlformats.org/drawingml/2006/main">
+            <a:r>
+              <a:t/>
+            </a:r>
+          </a:p>
+          <a:p xmlns:a="http://schemas.openxmlformats.org/drawingml/2006/main">
+            <a:r>
+              <a:t>SAY</a:t>
+            </a:r>
+          </a:p>
+          <a:p xmlns:a="http://schemas.openxmlformats.org/drawingml/2006/main">
+            <a:r>
+              <a:t>“Woven returned three complete options—not loose product links. This S$133 cart includes the charger, both required cables, and the Japan adapter. Everything is compatible, under budget, available in our demo inventory, and ready at one pickup location.”</a:t>
+            </a:r>
+          </a:p>
+          <a:p xmlns:a="http://schemas.openxmlformats.org/drawingml/2006/main">
+            <a:r>
+              <a:t/>
+            </a:r>
+          </a:p>
+          <a:p xmlns:a="http://schemas.openxmlformats.org/drawingml/2006/main">
+            <a:r>
+              <a:t>STAGE GUARDRAIL</a:t>
+            </a:r>
+          </a:p>
+          <a:p xmlns:a="http://schemas.openxmlformats.org/drawingml/2006/main">
+            <a:r>
+              <a:t>Do not explain the ranking algorithm unless asked. If the MCP host fails, move immediately to /demo; it uses the same backend.</a:t>
+            </a:r>
+          </a:p>
+          <a:p xmlns:a="http://schemas.openxmlformats.org/drawingml/2006/main">
+            <a:r>
+              <a:t/>
+            </a:r>
+          </a:p>
+          <a:p xmlns:a="http://schemas.openxmlformats.org/drawingml/2006/main">
+            <a:r>
               <a:t>[Sources]</a:t>
             </a:r>
           </a:p>
           <a:p xmlns:a="http://schemas.openxmlformats.org/drawingml/2006/main">
             <a:r>
-              <a:t>- SCRIPT.md — Live demo, working checkout block</a:t>
-            </a:r>
-          </a:p>
-          <a:p xmlns:a="http://schemas.openxmlformats.org/drawingml/2006/main">
-            <a:r>
-              <a:t>- docs/HANDOVER.md — Canonical demo path</a:t>
-            </a:r>
-          </a:p>
-          <a:p xmlns:a="http://schemas.openxmlformats.org/drawingml/2006/main">
-            <a:r>
-              <a:t>- docs/PRD.md — Canonical story</a:t>
+              <a:t>- script.md — 0:48–1:30 live demo</a:t>
+            </a:r>
+          </a:p>
+          <a:p xmlns:a="http://schemas.openxmlformats.org/drawingml/2006/main">
+            <a:r>
+              <a:t>- docs/HANDOVER.md — Canonical demo and fallback</a:t>
+            </a:r>
+          </a:p>
+          <a:p xmlns:a="http://schemas.openxmlformats.org/drawingml/2006/main">
+            <a:r>
+              <a:t>- docs/PRD.md — Canonical story and cart constraints</a:t>
             </a:r>
           </a:p>
         </p:txBody>
@@ -1012,7 +1307,17 @@
           <a:lstStyle xmlns:a="http://schemas.openxmlformats.org/drawingml/2006/main"/>
           <a:p xmlns:a="http://schemas.openxmlformats.org/drawingml/2006/main">
             <a:r>
-              <a:t>Demo the working checkout path only: preview the exact terms, show merchant, items, pickup, total and expiry, then use one direct human confirmation. The returned authorization is simulated. Identity verification is the next server-enforced integration and is not present in the live build. Never present a static identity screen as a working check.</a:t>
+              <a:t>TIME 1:30–2:15</a:t>
+            </a:r>
+          </a:p>
+          <a:p xmlns:a="http://schemas.openxmlformats.org/drawingml/2006/main">
+            <a:r>
+              <a:t>NARRATIVE JOB</a:t>
+            </a:r>
+          </a:p>
+          <a:p xmlns:a="http://schemas.openxmlformats.org/drawingml/2006/main">
+            <a:r>
+              <a:t>Draw the authorization boundary: the AI recommends; the user authorizes the exact purchase.</a:t>
             </a:r>
           </a:p>
           <a:p xmlns:a="http://schemas.openxmlformats.org/drawingml/2006/main">
@@ -1022,12 +1327,97 @@
           </a:p>
           <a:p xmlns:a="http://schemas.openxmlformats.org/drawingml/2006/main">
             <a:r>
+              <a:t>WORKING DEMO ACTIONS — USE NOW</a:t>
+            </a:r>
+          </a:p>
+          <a:p xmlns:a="http://schemas.openxmlformats.org/drawingml/2006/main">
+            <a:r>
+              <a:t>1. Click Review checkout.</a:t>
+            </a:r>
+          </a:p>
+          <a:p xmlns:a="http://schemas.openxmlformats.org/drawingml/2006/main">
+            <a:r>
+              <a:t>2. Show the exact merchant, items, pickup location, total, cart version, and expiry.</a:t>
+            </a:r>
+          </a:p>
+          <a:p xmlns:a="http://schemas.openxmlformats.org/drawingml/2006/main">
+            <a:r>
+              <a:t>3. Pause before clicking Confirm S$133.00.</a:t>
+            </a:r>
+          </a:p>
+          <a:p xmlns:a="http://schemas.openxmlformats.org/drawingml/2006/main">
+            <a:r>
+              <a:t>4. Confirm and show the simulated Visa authorization result and pickup receipt.</a:t>
+            </a:r>
+          </a:p>
+          <a:p xmlns:a="http://schemas.openxmlformats.org/drawingml/2006/main">
+            <a:r>
+              <a:t/>
+            </a:r>
+          </a:p>
+          <a:p xmlns:a="http://schemas.openxmlformats.org/drawingml/2006/main">
+            <a:r>
+              <a:t>SAY</a:t>
+            </a:r>
+          </a:p>
+          <a:p xmlns:a="http://schemas.openxmlformats.org/drawingml/2006/main">
+            <a:r>
+              <a:t>“Woven rechecks the price and stock, then creates an exact ten-minute checkout preview. The AI recommended this cart, but it cannot approve it. The user sees the merchant, every item, the pickup location, and the S$133 total before one direct confirmation.”</a:t>
+            </a:r>
+          </a:p>
+          <a:p xmlns:a="http://schemas.openxmlformats.org/drawingml/2006/main">
+            <a:r>
+              <a:t/>
+            </a:r>
+          </a:p>
+          <a:p xmlns:a="http://schemas.openxmlformats.org/drawingml/2006/main">
+            <a:r>
+              <a:t>“Only after that click does Woven produce a simulated Visa authorization and pickup receipt. No card details enter Woven, and no live charge occurs.”</a:t>
+            </a:r>
+          </a:p>
+          <a:p xmlns:a="http://schemas.openxmlformats.org/drawingml/2006/main">
+            <a:r>
+              <a:t/>
+            </a:r>
+          </a:p>
+          <a:p xmlns:a="http://schemas.openxmlformats.org/drawingml/2006/main">
+            <a:r>
+              <a:t>TRUTH BOUNDARY</a:t>
+            </a:r>
+          </a:p>
+          <a:p xmlns:a="http://schemas.openxmlformats.org/drawingml/2006/main">
+            <a:r>
+              <a:t>Identity verification is planned and not in the live build. Do not show a static identity mock as verification. After server enforcement exists, insert the connector-style demo identity check before exact-term review and keep it separate from final confirmation.</a:t>
+            </a:r>
+          </a:p>
+          <a:p xmlns:a="http://schemas.openxmlformats.org/drawingml/2006/main">
+            <a:r>
+              <a:t/>
+            </a:r>
+          </a:p>
+          <a:p xmlns:a="http://schemas.openxmlformats.org/drawingml/2006/main">
+            <a:r>
+              <a:t>TRANSITION</a:t>
+            </a:r>
+          </a:p>
+          <a:p xmlns:a="http://schemas.openxmlformats.org/drawingml/2006/main">
+            <a:r>
+              <a:t>“The same controls are visible on the merchant side.”</a:t>
+            </a:r>
+          </a:p>
+          <a:p xmlns:a="http://schemas.openxmlformats.org/drawingml/2006/main">
+            <a:r>
+              <a:t/>
+            </a:r>
+          </a:p>
+          <a:p xmlns:a="http://schemas.openxmlformats.org/drawingml/2006/main">
+            <a:r>
               <a:t>[Sources]</a:t>
             </a:r>
           </a:p>
           <a:p xmlns:a="http://schemas.openxmlformats.org/drawingml/2006/main">
             <a:r>
-              <a:t>- SCRIPT.md — Working checkout block and target identity block</a:t>
+              <a:t>- script.md — Working checkout block and target identity block</a:t>
             </a:r>
           </a:p>
           <a:p xmlns:a="http://schemas.openxmlformats.org/drawingml/2006/main">
@@ -1107,7 +1497,17 @@
           <a:lstStyle xmlns:a="http://schemas.openxmlformats.org/drawingml/2006/main"/>
           <a:p xmlns:a="http://schemas.openxmlformats.org/drawingml/2006/main">
             <a:r>
-              <a:t>Switch to the merchant desk. Show inventory and price edits, confirmed orders, the audit trail, and the decline and reversal demo scenarios. Clarify that inventory is seeded and authorization is simulated.</a:t>
+              <a:t>TIME 2:15–2:35</a:t>
+            </a:r>
+          </a:p>
+          <a:p xmlns:a="http://schemas.openxmlformats.org/drawingml/2006/main">
+            <a:r>
+              <a:t>NARRATIVE JOB</a:t>
+            </a:r>
+          </a:p>
+          <a:p xmlns:a="http://schemas.openxmlformats.org/drawingml/2006/main">
+            <a:r>
+              <a:t>Prove that merchants control inventory, scenarios, orders, and auditability.</a:t>
             </a:r>
           </a:p>
           <a:p xmlns:a="http://schemas.openxmlformats.org/drawingml/2006/main">
@@ -1117,12 +1517,72 @@
           </a:p>
           <a:p xmlns:a="http://schemas.openxmlformats.org/drawingml/2006/main">
             <a:r>
+              <a:t>DEMO ACTIONS</a:t>
+            </a:r>
+          </a:p>
+          <a:p xmlns:a="http://schemas.openxmlformats.org/drawingml/2006/main">
+            <a:r>
+              <a:t>Open the Merchant Desk. Show inventory and price controls, confirmed orders, the audit trail, and the stockout, price-change, decline, and reversal scenarios.</a:t>
+            </a:r>
+          </a:p>
+          <a:p xmlns:a="http://schemas.openxmlformats.org/drawingml/2006/main">
+            <a:r>
+              <a:t/>
+            </a:r>
+          </a:p>
+          <a:p xmlns:a="http://schemas.openxmlformats.org/drawingml/2006/main">
+            <a:r>
+              <a:t>SAY</a:t>
+            </a:r>
+          </a:p>
+          <a:p xmlns:a="http://schemas.openxmlformats.org/drawingml/2006/main">
+            <a:r>
+              <a:t>“On the merchant side, Woven already supports inventory import, price and stock controls, orders, and an audit trail. Merchants can simulate a price change, stockout, authorization decline, or reversal without changing code.”</a:t>
+            </a:r>
+          </a:p>
+          <a:p xmlns:a="http://schemas.openxmlformats.org/drawingml/2006/main">
+            <a:r>
+              <a:t/>
+            </a:r>
+          </a:p>
+          <a:p xmlns:a="http://schemas.openxmlformats.org/drawingml/2006/main">
+            <a:r>
+              <a:t>TRUTH BOUNDARY</a:t>
+            </a:r>
+          </a:p>
+          <a:p xmlns:a="http://schemas.openxmlformats.org/drawingml/2006/main">
+            <a:r>
+              <a:t>Call the current values seeded demo data. Do not call the CSV workflow a production merchant integration or imply a live payment rail.</a:t>
+            </a:r>
+          </a:p>
+          <a:p xmlns:a="http://schemas.openxmlformats.org/drawingml/2006/main">
+            <a:r>
+              <a:t/>
+            </a:r>
+          </a:p>
+          <a:p xmlns:a="http://schemas.openxmlformats.org/drawingml/2006/main">
+            <a:r>
+              <a:t>TRANSITION</a:t>
+            </a:r>
+          </a:p>
+          <a:p xmlns:a="http://schemas.openxmlformats.org/drawingml/2006/main">
+            <a:r>
+              <a:t>“That brings us back to why this belongs inside ChatGPT.”</a:t>
+            </a:r>
+          </a:p>
+          <a:p xmlns:a="http://schemas.openxmlformats.org/drawingml/2006/main">
+            <a:r>
+              <a:t/>
+            </a:r>
+          </a:p>
+          <a:p xmlns:a="http://schemas.openxmlformats.org/drawingml/2006/main">
+            <a:r>
               <a:t>[Sources]</a:t>
             </a:r>
           </a:p>
           <a:p xmlns:a="http://schemas.openxmlformats.org/drawingml/2006/main">
             <a:r>
-              <a:t>- SCRIPT.md — Merchant operations</a:t>
+              <a:t>- script.md — 2:15–2:35 merchant operations</a:t>
             </a:r>
           </a:p>
           <a:p xmlns:a="http://schemas.openxmlformats.org/drawingml/2006/main">
@@ -1202,7 +1662,17 @@
           <a:lstStyle xmlns:a="http://schemas.openxmlformats.org/drawingml/2006/main"/>
           <a:p xmlns:a="http://schemas.openxmlformats.org/drawingml/2006/main">
             <a:r>
-              <a:t>Close on the product thesis: the checkout belongs where the request begins. ChatGPT understands the mission, Woven builds the complete cart, and the user controls authorization. Ask once. Review once. Confirm once.</a:t>
+              <a:t>TIME 2:35–3:00</a:t>
+            </a:r>
+          </a:p>
+          <a:p xmlns:a="http://schemas.openxmlformats.org/drawingml/2006/main">
+            <a:r>
+              <a:t>NARRATIVE JOB</a:t>
+            </a:r>
+          </a:p>
+          <a:p xmlns:a="http://schemas.openxmlformats.org/drawingml/2006/main">
+            <a:r>
+              <a:t>Resolve the opening thesis and land the memorable close.</a:t>
             </a:r>
           </a:p>
           <a:p xmlns:a="http://schemas.openxmlformats.org/drawingml/2006/main">
@@ -1212,12 +1682,77 @@
           </a:p>
           <a:p xmlns:a="http://schemas.openxmlformats.org/drawingml/2006/main">
             <a:r>
+              <a:t>SAY</a:t>
+            </a:r>
+          </a:p>
+          <a:p xmlns:a="http://schemas.openxmlformats.org/drawingml/2006/main">
+            <a:r>
+              <a:t>“Why ChatGPT? Because that is where the user’s request already exists. Why a plugin? Because Woven can turn that conversation into merchant actions and a reviewable checkout without asking the user to start again.”</a:t>
+            </a:r>
+          </a:p>
+          <a:p xmlns:a="http://schemas.openxmlformats.org/drawingml/2006/main">
+            <a:r>
+              <a:t/>
+            </a:r>
+          </a:p>
+          <a:p xmlns:a="http://schemas.openxmlformats.org/drawingml/2006/main">
+            <a:r>
+              <a:t>“This prototype uses seeded inventory and a simulated Visa authorization; no live charge occurs. Our next trust step is the connector-style demo identity check.”</a:t>
+            </a:r>
+          </a:p>
+          <a:p xmlns:a="http://schemas.openxmlformats.org/drawingml/2006/main">
+            <a:r>
+              <a:t/>
+            </a:r>
+          </a:p>
+          <a:p xmlns:a="http://schemas.openxmlformats.org/drawingml/2006/main">
+            <a:r>
+              <a:t>“Woven makes shopping through AI simple enough to use—and controlled enough to trust.”</a:t>
+            </a:r>
+          </a:p>
+          <a:p xmlns:a="http://schemas.openxmlformats.org/drawingml/2006/main">
+            <a:r>
+              <a:t/>
+            </a:r>
+          </a:p>
+          <a:p xmlns:a="http://schemas.openxmlformats.org/drawingml/2006/main">
+            <a:r>
+              <a:t>CLOSE</a:t>
+            </a:r>
+          </a:p>
+          <a:p xmlns:a="http://schemas.openxmlformats.org/drawingml/2006/main">
+            <a:r>
+              <a:t>Ask once. Review once. Confirm once.</a:t>
+            </a:r>
+          </a:p>
+          <a:p xmlns:a="http://schemas.openxmlformats.org/drawingml/2006/main">
+            <a:r>
+              <a:t/>
+            </a:r>
+          </a:p>
+          <a:p xmlns:a="http://schemas.openxmlformats.org/drawingml/2006/main">
+            <a:r>
+              <a:t>STAGE CUE</a:t>
+            </a:r>
+          </a:p>
+          <a:p xmlns:a="http://schemas.openxmlformats.org/drawingml/2006/main">
+            <a:r>
+              <a:t>End the three-minute pitch here. Slides 8–11 are Q&amp;A backups only.</a:t>
+            </a:r>
+          </a:p>
+          <a:p xmlns:a="http://schemas.openxmlformats.org/drawingml/2006/main">
+            <a:r>
+              <a:t/>
+            </a:r>
+          </a:p>
+          <a:p xmlns:a="http://schemas.openxmlformats.org/drawingml/2006/main">
+            <a:r>
               <a:t>[Sources]</a:t>
             </a:r>
           </a:p>
           <a:p xmlns:a="http://schemas.openxmlformats.org/drawingml/2006/main">
             <a:r>
-              <a:t>- SCRIPT.md — Closing</a:t>
+              <a:t>- script.md — 2:35–3:00 closing</a:t>
             </a:r>
           </a:p>
           <a:p xmlns:a="http://schemas.openxmlformats.org/drawingml/2006/main">
@@ -1227,7 +1762,7 @@
           </a:p>
           <a:p xmlns:a="http://schemas.openxmlformats.org/drawingml/2006/main">
             <a:r>
-              <a:t>- docs/DEVPOST_SUBMISSION.md — Pitch</a:t>
+              <a:t>- docs/DEVPOST_SUBMISSION.md — Three-minute judge demo</a:t>
             </a:r>
           </a:p>
         </p:txBody>
@@ -1297,7 +1832,12 @@
           <a:lstStyle xmlns:a="http://schemas.openxmlformats.org/drawingml/2006/main"/>
           <a:p xmlns:a="http://schemas.openxmlformats.org/drawingml/2006/main">
             <a:r>
-              <a:t>Use this only in Q&amp;A. The working prototype includes cart construction, MCP tools and UI, exact expiring checkout terms, direct confirmation, idempotency, merchant operations, failure scenarios, and an audit trail.</a:t>
+              <a:t>USE IN Q&amp;A — WHAT IS REAL</a:t>
+            </a:r>
+          </a:p>
+          <a:p xmlns:a="http://schemas.openxmlformats.org/drawingml/2006/main">
+            <a:r>
+              <a:t>The working prototype includes the MCP App and browser fallback, complete one-merchant carts, compatibility and budget proof, exact expiring checkout terms, direct confirmation, idempotency, merchant operations, failure scenarios, and an audit trail.</a:t>
             </a:r>
           </a:p>
           <a:p xmlns:a="http://schemas.openxmlformats.org/drawingml/2006/main">
@@ -1307,12 +1847,27 @@
           </a:p>
           <a:p xmlns:a="http://schemas.openxmlformats.org/drawingml/2006/main">
             <a:r>
+              <a:t>JUDGE ANSWER</a:t>
+            </a:r>
+          </a:p>
+          <a:p xmlns:a="http://schemas.openxmlformats.org/drawingml/2006/main">
+            <a:r>
+              <a:t>“The core journey is working end to end with seeded demo inventory and a simulated payment boundary. The primary product is the MCP App; /demo is the same backend over HTTP for stage reliability.”</a:t>
+            </a:r>
+          </a:p>
+          <a:p xmlns:a="http://schemas.openxmlformats.org/drawingml/2006/main">
+            <a:r>
+              <a:t/>
+            </a:r>
+          </a:p>
+          <a:p xmlns:a="http://schemas.openxmlformats.org/drawingml/2006/main">
+            <a:r>
               <a:t>[Sources]</a:t>
             </a:r>
           </a:p>
           <a:p xmlns:a="http://schemas.openxmlformats.org/drawingml/2006/main">
             <a:r>
-              <a:t>- README.md — What is implemented</a:t>
+              <a:t>- README.md — Implemented surfaces and workflow</a:t>
             </a:r>
           </a:p>
           <a:p xmlns:a="http://schemas.openxmlformats.org/drawingml/2006/main">
@@ -1392,7 +1947,12 @@
           <a:lstStyle xmlns:a="http://schemas.openxmlformats.org/drawingml/2006/main"/>
           <a:p xmlns:a="http://schemas.openxmlformats.org/drawingml/2006/main">
             <a:r>
-              <a:t>Use this when judges ask what is simulated. Inventory and pickup are seeded. Identity is a product direction, not a live feature. Visa approval, decline and reversal are simulated. The prototype accepts no card data and makes no Visa partnership claim.</a:t>
+              <a:t>USE IN Q&amp;A — WHAT IS SIMULATED</a:t>
+            </a:r>
+          </a:p>
+          <a:p xmlns:a="http://schemas.openxmlformats.org/drawingml/2006/main">
+            <a:r>
+              <a:t>Inventory and pickup estimates are seeded. Identity verification is a planned product direction, not a live feature. Visa approval, decline, and reversal are simulated. No Visa account is accessed, no payment credentials are collected, and no live charge or partnership is claimed.</a:t>
             </a:r>
           </a:p>
           <a:p xmlns:a="http://schemas.openxmlformats.org/drawingml/2006/main">
@@ -1402,6 +1962,21 @@
           </a:p>
           <a:p xmlns:a="http://schemas.openxmlformats.org/drawingml/2006/main">
             <a:r>
+              <a:t>JUDGE ANSWER</a:t>
+            </a:r>
+          </a:p>
+          <a:p xmlns:a="http://schemas.openxmlformats.org/drawingml/2006/main">
+            <a:r>
+              <a:t>“The trust boundary is explicit: the working product binds exact terms and requires direct confirmation; identity is next, and the payment rail is clearly simulated.”</a:t>
+            </a:r>
+          </a:p>
+          <a:p xmlns:a="http://schemas.openxmlformats.org/drawingml/2006/main">
+            <a:r>
+              <a:t/>
+            </a:r>
+          </a:p>
+          <a:p xmlns:a="http://schemas.openxmlformats.org/drawingml/2006/main">
+            <a:r>
               <a:t>[Sources]</a:t>
             </a:r>
           </a:p>
@@ -1412,7 +1987,7 @@
           </a:p>
           <a:p xmlns:a="http://schemas.openxmlformats.org/drawingml/2006/main">
             <a:r>
-              <a:t>- SCRIPT.md — Truth guardrails</a:t>
+              <a:t>- script.md — Truth guardrails</a:t>
             </a:r>
           </a:p>
           <a:p xmlns:a="http://schemas.openxmlformats.org/drawingml/2006/main">
@@ -1485,7 +2060,7 @@
   </p:cSld>
   <p:clrMap bg1="lt1" tx1="dk1" bg2="lt2" tx2="dk2" accent1="accent1" accent2="accent2" accent3="accent3" accent4="accent4" accent5="accent5" accent6="accent6" hlink="hlink" folHlink="folHlink"/>
   <p:sldLayoutIdLst>
-    <p:sldLayoutId xmlns:r="http://schemas.openxmlformats.org/officeDocument/2006/relationships" id="2147483649" r:id="Rf952ab71b1574858"/>
+    <p:sldLayoutId xmlns:r="http://schemas.openxmlformats.org/officeDocument/2006/relationships" id="2147483649" r:id="R02831dc36adb413d"/>
   </p:sldLayoutIdLst>
   <p:txStyles>
     <p:titleStyle>
@@ -2423,222 +2998,200 @@
           <a:fontRef xmlns:a="http://schemas.openxmlformats.org/drawingml/2006/main" idx="major"/>
         </p:style>
       </p:sp>
+      <p:sp>
+        <p:nvSpPr>
+          <p:cNvPr id="7" name="closing-boundary">
+            <a:extLst xmlns:a="http://schemas.openxmlformats.org/drawingml/2006/main">
+              <a:ext uri="{FF2B5EF4-FFF2-40B4-BE49-F238E27FC236}">
+                <a16:creationId xmlns:a16="http://schemas.microsoft.com/office/drawing/2014/main" id="{F366E3E1-58EC-4B9E-85AC-84B9FDF83536}"/>
+              </a:ext>
+            </a:extLst>
+          </p:cNvPr>
+          <p:cNvSpPr>
+            <a:spLocks xmlns:a="http://schemas.openxmlformats.org/drawingml/2006/main" noGrp="1"/>
+          </p:cNvSpPr>
+          <p:nvPr/>
+        </p:nvSpPr>
+        <p:spPr>
+          <a:xfrm xmlns:a="http://schemas.openxmlformats.org/drawingml/2006/main">
+            <a:off x="8401050" y="6572250"/>
+            <a:ext cx="5334000" cy="247650"/>
+          </a:xfrm>
+          <a:prstGeom xmlns:a="http://schemas.openxmlformats.org/drawingml/2006/main" prst="rect">
+            <a:avLst/>
+          </a:prstGeom>
+          <a:noFill xmlns:a="http://schemas.openxmlformats.org/drawingml/2006/main"/>
+          <a:ln xmlns:a="http://schemas.openxmlformats.org/drawingml/2006/main" w="0">
+            <a:noFill/>
+            <a:prstDash val="solid"/>
+          </a:ln>
+        </p:spPr>
+        <p:txBody>
+          <a:bodyPr xmlns:a="http://schemas.openxmlformats.org/drawingml/2006/main" wrap="square" lIns="0" tIns="0" rIns="0" bIns="0">
+            <a:noAutofit/>
+          </a:bodyPr>
+          <a:lstStyle xmlns:a="http://schemas.openxmlformats.org/drawingml/2006/main"/>
+          <a:p xmlns:a="http://schemas.openxmlformats.org/drawingml/2006/main">
+            <a:pPr algn="ctr">
+              <a:buNone/>
+              <a:defRPr sz="1200" b="1">
+                <a:solidFill>
+                  <a:srgbClr val="B7F522"/>
+                </a:solidFill>
+                <a:latin typeface="Menlo"/>
+                <a:ea typeface="Menlo"/>
+                <a:cs typeface="Menlo"/>
+              </a:defRPr>
+            </a:pPr>
+            <a:r>
+              <a:rPr sz="1200" b="1">
+                <a:solidFill>
+                  <a:srgbClr val="B7F522"/>
+                </a:solidFill>
+                <a:latin typeface="Menlo"/>
+                <a:ea typeface="Menlo"/>
+                <a:cs typeface="Menlo"/>
+              </a:rPr>
+              <a:t>WORKING MCP APP · SEEDED DEMO DATA</a:t>
+            </a:r>
+          </a:p>
+        </p:txBody>
+      </p:sp>
+      <p:sp>
+        <p:nvSpPr>
+          <p:cNvPr id="8" name="footer-label-9">
+            <a:extLst xmlns:a="http://schemas.openxmlformats.org/drawingml/2006/main">
+              <a:ext uri="{FF2B5EF4-FFF2-40B4-BE49-F238E27FC236}">
+                <a16:creationId xmlns:a16="http://schemas.microsoft.com/office/drawing/2014/main" id="{D2647B79-80DB-4F8E-8A2F-05922DDDED74}"/>
+              </a:ext>
+            </a:extLst>
+          </p:cNvPr>
+          <p:cNvSpPr>
+            <a:spLocks xmlns:a="http://schemas.openxmlformats.org/drawingml/2006/main" noGrp="1"/>
+          </p:cNvSpPr>
+          <p:nvPr/>
+        </p:nvSpPr>
+        <p:spPr>
+          <a:xfrm xmlns:a="http://schemas.openxmlformats.org/drawingml/2006/main">
+            <a:off x="838200" y="8020050"/>
+            <a:ext cx="5334000" cy="228600"/>
+          </a:xfrm>
+          <a:prstGeom xmlns:a="http://schemas.openxmlformats.org/drawingml/2006/main" prst="rect">
+            <a:avLst/>
+          </a:prstGeom>
+          <a:noFill xmlns:a="http://schemas.openxmlformats.org/drawingml/2006/main"/>
+          <a:ln xmlns:a="http://schemas.openxmlformats.org/drawingml/2006/main" w="0">
+            <a:noFill/>
+            <a:prstDash val="solid"/>
+          </a:ln>
+        </p:spPr>
+        <p:txBody>
+          <a:bodyPr xmlns:a="http://schemas.openxmlformats.org/drawingml/2006/main" wrap="square" lIns="0" tIns="0" rIns="0" bIns="0">
+            <a:noAutofit/>
+          </a:bodyPr>
+          <a:lstStyle xmlns:a="http://schemas.openxmlformats.org/drawingml/2006/main"/>
+          <a:p xmlns:a="http://schemas.openxmlformats.org/drawingml/2006/main">
+            <a:pPr>
+              <a:buNone/>
+              <a:defRPr sz="1200" b="1">
+                <a:solidFill>
+                  <a:srgbClr val="DCECE5"/>
+                </a:solidFill>
+                <a:latin typeface="Menlo"/>
+                <a:ea typeface="Menlo"/>
+                <a:cs typeface="Menlo"/>
+              </a:defRPr>
+            </a:pPr>
+            <a:r>
+              <a:rPr sz="1200" b="1">
+                <a:solidFill>
+                  <a:srgbClr val="DCECE5"/>
+                </a:solidFill>
+                <a:latin typeface="Menlo"/>
+                <a:ea typeface="Menlo"/>
+                <a:cs typeface="Menlo"/>
+              </a:rPr>
+              <a:t>WOVEN  /  LIFEHACK 2026</a:t>
+            </a:r>
+          </a:p>
+        </p:txBody>
+      </p:sp>
+      <p:sp>
+        <p:nvSpPr>
+          <p:cNvPr id="9" name="footer-number-9">
+            <a:extLst xmlns:a="http://schemas.openxmlformats.org/drawingml/2006/main">
+              <a:ext uri="{FF2B5EF4-FFF2-40B4-BE49-F238E27FC236}">
+                <a16:creationId xmlns:a16="http://schemas.microsoft.com/office/drawing/2014/main" id="{62445167-1406-4B61-A1CF-80F49583F03F}"/>
+              </a:ext>
+            </a:extLst>
+          </p:cNvPr>
+          <p:cNvSpPr>
+            <a:spLocks xmlns:a="http://schemas.openxmlformats.org/drawingml/2006/main" noGrp="1"/>
+          </p:cNvSpPr>
+          <p:nvPr/>
+        </p:nvSpPr>
+        <p:spPr>
+          <a:xfrm xmlns:a="http://schemas.openxmlformats.org/drawingml/2006/main">
+            <a:off x="13620750" y="8001000"/>
+            <a:ext cx="762000" cy="247650"/>
+          </a:xfrm>
+          <a:prstGeom xmlns:a="http://schemas.openxmlformats.org/drawingml/2006/main" prst="rect">
+            <a:avLst/>
+          </a:prstGeom>
+          <a:noFill xmlns:a="http://schemas.openxmlformats.org/drawingml/2006/main"/>
+          <a:ln xmlns:a="http://schemas.openxmlformats.org/drawingml/2006/main" w="0">
+            <a:noFill/>
+            <a:prstDash val="solid"/>
+          </a:ln>
+        </p:spPr>
+        <p:txBody>
+          <a:bodyPr xmlns:a="http://schemas.openxmlformats.org/drawingml/2006/main" wrap="square" lIns="0" tIns="0" rIns="0" bIns="0">
+            <a:noAutofit/>
+          </a:bodyPr>
+          <a:lstStyle xmlns:a="http://schemas.openxmlformats.org/drawingml/2006/main"/>
+          <a:p xmlns:a="http://schemas.openxmlformats.org/drawingml/2006/main">
+            <a:pPr algn="r">
+              <a:buNone/>
+              <a:defRPr sz="1350" b="1">
+                <a:solidFill>
+                  <a:srgbClr val="DCECE5"/>
+                </a:solidFill>
+                <a:latin typeface="Menlo"/>
+                <a:ea typeface="Menlo"/>
+                <a:cs typeface="Menlo"/>
+              </a:defRPr>
+            </a:pPr>
+            <a:r>
+              <a:rPr sz="1350" b="1">
+                <a:solidFill>
+                  <a:srgbClr val="DCECE5"/>
+                </a:solidFill>
+                <a:latin typeface="Menlo"/>
+                <a:ea typeface="Menlo"/>
+                <a:cs typeface="Menlo"/>
+              </a:rPr>
+              <a:t>01</a:t>
+            </a:r>
+          </a:p>
+        </p:txBody>
+      </p:sp>
       <p:pic>
         <p:nvPicPr>
-          <p:cNvPr id="18" name=""/>
+          <p:cNvPr id="21" name=""/>
           <p:cNvPicPr>
             <a:picLocks xmlns:a="http://schemas.openxmlformats.org/drawingml/2006/main" noChangeAspect="1"/>
           </p:cNvPicPr>
           <p:nvPr/>
         </p:nvPicPr>
         <p:blipFill>
-          <a:blip xmlns:r="http://schemas.openxmlformats.org/officeDocument/2006/relationships" xmlns:a="http://schemas.openxmlformats.org/drawingml/2006/main" r:embed="R6927022f668944f0"/>
-          <a:stretch xmlns:a="http://schemas.openxmlformats.org/drawingml/2006/main"/>
-        </p:blipFill>
-        <p:spPr>
-          <a:xfrm xmlns:a="http://schemas.openxmlformats.org/drawingml/2006/main" flipH="0" flipV="0">
-            <a:off x="7715250" y="2477691"/>
-            <a:ext cx="6667500" cy="3750469"/>
-          </a:xfrm>
-          <a:prstGeom xmlns:a="http://schemas.openxmlformats.org/drawingml/2006/main" prst="roundRect">
-            <a:avLst/>
-          </a:prstGeom>
-        </p:spPr>
-      </p:pic>
-      <p:sp>
-        <p:nvSpPr>
-          <p:cNvPr id="7" name="closing-boundary">
-            <a:extLst xmlns:a="http://schemas.openxmlformats.org/drawingml/2006/main">
-              <a:ext uri="{FF2B5EF4-FFF2-40B4-BE49-F238E27FC236}">
-                <a16:creationId xmlns:a16="http://schemas.microsoft.com/office/drawing/2014/main" id="{F366E3E1-58EC-4B9E-85AC-84B9FDF83536}"/>
-              </a:ext>
-            </a:extLst>
-          </p:cNvPr>
-          <p:cNvSpPr>
-            <a:spLocks xmlns:a="http://schemas.openxmlformats.org/drawingml/2006/main" noGrp="1"/>
-          </p:cNvSpPr>
-          <p:nvPr/>
-        </p:nvSpPr>
-        <p:spPr>
-          <a:xfrm xmlns:a="http://schemas.openxmlformats.org/drawingml/2006/main">
-            <a:off x="8401050" y="6572250"/>
-            <a:ext cx="5334000" cy="247650"/>
-          </a:xfrm>
-          <a:prstGeom xmlns:a="http://schemas.openxmlformats.org/drawingml/2006/main" prst="rect">
-            <a:avLst/>
-          </a:prstGeom>
-          <a:noFill xmlns:a="http://schemas.openxmlformats.org/drawingml/2006/main"/>
-          <a:ln xmlns:a="http://schemas.openxmlformats.org/drawingml/2006/main" w="0">
-            <a:noFill/>
-            <a:prstDash val="solid"/>
-          </a:ln>
-        </p:spPr>
-        <p:txBody>
-          <a:bodyPr xmlns:a="http://schemas.openxmlformats.org/drawingml/2006/main" wrap="square" lIns="0" tIns="0" rIns="0" bIns="0">
-            <a:noAutofit/>
-          </a:bodyPr>
-          <a:lstStyle xmlns:a="http://schemas.openxmlformats.org/drawingml/2006/main"/>
-          <a:p xmlns:a="http://schemas.openxmlformats.org/drawingml/2006/main">
-            <a:pPr algn="ctr">
-              <a:buNone/>
-              <a:defRPr sz="1200" b="1">
-                <a:solidFill>
-                  <a:srgbClr val="B7F522"/>
-                </a:solidFill>
-                <a:latin typeface="Menlo"/>
-                <a:ea typeface="Menlo"/>
-                <a:cs typeface="Menlo"/>
-              </a:defRPr>
-            </a:pPr>
-            <a:r>
-              <a:rPr sz="1200" b="1">
-                <a:solidFill>
-                  <a:srgbClr val="B7F522"/>
-                </a:solidFill>
-                <a:latin typeface="Menlo"/>
-                <a:ea typeface="Menlo"/>
-                <a:cs typeface="Menlo"/>
-              </a:rPr>
-              <a:t>WORKING MCP APP · SEEDED DEMO DATA</a:t>
-            </a:r>
-          </a:p>
-        </p:txBody>
-      </p:sp>
-      <p:sp>
-        <p:nvSpPr>
-          <p:cNvPr id="8" name="footer-label-9">
-            <a:extLst xmlns:a="http://schemas.openxmlformats.org/drawingml/2006/main">
-              <a:ext uri="{FF2B5EF4-FFF2-40B4-BE49-F238E27FC236}">
-                <a16:creationId xmlns:a16="http://schemas.microsoft.com/office/drawing/2014/main" id="{D2647B79-80DB-4F8E-8A2F-05922DDDED74}"/>
-              </a:ext>
-            </a:extLst>
-          </p:cNvPr>
-          <p:cNvSpPr>
-            <a:spLocks xmlns:a="http://schemas.openxmlformats.org/drawingml/2006/main" noGrp="1"/>
-          </p:cNvSpPr>
-          <p:nvPr/>
-        </p:nvSpPr>
-        <p:spPr>
-          <a:xfrm xmlns:a="http://schemas.openxmlformats.org/drawingml/2006/main">
-            <a:off x="838200" y="8020050"/>
-            <a:ext cx="5334000" cy="228600"/>
-          </a:xfrm>
-          <a:prstGeom xmlns:a="http://schemas.openxmlformats.org/drawingml/2006/main" prst="rect">
-            <a:avLst/>
-          </a:prstGeom>
-          <a:noFill xmlns:a="http://schemas.openxmlformats.org/drawingml/2006/main"/>
-          <a:ln xmlns:a="http://schemas.openxmlformats.org/drawingml/2006/main" w="0">
-            <a:noFill/>
-            <a:prstDash val="solid"/>
-          </a:ln>
-        </p:spPr>
-        <p:txBody>
-          <a:bodyPr xmlns:a="http://schemas.openxmlformats.org/drawingml/2006/main" wrap="square" lIns="0" tIns="0" rIns="0" bIns="0">
-            <a:noAutofit/>
-          </a:bodyPr>
-          <a:lstStyle xmlns:a="http://schemas.openxmlformats.org/drawingml/2006/main"/>
-          <a:p xmlns:a="http://schemas.openxmlformats.org/drawingml/2006/main">
-            <a:pPr>
-              <a:buNone/>
-              <a:defRPr sz="1200" b="1">
-                <a:solidFill>
-                  <a:srgbClr val="DCECE5"/>
-                </a:solidFill>
-                <a:latin typeface="Menlo"/>
-                <a:ea typeface="Menlo"/>
-                <a:cs typeface="Menlo"/>
-              </a:defRPr>
-            </a:pPr>
-            <a:r>
-              <a:rPr sz="1200" b="1">
-                <a:solidFill>
-                  <a:srgbClr val="DCECE5"/>
-                </a:solidFill>
-                <a:latin typeface="Menlo"/>
-                <a:ea typeface="Menlo"/>
-                <a:cs typeface="Menlo"/>
-              </a:rPr>
-              <a:t>WOVEN  /  LIFEHACK 2026</a:t>
-            </a:r>
-          </a:p>
-        </p:txBody>
-      </p:sp>
-      <p:sp>
-        <p:nvSpPr>
-          <p:cNvPr id="9" name="footer-number-9">
-            <a:extLst xmlns:a="http://schemas.openxmlformats.org/drawingml/2006/main">
-              <a:ext uri="{FF2B5EF4-FFF2-40B4-BE49-F238E27FC236}">
-                <a16:creationId xmlns:a16="http://schemas.microsoft.com/office/drawing/2014/main" id="{62445167-1406-4B61-A1CF-80F49583F03F}"/>
-              </a:ext>
-            </a:extLst>
-          </p:cNvPr>
-          <p:cNvSpPr>
-            <a:spLocks xmlns:a="http://schemas.openxmlformats.org/drawingml/2006/main" noGrp="1"/>
-          </p:cNvSpPr>
-          <p:nvPr/>
-        </p:nvSpPr>
-        <p:spPr>
-          <a:xfrm xmlns:a="http://schemas.openxmlformats.org/drawingml/2006/main">
-            <a:off x="13620750" y="8001000"/>
-            <a:ext cx="762000" cy="247650"/>
-          </a:xfrm>
-          <a:prstGeom xmlns:a="http://schemas.openxmlformats.org/drawingml/2006/main" prst="rect">
-            <a:avLst/>
-          </a:prstGeom>
-          <a:noFill xmlns:a="http://schemas.openxmlformats.org/drawingml/2006/main"/>
-          <a:ln xmlns:a="http://schemas.openxmlformats.org/drawingml/2006/main" w="0">
-            <a:noFill/>
-            <a:prstDash val="solid"/>
-          </a:ln>
-        </p:spPr>
-        <p:txBody>
-          <a:bodyPr xmlns:a="http://schemas.openxmlformats.org/drawingml/2006/main" wrap="square" lIns="0" tIns="0" rIns="0" bIns="0">
-            <a:noAutofit/>
-          </a:bodyPr>
-          <a:lstStyle xmlns:a="http://schemas.openxmlformats.org/drawingml/2006/main"/>
-          <a:p xmlns:a="http://schemas.openxmlformats.org/drawingml/2006/main">
-            <a:pPr algn="r">
-              <a:buNone/>
-              <a:defRPr sz="1350" b="1">
-                <a:solidFill>
-                  <a:srgbClr val="DCECE5"/>
-                </a:solidFill>
-                <a:latin typeface="Menlo"/>
-                <a:ea typeface="Menlo"/>
-                <a:cs typeface="Menlo"/>
-              </a:defRPr>
-            </a:pPr>
-            <a:r>
-              <a:rPr sz="1350" b="1">
-                <a:solidFill>
-                  <a:srgbClr val="DCECE5"/>
-                </a:solidFill>
-                <a:latin typeface="Menlo"/>
-                <a:ea typeface="Menlo"/>
-                <a:cs typeface="Menlo"/>
-              </a:rPr>
-              <a:t>01</a:t>
-            </a:r>
-          </a:p>
-        </p:txBody>
-      </p:sp>
-      <p:pic>
-        <p:nvPicPr>
-          <p:cNvPr id="22" name=""/>
-          <p:cNvPicPr>
-            <a:picLocks xmlns:a="http://schemas.openxmlformats.org/drawingml/2006/main" noChangeAspect="1"/>
-          </p:cNvPicPr>
-          <p:nvPr/>
-        </p:nvPicPr>
-        <p:blipFill>
-          <a:blip xmlns:r="http://schemas.openxmlformats.org/officeDocument/2006/relationships" xmlns:a="http://schemas.openxmlformats.org/drawingml/2006/main" r:embed="Rd1d0da75597c4e87"/>
-          <a:srcRect xmlns:a="http://schemas.openxmlformats.org/drawingml/2006/main" l="0" t="0" r="0" b="0"/>
+          <a:blip xmlns:r="http://schemas.openxmlformats.org/officeDocument/2006/relationships" xmlns:a="http://schemas.openxmlformats.org/drawingml/2006/main" r:embed="R64deff9c5da942be"/>
+          <a:srcRect xmlns:a="http://schemas.openxmlformats.org/drawingml/2006/main" l="12000" t="0" r="2000" b="0"/>
           <a:stretch xmlns:a="http://schemas.openxmlformats.org/drawingml/2006/main">
             <a:fillRect l="0" t="0" r="0" b="0"/>
           </a:stretch>
         </p:blipFill>
         <p:spPr>
-          <a:xfrm xmlns:a="http://schemas.openxmlformats.org/drawingml/2006/main">
+          <a:xfrm xmlns:a="http://schemas.openxmlformats.org/drawingml/2006/main" flipH="0" flipV="0">
             <a:off x="7715250" y="2477691"/>
             <a:ext cx="6667500" cy="3750469"/>
           </a:xfrm>
@@ -2678,7 +3231,7 @@
           <p:nvPr/>
         </p:nvPicPr>
         <p:blipFill>
-          <a:blip xmlns:r="http://schemas.openxmlformats.org/officeDocument/2006/relationships" xmlns:a="http://schemas.openxmlformats.org/drawingml/2006/main" r:embed="R9909b5a239234798"/>
+          <a:blip xmlns:r="http://schemas.openxmlformats.org/officeDocument/2006/relationships" xmlns:a="http://schemas.openxmlformats.org/drawingml/2006/main" r:embed="R9bffdb01cf344feb"/>
           <a:srcRect xmlns:a="http://schemas.openxmlformats.org/drawingml/2006/main" l="0" t="0" r="0" b="0"/>
           <a:stretch xmlns:a="http://schemas.openxmlformats.org/drawingml/2006/main">
             <a:fillRect l="0" t="0" r="0" b="0"/>
@@ -3136,7 +3689,7 @@
           <p:nvPr/>
         </p:nvPicPr>
         <p:blipFill>
-          <a:blip xmlns:r="http://schemas.openxmlformats.org/officeDocument/2006/relationships" xmlns:a="http://schemas.openxmlformats.org/drawingml/2006/main" r:embed="R0ec13a034f654de9"/>
+          <a:blip xmlns:r="http://schemas.openxmlformats.org/officeDocument/2006/relationships" xmlns:a="http://schemas.openxmlformats.org/drawingml/2006/main" r:embed="R3785bd862f514d5a"/>
           <a:stretch xmlns:a="http://schemas.openxmlformats.org/drawingml/2006/main"/>
         </p:blipFill>
         <p:spPr>
@@ -4783,7 +5336,7 @@
           <p:nvPr/>
         </p:nvPicPr>
         <p:blipFill>
-          <a:blip xmlns:r="http://schemas.openxmlformats.org/officeDocument/2006/relationships" xmlns:a="http://schemas.openxmlformats.org/drawingml/2006/main" r:embed="R32925bf3c169406a"/>
+          <a:blip xmlns:r="http://schemas.openxmlformats.org/officeDocument/2006/relationships" xmlns:a="http://schemas.openxmlformats.org/drawingml/2006/main" r:embed="R815bc04db61343b4"/>
           <a:stretch xmlns:a="http://schemas.openxmlformats.org/drawingml/2006/main"/>
         </p:blipFill>
         <p:spPr>
@@ -6669,7 +7222,7 @@
                 <a:ea typeface="Avenir Next"/>
                 <a:cs typeface="Avenir Next"/>
               </a:rPr>
-              <a:t>WORKING — one human click, then a simulated Visa result.</a:t>
+              <a:t>WORKING — one click, then simulated Visa authorization.</a:t>
             </a:r>
           </a:p>
         </p:txBody>
@@ -7462,7 +8015,7 @@
           <p:nvPr/>
         </p:nvPicPr>
         <p:blipFill>
-          <a:blip xmlns:r="http://schemas.openxmlformats.org/officeDocument/2006/relationships" xmlns:a="http://schemas.openxmlformats.org/drawingml/2006/main" r:embed="Ra2ccd8e92fed4c21"/>
+          <a:blip xmlns:r="http://schemas.openxmlformats.org/officeDocument/2006/relationships" xmlns:a="http://schemas.openxmlformats.org/drawingml/2006/main" r:embed="Rf6c24c0f2c7d4d70"/>
           <a:stretch xmlns:a="http://schemas.openxmlformats.org/drawingml/2006/main"/>
         </p:blipFill>
         <p:spPr>
@@ -8112,7 +8665,7 @@
           <p:nvPr/>
         </p:nvPicPr>
         <p:blipFill>
-          <a:blip xmlns:r="http://schemas.openxmlformats.org/officeDocument/2006/relationships" xmlns:a="http://schemas.openxmlformats.org/drawingml/2006/main" r:embed="Re4b6b5bc752e42e0"/>
+          <a:blip xmlns:r="http://schemas.openxmlformats.org/officeDocument/2006/relationships" xmlns:a="http://schemas.openxmlformats.org/drawingml/2006/main" r:embed="R442128613b45476b"/>
           <a:stretch xmlns:a="http://schemas.openxmlformats.org/drawingml/2006/main"/>
         </p:blipFill>
         <p:spPr>
@@ -8179,7 +8732,7 @@
                 <a:ea typeface="Menlo"/>
                 <a:cs typeface="Menlo"/>
               </a:rPr>
-              <a:t>IDENTITY DIRECTION + VISA RESULT · CLEARLY SIMULATED</a:t>
+              <a:t>IDENTITY PLANNED · VISA AUTHORIZATION SIMULATED</a:t>
             </a:r>
           </a:p>
         </p:txBody>

</xml_diff>

<commit_message>
docs(feat): adopt product-style explainers in judge deck and Devpost
Swap the backup architecture slide's full-bleed image to
woven-system-architecture.png and add a matching full-bleed backup slide
for woven-how-it-works.png (deck is now 7 story + 5 backup slides). The
Devpost gallery rows 3 and 8 now upload the product-style explainers, the
README architecture figure follows, and the brand guide marks the
editorial user-flow/architecture renders as superseded variants.

Co-Authored-By: Claude Fable 5 <noreply@anthropic.com>
</commit_message>
<xml_diff>
--- a/docs/Woven-Hackathon-Pitch.pptx
+++ b/docs/Woven-Hackathon-Pitch.pptx
@@ -17,6 +17,7 @@
     <p:sldId xmlns:r="http://schemas.openxmlformats.org/officeDocument/2006/relationships" id="262" r:id="R7b5ce42f81a54f6f"/>
     <p:sldId xmlns:r="http://schemas.openxmlformats.org/officeDocument/2006/relationships" id="263" r:id="R42e87175a6a34fd9"/>
     <p:sldId xmlns:r="http://schemas.openxmlformats.org/officeDocument/2006/relationships" id="264" r:id="R37dfb12e7e61470d"/>
+    <p:sldId xmlns:r="http://schemas.openxmlformats.org/officeDocument/2006/relationships" id="267" r:id="Rab12cd34ef567801"/>
     <p:sldId xmlns:r="http://schemas.openxmlformats.org/officeDocument/2006/relationships" id="265" r:id="R43bbd7ed52b947d6"/>
     <p:sldId xmlns:r="http://schemas.openxmlformats.org/officeDocument/2006/relationships" id="266" r:id="R6026b644a94e4a72"/>
   </p:sldIdLst>
@@ -3830,6 +3831,53 @@
 </p:sld>
 </file>
 
+<file path=ppt/slides/slide12.xml><?xml version="1.0" encoding="utf-8"?>
+<p:sld xmlns:p="http://schemas.openxmlformats.org/presentationml/2006/main">
+  <p:cSld>
+    <p:spTree>
+      <p:nvGrpSpPr>
+        <p:cNvPr id="1" name=""/>
+        <p:cNvGrpSpPr/>
+        <p:nvPr/>
+      </p:nvGrpSpPr>
+      <p:grpSpPr>
+        <a:xfrm xmlns:a="http://schemas.openxmlformats.org/drawingml/2006/main"/>
+      </p:grpSpPr>
+      <p:pic>
+        <p:nvPicPr>
+          <p:cNvPr id="2" name=""/>
+          <p:cNvPicPr>
+            <a:picLocks xmlns:a="http://schemas.openxmlformats.org/drawingml/2006/main" noChangeAspect="1"/>
+          </p:cNvPicPr>
+          <p:nvPr/>
+        </p:nvPicPr>
+        <p:blipFill>
+          <a:blip xmlns:r="http://schemas.openxmlformats.org/officeDocument/2006/relationships" xmlns:a="http://schemas.openxmlformats.org/drawingml/2006/main" r:embed="R9bffdb01cf344feb"/>
+          <a:srcRect xmlns:a="http://schemas.openxmlformats.org/drawingml/2006/main" l="0" t="0" r="0" b="0"/>
+          <a:stretch xmlns:a="http://schemas.openxmlformats.org/drawingml/2006/main">
+            <a:fillRect l="0" t="0" r="0" b="0"/>
+          </a:stretch>
+        </p:blipFill>
+        <p:spPr>
+          <a:xfrm xmlns:a="http://schemas.openxmlformats.org/drawingml/2006/main" flipH="0" flipV="0">
+            <a:off x="0" y="0"/>
+            <a:ext cx="15240000" cy="8572500"/>
+          </a:xfrm>
+          <a:prstGeom xmlns:a="http://schemas.openxmlformats.org/drawingml/2006/main" prst="rect">
+            <a:avLst/>
+          </a:prstGeom>
+        </p:spPr>
+      </p:pic>
+    </p:spTree>
+    <p:extLst>
+      <p:ext uri="{BB962C8B-B14F-4D97-AF65-F5344CB8AC3E}">
+        <p14:creationId xmlns:p14="http://schemas.microsoft.com/office/powerpoint/2010/main" val="614777387"/>
+      </p:ext>
+    </p:extLst>
+  </p:cSld>
+</p:sld>
+</file>
+
 <file path=ppt/slides/slide2.xml><?xml version="1.0" encoding="utf-8"?>
 <p:sld xmlns:p="http://schemas.openxmlformats.org/presentationml/2006/main">
   <p:cSld>

</xml_diff>

<commit_message>
docs(feat): add under-the-hood deep-dive explainer
Trace one Codex request end to end in the product UI style: eight steps
from the model's start_mission call through app-only tools, the widget-
only nonce, and the checkout guard to the receipt, with the real payload
shapes and failure gates alongside. Ship it as gallery row 9, a new
full-bleed backup slide after how-it-works (deck is now 7 story + 6
backup), and an editable HTML source.

Co-Authored-By: Claude Fable 5 <noreply@anthropic.com>
</commit_message>
<xml_diff>
--- a/docs/Woven-Hackathon-Pitch.pptx
+++ b/docs/Woven-Hackathon-Pitch.pptx
@@ -18,6 +18,7 @@
     <p:sldId xmlns:r="http://schemas.openxmlformats.org/officeDocument/2006/relationships" id="263" r:id="R42e87175a6a34fd9"/>
     <p:sldId xmlns:r="http://schemas.openxmlformats.org/officeDocument/2006/relationships" id="264" r:id="R37dfb12e7e61470d"/>
     <p:sldId xmlns:r="http://schemas.openxmlformats.org/officeDocument/2006/relationships" id="267" r:id="Rab12cd34ef567801"/>
+    <p:sldId xmlns:r="http://schemas.openxmlformats.org/officeDocument/2006/relationships" id="268" r:id="Rab12cd34ef567802"/>
     <p:sldId xmlns:r="http://schemas.openxmlformats.org/officeDocument/2006/relationships" id="265" r:id="R43bbd7ed52b947d6"/>
     <p:sldId xmlns:r="http://schemas.openxmlformats.org/officeDocument/2006/relationships" id="266" r:id="R6026b644a94e4a72"/>
   </p:sldIdLst>
@@ -3878,6 +3879,53 @@
 </p:sld>
 </file>
 
+<file path=ppt/slides/slide13.xml><?xml version="1.0" encoding="utf-8"?>
+<p:sld xmlns:p="http://schemas.openxmlformats.org/presentationml/2006/main">
+  <p:cSld>
+    <p:spTree>
+      <p:nvGrpSpPr>
+        <p:cNvPr id="1" name=""/>
+        <p:cNvGrpSpPr/>
+        <p:nvPr/>
+      </p:nvGrpSpPr>
+      <p:grpSpPr>
+        <a:xfrm xmlns:a="http://schemas.openxmlformats.org/drawingml/2006/main"/>
+      </p:grpSpPr>
+      <p:pic>
+        <p:nvPicPr>
+          <p:cNvPr id="2" name=""/>
+          <p:cNvPicPr>
+            <a:picLocks xmlns:a="http://schemas.openxmlformats.org/drawingml/2006/main" noChangeAspect="1"/>
+          </p:cNvPicPr>
+          <p:nvPr/>
+        </p:nvPicPr>
+        <p:blipFill>
+          <a:blip xmlns:r="http://schemas.openxmlformats.org/officeDocument/2006/relationships" xmlns:a="http://schemas.openxmlformats.org/drawingml/2006/main" r:embed="R9bffdb01cf344feb"/>
+          <a:srcRect xmlns:a="http://schemas.openxmlformats.org/drawingml/2006/main" l="0" t="0" r="0" b="0"/>
+          <a:stretch xmlns:a="http://schemas.openxmlformats.org/drawingml/2006/main">
+            <a:fillRect l="0" t="0" r="0" b="0"/>
+          </a:stretch>
+        </p:blipFill>
+        <p:spPr>
+          <a:xfrm xmlns:a="http://schemas.openxmlformats.org/drawingml/2006/main" flipH="0" flipV="0">
+            <a:off x="0" y="0"/>
+            <a:ext cx="15240000" cy="8572500"/>
+          </a:xfrm>
+          <a:prstGeom xmlns:a="http://schemas.openxmlformats.org/drawingml/2006/main" prst="rect">
+            <a:avLst/>
+          </a:prstGeom>
+        </p:spPr>
+      </p:pic>
+    </p:spTree>
+    <p:extLst>
+      <p:ext uri="{BB962C8B-B14F-4D97-AF65-F5344CB8AC3E}">
+        <p14:creationId xmlns:p14="http://schemas.microsoft.com/office/powerpoint/2010/main" val="614777387"/>
+      </p:ext>
+    </p:extLst>
+  </p:cSld>
+</p:sld>
+</file>
+
 <file path=ppt/slides/slide2.xml><?xml version="1.0" encoding="utf-8"?>
 <p:sld xmlns:p="http://schemas.openxmlformats.org/presentationml/2006/main">
   <p:cSld>

</xml_diff>

<commit_message>
fullstack(feat): add choice-driven verified checkout
Summary:
- replace the canonical demo with five complete camping-kit choices
- add comparison, preferences, pickup planning, and approved swaps
- bind checkout to demo identity and add signed receipt verification
- update merchant controls, plugin metadata, docs, deck, and media

Rationale:
- make Woven's multi-option decision flow visible inside the host UI
- keep recommendations, identity, confirmation, and receipts auditable
- align the working demo and submission material with shipped behavior

Tests:
- npm run check
- npm audit --audit-level=high
- desktop and mobile browser flow with zero console errors
</commit_message>
<xml_diff>
--- a/docs/Woven-Hackathon-Pitch.pptx
+++ b/docs/Woven-Hackathon-Pitch.pptx
@@ -2,25 +2,25 @@
 <file path=ppt/presentation.xml><?xml version="1.0" encoding="utf-8"?>
 <p:presentation xmlns:p="http://schemas.openxmlformats.org/presentationml/2006/main">
   <p:sldMasterIdLst>
-    <p:sldMasterId xmlns:r="http://schemas.openxmlformats.org/officeDocument/2006/relationships" id="2147483648" r:id="Rbd7b917bceef459a"/>
+    <p:sldMasterId xmlns:r="http://schemas.openxmlformats.org/officeDocument/2006/relationships" id="2147483648" r:id="Rb6a2fb069c8f4569"/>
   </p:sldMasterIdLst>
   <p:notesMasterIdLst>
-    <p:notesMasterId xmlns:r="http://schemas.openxmlformats.org/officeDocument/2006/relationships" r:id="Reb6cee3a506b43cf"/>
+    <p:notesMasterId xmlns:r="http://schemas.openxmlformats.org/officeDocument/2006/relationships" r:id="R5e20c70de6fc4b11"/>
   </p:notesMasterIdLst>
   <p:sldIdLst>
-    <p:sldId xmlns:r="http://schemas.openxmlformats.org/officeDocument/2006/relationships" id="256" r:id="R5326ca9495684228"/>
-    <p:sldId xmlns:r="http://schemas.openxmlformats.org/officeDocument/2006/relationships" id="257" r:id="R7129933df5f84180"/>
-    <p:sldId xmlns:r="http://schemas.openxmlformats.org/officeDocument/2006/relationships" id="258" r:id="Ree048974157b4473"/>
-    <p:sldId xmlns:r="http://schemas.openxmlformats.org/officeDocument/2006/relationships" id="259" r:id="Rfbc0c85f698f4fa6"/>
-    <p:sldId xmlns:r="http://schemas.openxmlformats.org/officeDocument/2006/relationships" id="260" r:id="R4aba994753af4d4e"/>
-    <p:sldId xmlns:r="http://schemas.openxmlformats.org/officeDocument/2006/relationships" id="261" r:id="R1293d76b0bb24c15"/>
-    <p:sldId xmlns:r="http://schemas.openxmlformats.org/officeDocument/2006/relationships" id="262" r:id="R7b5ce42f81a54f6f"/>
-    <p:sldId xmlns:r="http://schemas.openxmlformats.org/officeDocument/2006/relationships" id="263" r:id="R42e87175a6a34fd9"/>
-    <p:sldId xmlns:r="http://schemas.openxmlformats.org/officeDocument/2006/relationships" id="264" r:id="R37dfb12e7e61470d"/>
-    <p:sldId xmlns:r="http://schemas.openxmlformats.org/officeDocument/2006/relationships" id="267" r:id="Rab12cd34ef567801"/>
-    <p:sldId xmlns:r="http://schemas.openxmlformats.org/officeDocument/2006/relationships" id="268" r:id="Rab12cd34ef567802"/>
-    <p:sldId xmlns:r="http://schemas.openxmlformats.org/officeDocument/2006/relationships" id="265" r:id="R43bbd7ed52b947d6"/>
-    <p:sldId xmlns:r="http://schemas.openxmlformats.org/officeDocument/2006/relationships" id="266" r:id="R6026b644a94e4a72"/>
+    <p:sldId xmlns:r="http://schemas.openxmlformats.org/officeDocument/2006/relationships" id="256" r:id="R98d8ee8416cf4ffc"/>
+    <p:sldId xmlns:r="http://schemas.openxmlformats.org/officeDocument/2006/relationships" id="257" r:id="Ra4c4b5f632f94241"/>
+    <p:sldId xmlns:r="http://schemas.openxmlformats.org/officeDocument/2006/relationships" id="258" r:id="R7d208e6ec878474d"/>
+    <p:sldId xmlns:r="http://schemas.openxmlformats.org/officeDocument/2006/relationships" id="259" r:id="R89d593be9e6d4cf4"/>
+    <p:sldId xmlns:r="http://schemas.openxmlformats.org/officeDocument/2006/relationships" id="260" r:id="Rffeb4586ba4a41b9"/>
+    <p:sldId xmlns:r="http://schemas.openxmlformats.org/officeDocument/2006/relationships" id="261" r:id="Rb92cde8e70064a37"/>
+    <p:sldId xmlns:r="http://schemas.openxmlformats.org/officeDocument/2006/relationships" id="262" r:id="R4128fb2bf0704f25"/>
+    <p:sldId xmlns:r="http://schemas.openxmlformats.org/officeDocument/2006/relationships" id="263" r:id="R7f4b1f12886e40c8"/>
+    <p:sldId xmlns:r="http://schemas.openxmlformats.org/officeDocument/2006/relationships" id="264" r:id="Re341b4aa7f1547c4"/>
+    <p:sldId xmlns:r="http://schemas.openxmlformats.org/officeDocument/2006/relationships" id="265" r:id="R42eafb655d4e4181"/>
+    <p:sldId xmlns:r="http://schemas.openxmlformats.org/officeDocument/2006/relationships" id="266" r:id="Rab76a8025d71479b"/>
+    <p:sldId xmlns:r="http://schemas.openxmlformats.org/officeDocument/2006/relationships" id="267" r:id="R03200bae06724954"/>
+    <p:sldId xmlns:r="http://schemas.openxmlformats.org/officeDocument/2006/relationships" id="268" r:id="R17020387e05549b3"/>
   </p:sldIdLst>
   <p:sldSz cx="15240000" cy="8572500"/>
   <p:notesSz cx="6858000" cy="9144000"/>
@@ -602,56 +602,7 @@
         <p:txBody>
           <a:bodyPr xmlns:a="http://schemas.openxmlformats.org/drawingml/2006/main"/>
           <a:lstStyle xmlns:a="http://schemas.openxmlformats.org/drawingml/2006/main"/>
-          <a:p xmlns:a="http://schemas.openxmlformats.org/drawingml/2006/main">
-            <a:r>
-              <a:t>USE IN TECHNICAL Q&amp;A — ARCHITECTURE</a:t>
-            </a:r>
-          </a:p>
-          <a:p xmlns:a="http://schemas.openxmlformats.org/drawingml/2006/main">
-            <a:r>
-              <a:t>The ChatGPT or Codex host invokes Woven’s MCP tools. One Node.js service owns cart construction, checkout mandate binding, confirmation, order state, merchant operations, and the simulated Visa adapter. The browser demo is a second transport over the same backend, not a separate product.</a:t>
-            </a:r>
-          </a:p>
-          <a:p xmlns:a="http://schemas.openxmlformats.org/drawingml/2006/main">
-            <a:r>
-              <a:t/>
-            </a:r>
-          </a:p>
-          <a:p xmlns:a="http://schemas.openxmlformats.org/drawingml/2006/main">
-            <a:r>
-              <a:t>POINT TO</a:t>
-            </a:r>
-          </a:p>
-          <a:p xmlns:a="http://schemas.openxmlformats.org/drawingml/2006/main">
-            <a:r>
-              <a:t>MCP and HTTP transports. Mission and cart engine. Checkout guard. Node SQLite atomic inventory and order transaction. Simulated Visa boundary.</a:t>
-            </a:r>
-          </a:p>
-          <a:p xmlns:a="http://schemas.openxmlformats.org/drawingml/2006/main">
-            <a:r>
-              <a:t/>
-            </a:r>
-          </a:p>
-          <a:p xmlns:a="http://schemas.openxmlformats.org/drawingml/2006/main">
-            <a:r>
-              <a:t>[Sources]</a:t>
-            </a:r>
-          </a:p>
-          <a:p xmlns:a="http://schemas.openxmlformats.org/drawingml/2006/main">
-            <a:r>
-              <a:t>- docs/assets/devpost/woven-architecture.png</a:t>
-            </a:r>
-          </a:p>
-          <a:p xmlns:a="http://schemas.openxmlformats.org/drawingml/2006/main">
-            <a:r>
-              <a:t>- docs/architecture.md — System architecture and trust boundaries</a:t>
-            </a:r>
-          </a:p>
-          <a:p xmlns:a="http://schemas.openxmlformats.org/drawingml/2006/main">
-            <a:r>
-              <a:t>- docs/HANDOVER.md — One-service product invariant</a:t>
-            </a:r>
-          </a:p>
+          <a:p xmlns:a="http://schemas.openxmlformats.org/drawingml/2006/main"/>
         </p:txBody>
       </p:sp>
       <p:sp>
@@ -717,6 +668,187 @@
         <p:txBody>
           <a:bodyPr xmlns:a="http://schemas.openxmlformats.org/drawingml/2006/main"/>
           <a:lstStyle xmlns:a="http://schemas.openxmlformats.org/drawingml/2006/main"/>
+          <a:p xmlns:a="http://schemas.openxmlformats.org/drawingml/2006/main"/>
+        </p:txBody>
+      </p:sp>
+      <p:sp>
+        <p:nvSpPr>
+          <p:cNvPr id="4" name="Slide Number Placeholder 3"/>
+          <p:cNvSpPr>
+            <a:spLocks xmlns:a="http://schemas.openxmlformats.org/drawingml/2006/main" noGrp="1"/>
+          </p:cNvSpPr>
+          <p:nvPr>
+            <p:ph type="sldNum" idx="5"/>
+          </p:nvPr>
+        </p:nvSpPr>
+        <p:spPr/>
+        <p:txBody>
+          <a:bodyPr xmlns:a="http://schemas.openxmlformats.org/drawingml/2006/main"/>
+          <a:lstStyle xmlns:a="http://schemas.openxmlformats.org/drawingml/2006/main"/>
+          <a:p xmlns:a="http://schemas.openxmlformats.org/drawingml/2006/main"/>
+        </p:txBody>
+      </p:sp>
+    </p:spTree>
+  </p:cSld>
+  <p:clrMapOvr>
+    <a:masterClrMapping xmlns:a="http://schemas.openxmlformats.org/drawingml/2006/main"/>
+  </p:clrMapOvr>
+</p:notes>
+</file>
+
+<file path=ppt/notesSlides/notesSlide12.xml><?xml version="1.0" encoding="utf-8"?>
+<p:notes xmlns:p="http://schemas.openxmlformats.org/presentationml/2006/main">
+  <p:cSld>
+    <p:spTree>
+      <p:nvGrpSpPr>
+        <p:cNvPr id="1" name=""/>
+        <p:cNvGrpSpPr/>
+        <p:nvPr/>
+      </p:nvGrpSpPr>
+      <p:grpSpPr>
+        <a:xfrm xmlns:a="http://schemas.openxmlformats.org/drawingml/2006/main"/>
+      </p:grpSpPr>
+      <p:sp>
+        <p:nvSpPr>
+          <p:cNvPr id="2" name="Slide Image Placeholder 1"/>
+          <p:cNvSpPr>
+            <a:spLocks xmlns:a="http://schemas.openxmlformats.org/drawingml/2006/main" noGrp="1"/>
+          </p:cNvSpPr>
+          <p:nvPr>
+            <p:ph type="sldImg" idx="0"/>
+          </p:nvPr>
+        </p:nvSpPr>
+        <p:spPr/>
+      </p:sp>
+      <p:sp>
+        <p:nvSpPr>
+          <p:cNvPr id="3" name="Notes Placeholder 2"/>
+          <p:cNvSpPr>
+            <a:spLocks xmlns:a="http://schemas.openxmlformats.org/drawingml/2006/main" noGrp="1"/>
+          </p:cNvSpPr>
+          <p:nvPr>
+            <p:ph type="body" idx="1"/>
+          </p:nvPr>
+        </p:nvSpPr>
+        <p:spPr/>
+        <p:txBody>
+          <a:bodyPr xmlns:a="http://schemas.openxmlformats.org/drawingml/2006/main"/>
+          <a:lstStyle xmlns:a="http://schemas.openxmlformats.org/drawingml/2006/main"/>
+          <a:p xmlns:a="http://schemas.openxmlformats.org/drawingml/2006/main">
+            <a:r>
+              <a:t>USE IN TECHNICAL Q&amp;A — ARCHITECTURE</a:t>
+            </a:r>
+          </a:p>
+          <a:p xmlns:a="http://schemas.openxmlformats.org/drawingml/2006/main">
+            <a:r>
+              <a:t>The ChatGPT or Codex host invokes Woven’s MCP tools. One Node.js service owns cart construction, checkout mandate binding, confirmation, order state, merchant operations, and the simulated Visa adapter. The browser demo is a second transport over the same backend, not a separate product.</a:t>
+            </a:r>
+          </a:p>
+          <a:p xmlns:a="http://schemas.openxmlformats.org/drawingml/2006/main">
+            <a:r>
+              <a:t/>
+            </a:r>
+          </a:p>
+          <a:p xmlns:a="http://schemas.openxmlformats.org/drawingml/2006/main">
+            <a:r>
+              <a:t>POINT TO</a:t>
+            </a:r>
+          </a:p>
+          <a:p xmlns:a="http://schemas.openxmlformats.org/drawingml/2006/main">
+            <a:r>
+              <a:t>MCP and HTTP transports. Mission and cart engine. Checkout guard. Node SQLite atomic inventory and order transaction. Simulated Visa boundary.</a:t>
+            </a:r>
+          </a:p>
+          <a:p xmlns:a="http://schemas.openxmlformats.org/drawingml/2006/main">
+            <a:r>
+              <a:t/>
+            </a:r>
+          </a:p>
+          <a:p xmlns:a="http://schemas.openxmlformats.org/drawingml/2006/main">
+            <a:r>
+              <a:t>[Sources]</a:t>
+            </a:r>
+          </a:p>
+          <a:p xmlns:a="http://schemas.openxmlformats.org/drawingml/2006/main">
+            <a:r>
+              <a:t>- docs/assets/devpost/woven-architecture.png</a:t>
+            </a:r>
+          </a:p>
+          <a:p xmlns:a="http://schemas.openxmlformats.org/drawingml/2006/main">
+            <a:r>
+              <a:t>- docs/architecture.md — System architecture and trust boundaries</a:t>
+            </a:r>
+          </a:p>
+          <a:p xmlns:a="http://schemas.openxmlformats.org/drawingml/2006/main">
+            <a:r>
+              <a:t>- docs/HANDOVER.md — One-service product invariant</a:t>
+            </a:r>
+          </a:p>
+        </p:txBody>
+      </p:sp>
+      <p:sp>
+        <p:nvSpPr>
+          <p:cNvPr id="4" name="Slide Number Placeholder 3"/>
+          <p:cNvSpPr>
+            <a:spLocks xmlns:a="http://schemas.openxmlformats.org/drawingml/2006/main" noGrp="1"/>
+          </p:cNvSpPr>
+          <p:nvPr>
+            <p:ph type="sldNum" idx="5"/>
+          </p:nvPr>
+        </p:nvSpPr>
+        <p:spPr/>
+        <p:txBody>
+          <a:bodyPr xmlns:a="http://schemas.openxmlformats.org/drawingml/2006/main"/>
+          <a:lstStyle xmlns:a="http://schemas.openxmlformats.org/drawingml/2006/main"/>
+          <a:p xmlns:a="http://schemas.openxmlformats.org/drawingml/2006/main"/>
+        </p:txBody>
+      </p:sp>
+    </p:spTree>
+  </p:cSld>
+  <p:clrMapOvr>
+    <a:masterClrMapping xmlns:a="http://schemas.openxmlformats.org/drawingml/2006/main"/>
+  </p:clrMapOvr>
+</p:notes>
+</file>
+
+<file path=ppt/notesSlides/notesSlide13.xml><?xml version="1.0" encoding="utf-8"?>
+<p:notes xmlns:p="http://schemas.openxmlformats.org/presentationml/2006/main">
+  <p:cSld>
+    <p:spTree>
+      <p:nvGrpSpPr>
+        <p:cNvPr id="1" name=""/>
+        <p:cNvGrpSpPr/>
+        <p:nvPr/>
+      </p:nvGrpSpPr>
+      <p:grpSpPr>
+        <a:xfrm xmlns:a="http://schemas.openxmlformats.org/drawingml/2006/main"/>
+      </p:grpSpPr>
+      <p:sp>
+        <p:nvSpPr>
+          <p:cNvPr id="2" name="Slide Image Placeholder 1"/>
+          <p:cNvSpPr>
+            <a:spLocks xmlns:a="http://schemas.openxmlformats.org/drawingml/2006/main" noGrp="1"/>
+          </p:cNvSpPr>
+          <p:nvPr>
+            <p:ph type="sldImg" idx="0"/>
+          </p:nvPr>
+        </p:nvSpPr>
+        <p:spPr/>
+      </p:sp>
+      <p:sp>
+        <p:nvSpPr>
+          <p:cNvPr id="3" name="Notes Placeholder 2"/>
+          <p:cNvSpPr>
+            <a:spLocks xmlns:a="http://schemas.openxmlformats.org/drawingml/2006/main" noGrp="1"/>
+          </p:cNvSpPr>
+          <p:nvPr>
+            <p:ph type="body" idx="1"/>
+          </p:nvPr>
+        </p:nvSpPr>
+        <p:spPr/>
+        <p:txBody>
+          <a:bodyPr xmlns:a="http://schemas.openxmlformats.org/drawingml/2006/main"/>
+          <a:lstStyle xmlns:a="http://schemas.openxmlformats.org/drawingml/2006/main"/>
           <a:p xmlns:a="http://schemas.openxmlformats.org/drawingml/2006/main">
             <a:r>
               <a:t>USE IN TRUST AND SAFETY Q&amp;A</a:t>
@@ -724,7 +856,7 @@
           </a:p>
           <a:p xmlns:a="http://schemas.openxmlformats.org/drawingml/2006/main">
             <a:r>
-              <a:t>Current controls bind merchant, cart version, amount, expiry, nonce, and idempotency key; recheck price and stock; keep the confirmation nonce outside model-visible tool arguments; and simulate reversal after downstream merchant failure. Identity is a planned pre-checkout control and is not implemented.</a:t>
+              <a:t>Current controls require a short-lived simulated identity session before checkout; bind merchant, cart version, amount, expiry, identity session, nonce, and idempotency key; recheck price and stock; keep confirmation secrets outside model-visible tool arguments; and simulate reversal after downstream merchant failure.</a:t>
             </a:r>
           </a:p>
           <a:p xmlns:a="http://schemas.openxmlformats.org/drawingml/2006/main">
@@ -1334,22 +1466,32 @@
           </a:p>
           <a:p xmlns:a="http://schemas.openxmlformats.org/drawingml/2006/main">
             <a:r>
-              <a:t>1. Click Review checkout.</a:t>
-            </a:r>
-          </a:p>
-          <a:p xmlns:a="http://schemas.openxmlformats.org/drawingml/2006/main">
-            <a:r>
-              <a:t>2. Show the exact merchant, items, pickup location, total, cart version, and expiry.</a:t>
-            </a:r>
-          </a:p>
-          <a:p xmlns:a="http://schemas.openxmlformats.org/drawingml/2006/main">
-            <a:r>
-              <a:t>3. Pause before clicking Confirm S$133.00.</a:t>
-            </a:r>
-          </a:p>
-          <a:p xmlns:a="http://schemas.openxmlformats.org/drawingml/2006/main">
-            <a:r>
-              <a:t>4. Confirm and show the simulated Visa authorization result and pickup receipt.</a:t>
+              <a:t>1. Click Verify demo identity.</a:t>
+            </a:r>
+          </a:p>
+          <a:p xmlns:a="http://schemas.openxmlformats.org/drawingml/2006/main">
+            <a:r>
+              <a:t>2. On the clearly labeled simulator page, point out that no Visa account, password, or card credential is accessed; click Continue as Chai.</a:t>
+            </a:r>
+          </a:p>
+          <a:p xmlns:a="http://schemas.openxmlformats.org/drawingml/2006/main">
+            <a:r>
+              <a:t>3. Return to Woven, check identity status, then click Review checkout.</a:t>
+            </a:r>
+          </a:p>
+          <a:p xmlns:a="http://schemas.openxmlformats.org/drawingml/2006/main">
+            <a:r>
+              <a:t>4. Show the exact merchant, items, pickup location, total, cart version, and expiry.</a:t>
+            </a:r>
+          </a:p>
+          <a:p xmlns:a="http://schemas.openxmlformats.org/drawingml/2006/main">
+            <a:r>
+              <a:t>5. Pause before clicking Confirm S$133.00.</a:t>
+            </a:r>
+          </a:p>
+          <a:p xmlns:a="http://schemas.openxmlformats.org/drawingml/2006/main">
+            <a:r>
+              <a:t>6. Confirm and show the simulated Visa authorization result and pickup receipt.</a:t>
             </a:r>
           </a:p>
           <a:p xmlns:a="http://schemas.openxmlformats.org/drawingml/2006/main">
@@ -1364,7 +1506,7 @@
           </a:p>
           <a:p xmlns:a="http://schemas.openxmlformats.org/drawingml/2006/main">
             <a:r>
-              <a:t>“Woven rechecks the price and stock, then creates an exact ten-minute checkout preview. The AI recommended this cart, but it cannot approve it. The user sees the merchant, every item, the pickup location, and the S$133 total before one direct confirmation.”</a:t>
+              <a:t>“Before checkout, Woven requires a short, server-enforced demo identity session. The page is visibly simulated and accepts no password or payment credential. Woven then rechecks the price and stock and creates an exact ten-minute checkout preview. The AI recommended this cart, but it cannot approve it.”</a:t>
             </a:r>
           </a:p>
           <a:p xmlns:a="http://schemas.openxmlformats.org/drawingml/2006/main">
@@ -1389,7 +1531,7 @@
           </a:p>
           <a:p xmlns:a="http://schemas.openxmlformats.org/drawingml/2006/main">
             <a:r>
-              <a:t>Identity verification is planned and not in the live build. Do not show a static identity mock as verification. After server enforcement exists, insert the connector-style demo identity check before exact-term review and keep it separate from final confirmation.</a:t>
+              <a:t>The identity simulator is working and server-enforced, but it is not Visa identity verification and accesses no Visa account or credential. Keep the simulated identity gate visibly separate from final purchase confirmation.</a:t>
             </a:r>
           </a:p>
           <a:p xmlns:a="http://schemas.openxmlformats.org/drawingml/2006/main">
@@ -1699,7 +1841,7 @@
           </a:p>
           <a:p xmlns:a="http://schemas.openxmlformats.org/drawingml/2006/main">
             <a:r>
-              <a:t>“This prototype uses seeded inventory and a simulated Visa authorization; no live charge occurs. Our next trust step is the connector-style demo identity check.”</a:t>
+              <a:t>“This prototype uses seeded inventory, a server-enforced demo identity simulator, and a simulated Visa authorization. No Visa account is accessed and no live charge occurs.”</a:t>
             </a:r>
           </a:p>
           <a:p xmlns:a="http://schemas.openxmlformats.org/drawingml/2006/main">
@@ -1954,7 +2096,7 @@
           </a:p>
           <a:p xmlns:a="http://schemas.openxmlformats.org/drawingml/2006/main">
             <a:r>
-              <a:t>Inventory and pickup estimates are seeded. Identity verification is a planned product direction, not a live feature. Visa approval, decline, and reversal are simulated. No Visa account is accessed, no payment credentials are collected, and no live charge or partnership is claimed.</a:t>
+              <a:t>Inventory and pickup estimates are seeded. The demo identity gate is working and server-enforced, but it is not Visa identity verification. Visa approval, decline, and reversal are simulated. No Visa account is accessed, no payment credentials are collected, and no live charge or partnership is claimed.</a:t>
             </a:r>
           </a:p>
           <a:p xmlns:a="http://schemas.openxmlformats.org/drawingml/2006/main">
@@ -1969,7 +2111,7 @@
           </a:p>
           <a:p xmlns:a="http://schemas.openxmlformats.org/drawingml/2006/main">
             <a:r>
-              <a:t>“The trust boundary is explicit: the working product binds exact terms and requires direct confirmation; identity is next, and the payment rail is clearly simulated.”</a:t>
+              <a:t>“The trust boundary is explicit: simulated identity is one enforced gate, and direct confirmation of exact terms is a separate gate. The payment rail is also clearly simulated.”</a:t>
             </a:r>
           </a:p>
           <a:p xmlns:a="http://schemas.openxmlformats.org/drawingml/2006/main">
@@ -2062,7 +2204,7 @@
   </p:cSld>
   <p:clrMap bg1="lt1" tx1="dk1" bg2="lt2" tx2="dk2" accent1="accent1" accent2="accent2" accent3="accent3" accent4="accent4" accent5="accent5" accent6="accent6" hlink="hlink" folHlink="folHlink"/>
   <p:sldLayoutIdLst>
-    <p:sldLayoutId xmlns:r="http://schemas.openxmlformats.org/officeDocument/2006/relationships" id="2147483649" r:id="R02831dc36adb413d"/>
+    <p:sldLayoutId xmlns:r="http://schemas.openxmlformats.org/officeDocument/2006/relationships" id="2147483649" r:id="Ra770cef4c9d4443d"/>
   </p:sldLayoutIdLst>
   <p:txStyles>
     <p:titleStyle>
@@ -3179,14 +3321,14 @@
       </p:sp>
       <p:pic>
         <p:nvPicPr>
-          <p:cNvPr id="21" name=""/>
+          <p:cNvPr id="20" name=""/>
           <p:cNvPicPr>
             <a:picLocks xmlns:a="http://schemas.openxmlformats.org/drawingml/2006/main" noChangeAspect="1"/>
           </p:cNvPicPr>
           <p:nvPr/>
         </p:nvPicPr>
         <p:blipFill>
-          <a:blip xmlns:r="http://schemas.openxmlformats.org/officeDocument/2006/relationships" xmlns:a="http://schemas.openxmlformats.org/drawingml/2006/main" r:embed="R64deff9c5da942be"/>
+          <a:blip xmlns:r="http://schemas.openxmlformats.org/officeDocument/2006/relationships" xmlns:a="http://schemas.openxmlformats.org/drawingml/2006/main" r:embed="Rb0dc8e30eddc4c2b"/>
           <a:srcRect xmlns:a="http://schemas.openxmlformats.org/drawingml/2006/main" l="12000" t="0" r="2000" b="0"/>
           <a:stretch xmlns:a="http://schemas.openxmlformats.org/drawingml/2006/main">
             <a:fillRect l="0" t="0" r="0" b="0"/>
@@ -3233,7 +3375,7 @@
           <p:nvPr/>
         </p:nvPicPr>
         <p:blipFill>
-          <a:blip xmlns:r="http://schemas.openxmlformats.org/officeDocument/2006/relationships" xmlns:a="http://schemas.openxmlformats.org/drawingml/2006/main" r:embed="R9bffdb01cf344feb"/>
+          <a:blip xmlns:r="http://schemas.openxmlformats.org/officeDocument/2006/relationships" xmlns:a="http://schemas.openxmlformats.org/drawingml/2006/main" r:embed="R0619994766454326"/>
           <a:srcRect xmlns:a="http://schemas.openxmlformats.org/drawingml/2006/main" l="0" t="0" r="0" b="0"/>
           <a:stretch xmlns:a="http://schemas.openxmlformats.org/drawingml/2006/main">
             <a:fillRect l="0" t="0" r="0" b="0"/>
@@ -3262,13 +3404,6 @@
 <file path=ppt/slides/slide11.xml><?xml version="1.0" encoding="utf-8"?>
 <p:sld xmlns:p="http://schemas.openxmlformats.org/presentationml/2006/main">
   <p:cSld>
-    <p:bg>
-      <p:bgPr>
-        <a:solidFill xmlns:a="http://schemas.openxmlformats.org/drawingml/2006/main">
-          <a:srgbClr val="F4EEE4"/>
-        </a:solidFill>
-      </p:bgPr>
-    </p:bg>
     <p:spTree>
       <p:nvGrpSpPr>
         <p:cNvPr id="1" name=""/>
@@ -3278,554 +3413,35 @@
       <p:grpSpPr>
         <a:xfrm xmlns:a="http://schemas.openxmlformats.org/drawingml/2006/main"/>
       </p:grpSpPr>
-      <p:sp>
-        <p:nvSpPr>
-          <p:cNvPr id="11" name="eyebrow-The live demo">
-            <a:extLst xmlns:a="http://schemas.openxmlformats.org/drawingml/2006/main">
-              <a:ext uri="{FF2B5EF4-FFF2-40B4-BE49-F238E27FC236}">
-                <a16:creationId xmlns:a16="http://schemas.microsoft.com/office/drawing/2014/main" id="{46635EF8-3618-4994-81BA-2542F409376A}"/>
-              </a:ext>
-            </a:extLst>
-          </p:cNvPr>
-          <p:cNvSpPr>
-            <a:spLocks xmlns:a="http://schemas.openxmlformats.org/drawingml/2006/main" noGrp="1"/>
-          </p:cNvSpPr>
-          <p:nvPr/>
-        </p:nvSpPr>
-        <p:spPr>
-          <a:xfrm xmlns:a="http://schemas.openxmlformats.org/drawingml/2006/main">
-            <a:off x="838200" y="590550"/>
-            <a:ext cx="8572500" cy="247650"/>
-          </a:xfrm>
-          <a:prstGeom xmlns:a="http://schemas.openxmlformats.org/drawingml/2006/main" prst="rect">
-            <a:avLst/>
-          </a:prstGeom>
-          <a:noFill xmlns:a="http://schemas.openxmlformats.org/drawingml/2006/main"/>
-          <a:ln xmlns:a="http://schemas.openxmlformats.org/drawingml/2006/main" w="0">
-            <a:noFill/>
-            <a:prstDash val="solid"/>
-          </a:ln>
-        </p:spPr>
-        <p:txBody>
-          <a:bodyPr xmlns:a="http://schemas.openxmlformats.org/drawingml/2006/main" wrap="square" lIns="0" tIns="0" rIns="0" bIns="0">
-            <a:noAutofit/>
-          </a:bodyPr>
-          <a:lstStyle xmlns:a="http://schemas.openxmlformats.org/drawingml/2006/main"/>
-          <a:p xmlns:a="http://schemas.openxmlformats.org/drawingml/2006/main">
-            <a:pPr>
-              <a:buNone/>
-              <a:defRPr sz="1350" b="1">
-                <a:solidFill>
-                  <a:srgbClr val="6D7974"/>
-                </a:solidFill>
-                <a:latin typeface="Menlo"/>
-                <a:ea typeface="Menlo"/>
-                <a:cs typeface="Menlo"/>
-              </a:defRPr>
-            </a:pPr>
-            <a:r>
-              <a:rPr sz="1350" b="1">
-                <a:solidFill>
-                  <a:srgbClr val="6D7974"/>
-                </a:solidFill>
-                <a:latin typeface="Menlo"/>
-                <a:ea typeface="Menlo"/>
-                <a:cs typeface="Menlo"/>
-              </a:rPr>
-              <a:t>BACKUP · TRUST CONTROLS</a:t>
-            </a:r>
-          </a:p>
-        </p:txBody>
-      </p:sp>
-      <p:sp>
-        <p:nvSpPr>
-          <p:cNvPr id="2" name="title-The AI recommends. The user confirms the exact terms.">
-            <a:extLst xmlns:a="http://schemas.openxmlformats.org/drawingml/2006/main">
-              <a:ext uri="{FF2B5EF4-FFF2-40B4-BE49-F238E27FC236}">
-                <a16:creationId xmlns:a16="http://schemas.microsoft.com/office/drawing/2014/main" id="{E6C7E214-CE49-432D-A6ED-84FB60003964}"/>
-              </a:ext>
-            </a:extLst>
-          </p:cNvPr>
-          <p:cNvSpPr>
-            <a:spLocks xmlns:a="http://schemas.openxmlformats.org/drawingml/2006/main" noGrp="1"/>
-          </p:cNvSpPr>
-          <p:nvPr/>
-        </p:nvSpPr>
-        <p:spPr>
-          <a:xfrm xmlns:a="http://schemas.openxmlformats.org/drawingml/2006/main">
-            <a:off x="838200" y="990600"/>
-            <a:ext cx="13525500" cy="1028700"/>
-          </a:xfrm>
-          <a:prstGeom xmlns:a="http://schemas.openxmlformats.org/drawingml/2006/main" prst="rect">
-            <a:avLst/>
-          </a:prstGeom>
-          <a:noFill xmlns:a="http://schemas.openxmlformats.org/drawingml/2006/main"/>
-          <a:ln xmlns:a="http://schemas.openxmlformats.org/drawingml/2006/main" w="0">
-            <a:noFill/>
-            <a:prstDash val="solid"/>
-          </a:ln>
-        </p:spPr>
-        <p:txBody>
-          <a:bodyPr xmlns:a="http://schemas.openxmlformats.org/drawingml/2006/main" wrap="square" lIns="0" tIns="0" rIns="0" bIns="0">
-            <a:noAutofit/>
-          </a:bodyPr>
-          <a:lstStyle xmlns:a="http://schemas.openxmlformats.org/drawingml/2006/main"/>
-          <a:p xmlns:a="http://schemas.openxmlformats.org/drawingml/2006/main">
-            <a:pPr>
-              <a:lnSpc>
-                <a:spcPct val="95000"/>
-              </a:lnSpc>
-              <a:buNone/>
-              <a:defRPr sz="4650" b="1">
-                <a:solidFill>
-                  <a:srgbClr val="0E4B3B"/>
-                </a:solidFill>
-                <a:latin typeface="Georgia"/>
-                <a:ea typeface="Georgia"/>
-                <a:cs typeface="Georgia"/>
-              </a:defRPr>
-            </a:pPr>
-            <a:r>
-              <a:rPr sz="4650" b="1">
-                <a:solidFill>
-                  <a:srgbClr val="0E4B3B"/>
-                </a:solidFill>
-                <a:latin typeface="Georgia"/>
-                <a:ea typeface="Georgia"/>
-                <a:cs typeface="Georgia"/>
-              </a:rPr>
-              <a:t>Trust is enforced at the purchase boundary.</a:t>
-            </a:r>
-          </a:p>
-        </p:txBody>
-      </p:sp>
-      <p:sp>
-        <p:nvSpPr>
-          <p:cNvPr id="3" name="boundary-statement">
-            <a:extLst xmlns:a="http://schemas.openxmlformats.org/drawingml/2006/main">
-              <a:ext uri="{FF2B5EF4-FFF2-40B4-BE49-F238E27FC236}">
-                <a16:creationId xmlns:a16="http://schemas.microsoft.com/office/drawing/2014/main" id="{64039A6F-00FA-4C7A-8407-F1FA78BFDFA5}"/>
-              </a:ext>
-            </a:extLst>
-          </p:cNvPr>
-          <p:cNvSpPr>
-            <a:spLocks xmlns:a="http://schemas.openxmlformats.org/drawingml/2006/main" noGrp="1"/>
-          </p:cNvSpPr>
-          <p:nvPr/>
-        </p:nvSpPr>
-        <p:spPr>
-          <a:xfrm xmlns:a="http://schemas.openxmlformats.org/drawingml/2006/main">
-            <a:off x="838200" y="2895600"/>
-            <a:ext cx="4191000" cy="1371600"/>
-          </a:xfrm>
-          <a:prstGeom xmlns:a="http://schemas.openxmlformats.org/drawingml/2006/main" prst="rect">
-            <a:avLst/>
-          </a:prstGeom>
-          <a:noFill xmlns:a="http://schemas.openxmlformats.org/drawingml/2006/main"/>
-          <a:ln xmlns:a="http://schemas.openxmlformats.org/drawingml/2006/main" w="0">
-            <a:noFill/>
-            <a:prstDash val="solid"/>
-          </a:ln>
-        </p:spPr>
-        <p:txBody>
-          <a:bodyPr xmlns:a="http://schemas.openxmlformats.org/drawingml/2006/main" wrap="square" lIns="0" tIns="0" rIns="0" bIns="0">
-            <a:noAutofit/>
-          </a:bodyPr>
-          <a:lstStyle xmlns:a="http://schemas.openxmlformats.org/drawingml/2006/main"/>
-          <a:p xmlns:a="http://schemas.openxmlformats.org/drawingml/2006/main">
-            <a:pPr>
-              <a:lnSpc>
-                <a:spcPct val="95000"/>
-              </a:lnSpc>
-              <a:buNone/>
-              <a:defRPr sz="3150" b="1">
-                <a:solidFill>
-                  <a:srgbClr val="0E4B3B"/>
-                </a:solidFill>
-                <a:latin typeface="Georgia"/>
-                <a:ea typeface="Georgia"/>
-                <a:cs typeface="Georgia"/>
-              </a:defRPr>
-            </a:pPr>
-            <a:r>
-              <a:rPr sz="3150" b="1">
-                <a:solidFill>
-                  <a:srgbClr val="0E4B3B"/>
-                </a:solidFill>
-                <a:latin typeface="Georgia"/>
-                <a:ea typeface="Georgia"/>
-                <a:cs typeface="Georgia"/>
-              </a:rPr>
-              <a:t>Exact terms are bound.</a:t>
-            </a:r>
-          </a:p>
-          <a:p xmlns:a="http://schemas.openxmlformats.org/drawingml/2006/main">
-            <a:pPr>
-              <a:lnSpc>
-                <a:spcPct val="95000"/>
-              </a:lnSpc>
-              <a:buNone/>
-              <a:defRPr sz="3150" b="1">
-                <a:solidFill>
-                  <a:srgbClr val="0E4B3B"/>
-                </a:solidFill>
-                <a:latin typeface="Georgia"/>
-                <a:ea typeface="Georgia"/>
-                <a:cs typeface="Georgia"/>
-              </a:defRPr>
-            </a:pPr>
-            <a:r>
-              <a:rPr sz="3150" b="1">
-                <a:solidFill>
-                  <a:srgbClr val="0E4B3B"/>
-                </a:solidFill>
-                <a:latin typeface="Georgia"/>
-                <a:ea typeface="Georgia"/>
-                <a:cs typeface="Georgia"/>
-              </a:rPr>
-              <a:t>Only the user confirms.</a:t>
-            </a:r>
-          </a:p>
-        </p:txBody>
-      </p:sp>
-      <p:sp>
-        <p:nvSpPr>
-          <p:cNvPr id="4" name="simulated-label">
-            <a:extLst xmlns:a="http://schemas.openxmlformats.org/drawingml/2006/main">
-              <a:ext uri="{FF2B5EF4-FFF2-40B4-BE49-F238E27FC236}">
-                <a16:creationId xmlns:a16="http://schemas.microsoft.com/office/drawing/2014/main" id="{906B7775-6C73-4936-919D-C949C0ED9DEE}"/>
-              </a:ext>
-            </a:extLst>
-          </p:cNvPr>
-          <p:cNvSpPr>
-            <a:spLocks xmlns:a="http://schemas.openxmlformats.org/drawingml/2006/main" noGrp="1"/>
-          </p:cNvSpPr>
-          <p:nvPr/>
-        </p:nvSpPr>
-        <p:spPr>
-          <a:xfrm xmlns:a="http://schemas.openxmlformats.org/drawingml/2006/main">
-            <a:off x="838200" y="4724400"/>
-            <a:ext cx="3143250" cy="514350"/>
-          </a:xfrm>
-          <a:prstGeom xmlns:a="http://schemas.openxmlformats.org/drawingml/2006/main" prst="roundRect">
-            <a:avLst>
-              <a:gd name="adj" fmla="val 50000"/>
-            </a:avLst>
-          </a:prstGeom>
-          <a:solidFill xmlns:a="http://schemas.openxmlformats.org/drawingml/2006/main">
-            <a:srgbClr val="1545E8"/>
-          </a:solidFill>
-          <a:ln xmlns:a="http://schemas.openxmlformats.org/drawingml/2006/main" w="0">
-            <a:noFill/>
-            <a:prstDash val="solid"/>
-          </a:ln>
-        </p:spPr>
-      </p:sp>
-      <p:sp>
-        <p:nvSpPr>
-          <p:cNvPr id="5" name="simulated-label-text">
-            <a:extLst xmlns:a="http://schemas.openxmlformats.org/drawingml/2006/main">
-              <a:ext uri="{FF2B5EF4-FFF2-40B4-BE49-F238E27FC236}">
-                <a16:creationId xmlns:a16="http://schemas.microsoft.com/office/drawing/2014/main" id="{0DCF3A62-833F-4EDD-B0B4-4EEFB00BFC41}"/>
-              </a:ext>
-            </a:extLst>
-          </p:cNvPr>
-          <p:cNvSpPr>
-            <a:spLocks xmlns:a="http://schemas.openxmlformats.org/drawingml/2006/main" noGrp="1"/>
-          </p:cNvSpPr>
-          <p:nvPr/>
-        </p:nvSpPr>
-        <p:spPr>
-          <a:xfrm xmlns:a="http://schemas.openxmlformats.org/drawingml/2006/main">
-            <a:off x="1028700" y="4876800"/>
-            <a:ext cx="2762250" cy="228600"/>
-          </a:xfrm>
-          <a:prstGeom xmlns:a="http://schemas.openxmlformats.org/drawingml/2006/main" prst="rect">
-            <a:avLst/>
-          </a:prstGeom>
-          <a:noFill xmlns:a="http://schemas.openxmlformats.org/drawingml/2006/main"/>
-          <a:ln xmlns:a="http://schemas.openxmlformats.org/drawingml/2006/main" w="0">
-            <a:noFill/>
-            <a:prstDash val="solid"/>
-          </a:ln>
-        </p:spPr>
-        <p:txBody>
-          <a:bodyPr xmlns:a="http://schemas.openxmlformats.org/drawingml/2006/main" wrap="square" lIns="0" tIns="0" rIns="0" bIns="0">
-            <a:noAutofit/>
-          </a:bodyPr>
-          <a:lstStyle xmlns:a="http://schemas.openxmlformats.org/drawingml/2006/main"/>
-          <a:p xmlns:a="http://schemas.openxmlformats.org/drawingml/2006/main">
-            <a:pPr algn="ctr">
-              <a:buNone/>
-              <a:defRPr sz="1275" b="1">
-                <a:solidFill>
-                  <a:srgbClr val="FFFFFF"/>
-                </a:solidFill>
-                <a:latin typeface="Menlo"/>
-                <a:ea typeface="Menlo"/>
-                <a:cs typeface="Menlo"/>
-              </a:defRPr>
-            </a:pPr>
-            <a:r>
-              <a:rPr sz="1275" b="1">
-                <a:solidFill>
-                  <a:srgbClr val="FFFFFF"/>
-                </a:solidFill>
-                <a:latin typeface="Menlo"/>
-                <a:ea typeface="Menlo"/>
-                <a:cs typeface="Menlo"/>
-              </a:rPr>
-              <a:t>IDENTITY · PLANNED / NOT LIVE</a:t>
-            </a:r>
-          </a:p>
-        </p:txBody>
-      </p:sp>
-      <p:sp>
-        <p:nvSpPr>
-          <p:cNvPr id="6" name="exact-terms">
-            <a:extLst xmlns:a="http://schemas.openxmlformats.org/drawingml/2006/main">
-              <a:ext uri="{FF2B5EF4-FFF2-40B4-BE49-F238E27FC236}">
-                <a16:creationId xmlns:a16="http://schemas.microsoft.com/office/drawing/2014/main" id="{24D4E798-F7E3-4205-9A3C-908586EEA799}"/>
-              </a:ext>
-            </a:extLst>
-          </p:cNvPr>
-          <p:cNvSpPr>
-            <a:spLocks xmlns:a="http://schemas.openxmlformats.org/drawingml/2006/main" noGrp="1"/>
-          </p:cNvSpPr>
-          <p:nvPr/>
-        </p:nvSpPr>
-        <p:spPr>
-          <a:xfrm xmlns:a="http://schemas.openxmlformats.org/drawingml/2006/main">
-            <a:off x="838200" y="5638800"/>
-            <a:ext cx="3810000" cy="1104900"/>
-          </a:xfrm>
-          <a:prstGeom xmlns:a="http://schemas.openxmlformats.org/drawingml/2006/main" prst="rect">
-            <a:avLst/>
-          </a:prstGeom>
-          <a:noFill xmlns:a="http://schemas.openxmlformats.org/drawingml/2006/main"/>
-          <a:ln xmlns:a="http://schemas.openxmlformats.org/drawingml/2006/main" w="0">
-            <a:noFill/>
-            <a:prstDash val="solid"/>
-          </a:ln>
-        </p:spPr>
-        <p:txBody>
-          <a:bodyPr xmlns:a="http://schemas.openxmlformats.org/drawingml/2006/main" wrap="square" lIns="0" tIns="0" rIns="0" bIns="0">
-            <a:noAutofit/>
-          </a:bodyPr>
-          <a:lstStyle xmlns:a="http://schemas.openxmlformats.org/drawingml/2006/main"/>
-          <a:p xmlns:a="http://schemas.openxmlformats.org/drawingml/2006/main">
-            <a:pPr>
-              <a:lnSpc>
-                <a:spcPct val="118000"/>
-              </a:lnSpc>
-              <a:buNone/>
-              <a:defRPr sz="1800">
-                <a:solidFill>
-                  <a:srgbClr val="6D7974"/>
-                </a:solidFill>
-                <a:latin typeface="Avenir Next"/>
-                <a:ea typeface="Avenir Next"/>
-                <a:cs typeface="Avenir Next"/>
-              </a:defRPr>
-            </a:pPr>
-            <a:r>
-              <a:rPr sz="1800">
-                <a:solidFill>
-                  <a:srgbClr val="6D7974"/>
-                </a:solidFill>
-                <a:latin typeface="Avenir Next"/>
-                <a:ea typeface="Avenir Next"/>
-                <a:cs typeface="Avenir Next"/>
-              </a:rPr>
-              <a:t>Price + stock rechecked · mandate expires · private nonce
-Idempotent order · simulated reversal</a:t>
-            </a:r>
-          </a:p>
-        </p:txBody>
-      </p:sp>
-      <p:sp>
-        <p:nvSpPr>
-          <p:cNvPr id="7" name="Woven checkout mandate showing exact terms and explicit confirmation-backplate">
-            <a:extLst xmlns:a="http://schemas.openxmlformats.org/drawingml/2006/main">
-              <a:ext uri="{FF2B5EF4-FFF2-40B4-BE49-F238E27FC236}">
-                <a16:creationId xmlns:a16="http://schemas.microsoft.com/office/drawing/2014/main" id="{8ADD3CA5-C1ED-4601-B88F-C6932A9AEDCB}"/>
-              </a:ext>
-            </a:extLst>
-          </p:cNvPr>
-          <p:cNvSpPr>
-            <a:spLocks xmlns:a="http://schemas.openxmlformats.org/drawingml/2006/main" noGrp="1"/>
-          </p:cNvSpPr>
-          <p:nvPr/>
-        </p:nvSpPr>
-        <p:spPr>
-          <a:xfrm xmlns:a="http://schemas.openxmlformats.org/drawingml/2006/main">
-            <a:off x="5095875" y="2362200"/>
-            <a:ext cx="9191625" cy="5257800"/>
-          </a:xfrm>
-          <a:prstGeom xmlns:a="http://schemas.openxmlformats.org/drawingml/2006/main" prst="roundRect">
-            <a:avLst>
-              <a:gd name="adj" fmla="val 4348"/>
-            </a:avLst>
-          </a:prstGeom>
-          <a:solidFill xmlns:a="http://schemas.openxmlformats.org/drawingml/2006/main">
-            <a:srgbClr val="FFFFFF"/>
-          </a:solidFill>
-          <a:ln xmlns:a="http://schemas.openxmlformats.org/drawingml/2006/main" w="0">
-            <a:noFill/>
-            <a:prstDash val="solid"/>
-          </a:ln>
-        </p:spPr>
-        <p:style>
-          <a:lnRef xmlns:a="http://schemas.openxmlformats.org/drawingml/2006/main" idx="0"/>
-          <a:fillRef xmlns:a="http://schemas.openxmlformats.org/drawingml/2006/main" idx="0"/>
-          <a:effectRef xmlns:a="http://schemas.openxmlformats.org/drawingml/2006/main" idx="7"/>
-          <a:fontRef xmlns:a="http://schemas.openxmlformats.org/drawingml/2006/main" idx="major"/>
-        </p:style>
-      </p:sp>
       <p:pic>
         <p:nvPicPr>
-          <p:cNvPr id="20" name=""/>
+          <p:cNvPr id="2" name=""/>
           <p:cNvPicPr>
             <a:picLocks xmlns:a="http://schemas.openxmlformats.org/drawingml/2006/main" noChangeAspect="1"/>
           </p:cNvPicPr>
           <p:nvPr/>
         </p:nvPicPr>
         <p:blipFill>
-          <a:blip xmlns:r="http://schemas.openxmlformats.org/officeDocument/2006/relationships" xmlns:a="http://schemas.openxmlformats.org/drawingml/2006/main" r:embed="R3785bd862f514d5a"/>
-          <a:stretch xmlns:a="http://schemas.openxmlformats.org/drawingml/2006/main"/>
+          <a:blip xmlns:r="http://schemas.openxmlformats.org/officeDocument/2006/relationships" xmlns:a="http://schemas.openxmlformats.org/drawingml/2006/main" r:embed="Rb29ea2cbe63d48c4"/>
+          <a:srcRect xmlns:a="http://schemas.openxmlformats.org/drawingml/2006/main" l="0" t="0" r="0" b="0"/>
+          <a:stretch xmlns:a="http://schemas.openxmlformats.org/drawingml/2006/main">
+            <a:fillRect l="0" t="0" r="0" b="0"/>
+          </a:stretch>
         </p:blipFill>
         <p:spPr>
           <a:xfrm xmlns:a="http://schemas.openxmlformats.org/drawingml/2006/main" flipH="0" flipV="0">
-            <a:off x="5191125" y="2459534"/>
-            <a:ext cx="9001125" cy="5063133"/>
-          </a:xfrm>
-          <a:prstGeom xmlns:a="http://schemas.openxmlformats.org/drawingml/2006/main" prst="roundRect">
+            <a:off x="0" y="0"/>
+            <a:ext cx="15240000" cy="8572500"/>
+          </a:xfrm>
+          <a:prstGeom xmlns:a="http://schemas.openxmlformats.org/drawingml/2006/main" prst="rect">
             <a:avLst/>
           </a:prstGeom>
         </p:spPr>
       </p:pic>
-      <p:sp>
-        <p:nvSpPr>
-          <p:cNvPr id="9" name="footer-label-6">
-            <a:extLst xmlns:a="http://schemas.openxmlformats.org/drawingml/2006/main">
-              <a:ext uri="{FF2B5EF4-FFF2-40B4-BE49-F238E27FC236}">
-                <a16:creationId xmlns:a16="http://schemas.microsoft.com/office/drawing/2014/main" id="{180E82C5-4959-4CB6-9B7C-CA48FE5A4C58}"/>
-              </a:ext>
-            </a:extLst>
-          </p:cNvPr>
-          <p:cNvSpPr>
-            <a:spLocks xmlns:a="http://schemas.openxmlformats.org/drawingml/2006/main" noGrp="1"/>
-          </p:cNvSpPr>
-          <p:nvPr/>
-        </p:nvSpPr>
-        <p:spPr>
-          <a:xfrm xmlns:a="http://schemas.openxmlformats.org/drawingml/2006/main">
-            <a:off x="838200" y="8020050"/>
-            <a:ext cx="5334000" cy="228600"/>
-          </a:xfrm>
-          <a:prstGeom xmlns:a="http://schemas.openxmlformats.org/drawingml/2006/main" prst="rect">
-            <a:avLst/>
-          </a:prstGeom>
-          <a:noFill xmlns:a="http://schemas.openxmlformats.org/drawingml/2006/main"/>
-          <a:ln xmlns:a="http://schemas.openxmlformats.org/drawingml/2006/main" w="0">
-            <a:noFill/>
-            <a:prstDash val="solid"/>
-          </a:ln>
-        </p:spPr>
-        <p:txBody>
-          <a:bodyPr xmlns:a="http://schemas.openxmlformats.org/drawingml/2006/main" wrap="square" lIns="0" tIns="0" rIns="0" bIns="0">
-            <a:noAutofit/>
-          </a:bodyPr>
-          <a:lstStyle xmlns:a="http://schemas.openxmlformats.org/drawingml/2006/main"/>
-          <a:p xmlns:a="http://schemas.openxmlformats.org/drawingml/2006/main">
-            <a:pPr>
-              <a:buNone/>
-              <a:defRPr sz="1200" b="1">
-                <a:solidFill>
-                  <a:srgbClr val="6D7974"/>
-                </a:solidFill>
-                <a:latin typeface="Menlo"/>
-                <a:ea typeface="Menlo"/>
-                <a:cs typeface="Menlo"/>
-              </a:defRPr>
-            </a:pPr>
-            <a:r>
-              <a:rPr sz="1200" b="1">
-                <a:solidFill>
-                  <a:srgbClr val="6D7974"/>
-                </a:solidFill>
-                <a:latin typeface="Menlo"/>
-                <a:ea typeface="Menlo"/>
-                <a:cs typeface="Menlo"/>
-              </a:rPr>
-              <a:t>WOVEN  /  LIFEHACK 2026</a:t>
-            </a:r>
-          </a:p>
-        </p:txBody>
-      </p:sp>
-      <p:sp>
-        <p:nvSpPr>
-          <p:cNvPr id="10" name="footer-number-6">
-            <a:extLst xmlns:a="http://schemas.openxmlformats.org/drawingml/2006/main">
-              <a:ext uri="{FF2B5EF4-FFF2-40B4-BE49-F238E27FC236}">
-                <a16:creationId xmlns:a16="http://schemas.microsoft.com/office/drawing/2014/main" id="{573541B3-83F3-4ADA-A401-90AC23E83D47}"/>
-              </a:ext>
-            </a:extLst>
-          </p:cNvPr>
-          <p:cNvSpPr>
-            <a:spLocks xmlns:a="http://schemas.openxmlformats.org/drawingml/2006/main" noGrp="1"/>
-          </p:cNvSpPr>
-          <p:nvPr/>
-        </p:nvSpPr>
-        <p:spPr>
-          <a:xfrm xmlns:a="http://schemas.openxmlformats.org/drawingml/2006/main">
-            <a:off x="13620750" y="8001000"/>
-            <a:ext cx="762000" cy="247650"/>
-          </a:xfrm>
-          <a:prstGeom xmlns:a="http://schemas.openxmlformats.org/drawingml/2006/main" prst="rect">
-            <a:avLst/>
-          </a:prstGeom>
-          <a:noFill xmlns:a="http://schemas.openxmlformats.org/drawingml/2006/main"/>
-          <a:ln xmlns:a="http://schemas.openxmlformats.org/drawingml/2006/main" w="0">
-            <a:noFill/>
-            <a:prstDash val="solid"/>
-          </a:ln>
-        </p:spPr>
-        <p:txBody>
-          <a:bodyPr xmlns:a="http://schemas.openxmlformats.org/drawingml/2006/main" wrap="square" lIns="0" tIns="0" rIns="0" bIns="0">
-            <a:noAutofit/>
-          </a:bodyPr>
-          <a:lstStyle xmlns:a="http://schemas.openxmlformats.org/drawingml/2006/main"/>
-          <a:p xmlns:a="http://schemas.openxmlformats.org/drawingml/2006/main">
-            <a:pPr algn="r">
-              <a:buNone/>
-              <a:defRPr sz="1350" b="1">
-                <a:solidFill>
-                  <a:srgbClr val="6D7974"/>
-                </a:solidFill>
-                <a:latin typeface="Menlo"/>
-                <a:ea typeface="Menlo"/>
-                <a:cs typeface="Menlo"/>
-              </a:defRPr>
-            </a:pPr>
-            <a:r>
-              <a:rPr sz="1350" b="1">
-                <a:solidFill>
-                  <a:srgbClr val="6D7974"/>
-                </a:solidFill>
-                <a:latin typeface="Menlo"/>
-                <a:ea typeface="Menlo"/>
-                <a:cs typeface="Menlo"/>
-              </a:rPr>
-              <a:t>11</a:t>
-            </a:r>
-          </a:p>
-        </p:txBody>
-      </p:sp>
     </p:spTree>
     <p:extLst>
       <p:ext uri="{BB962C8B-B14F-4D97-AF65-F5344CB8AC3E}">
-        <p14:creationId xmlns:p14="http://schemas.microsoft.com/office/powerpoint/2010/main" val="2091917452"/>
+        <p14:creationId xmlns:p14="http://schemas.microsoft.com/office/powerpoint/2010/main" val="614777387"/>
       </p:ext>
     </p:extLst>
   </p:cSld>
@@ -3853,7 +3469,7 @@
           <p:nvPr/>
         </p:nvPicPr>
         <p:blipFill>
-          <a:blip xmlns:r="http://schemas.openxmlformats.org/officeDocument/2006/relationships" xmlns:a="http://schemas.openxmlformats.org/drawingml/2006/main" r:embed="R9bffdb01cf344feb"/>
+          <a:blip xmlns:r="http://schemas.openxmlformats.org/officeDocument/2006/relationships" xmlns:a="http://schemas.openxmlformats.org/drawingml/2006/main" r:embed="Rfeb6ad0d739f4466"/>
           <a:srcRect xmlns:a="http://schemas.openxmlformats.org/drawingml/2006/main" l="0" t="0" r="0" b="0"/>
           <a:stretch xmlns:a="http://schemas.openxmlformats.org/drawingml/2006/main">
             <a:fillRect l="0" t="0" r="0" b="0"/>
@@ -3882,6 +3498,13 @@
 <file path=ppt/slides/slide13.xml><?xml version="1.0" encoding="utf-8"?>
 <p:sld xmlns:p="http://schemas.openxmlformats.org/presentationml/2006/main">
   <p:cSld>
+    <p:bg>
+      <p:bgPr>
+        <a:solidFill xmlns:a="http://schemas.openxmlformats.org/drawingml/2006/main">
+          <a:srgbClr val="F4EEE4"/>
+        </a:solidFill>
+      </p:bgPr>
+    </p:bg>
     <p:spTree>
       <p:nvGrpSpPr>
         <p:cNvPr id="1" name=""/>
@@ -3891,35 +3514,554 @@
       <p:grpSpPr>
         <a:xfrm xmlns:a="http://schemas.openxmlformats.org/drawingml/2006/main"/>
       </p:grpSpPr>
+      <p:sp>
+        <p:nvSpPr>
+          <p:cNvPr id="11" name="eyebrow-The live demo">
+            <a:extLst xmlns:a="http://schemas.openxmlformats.org/drawingml/2006/main">
+              <a:ext uri="{FF2B5EF4-FFF2-40B4-BE49-F238E27FC236}">
+                <a16:creationId xmlns:a16="http://schemas.microsoft.com/office/drawing/2014/main" id="{46635EF8-3618-4994-81BA-2542F409376A}"/>
+              </a:ext>
+            </a:extLst>
+          </p:cNvPr>
+          <p:cNvSpPr>
+            <a:spLocks xmlns:a="http://schemas.openxmlformats.org/drawingml/2006/main" noGrp="1"/>
+          </p:cNvSpPr>
+          <p:nvPr/>
+        </p:nvSpPr>
+        <p:spPr>
+          <a:xfrm xmlns:a="http://schemas.openxmlformats.org/drawingml/2006/main">
+            <a:off x="838200" y="590550"/>
+            <a:ext cx="8572500" cy="247650"/>
+          </a:xfrm>
+          <a:prstGeom xmlns:a="http://schemas.openxmlformats.org/drawingml/2006/main" prst="rect">
+            <a:avLst/>
+          </a:prstGeom>
+          <a:noFill xmlns:a="http://schemas.openxmlformats.org/drawingml/2006/main"/>
+          <a:ln xmlns:a="http://schemas.openxmlformats.org/drawingml/2006/main" w="0">
+            <a:noFill/>
+            <a:prstDash val="solid"/>
+          </a:ln>
+        </p:spPr>
+        <p:txBody>
+          <a:bodyPr xmlns:a="http://schemas.openxmlformats.org/drawingml/2006/main" wrap="square" lIns="0" tIns="0" rIns="0" bIns="0">
+            <a:noAutofit/>
+          </a:bodyPr>
+          <a:lstStyle xmlns:a="http://schemas.openxmlformats.org/drawingml/2006/main"/>
+          <a:p xmlns:a="http://schemas.openxmlformats.org/drawingml/2006/main">
+            <a:pPr>
+              <a:buNone/>
+              <a:defRPr sz="1350" b="1">
+                <a:solidFill>
+                  <a:srgbClr val="6D7974"/>
+                </a:solidFill>
+                <a:latin typeface="Menlo"/>
+                <a:ea typeface="Menlo"/>
+                <a:cs typeface="Menlo"/>
+              </a:defRPr>
+            </a:pPr>
+            <a:r>
+              <a:rPr sz="1350" b="1">
+                <a:solidFill>
+                  <a:srgbClr val="6D7974"/>
+                </a:solidFill>
+                <a:latin typeface="Menlo"/>
+                <a:ea typeface="Menlo"/>
+                <a:cs typeface="Menlo"/>
+              </a:rPr>
+              <a:t>BACKUP · TRUST CONTROLS</a:t>
+            </a:r>
+          </a:p>
+        </p:txBody>
+      </p:sp>
+      <p:sp>
+        <p:nvSpPr>
+          <p:cNvPr id="2" name="title-The AI recommends. The user confirms the exact terms.">
+            <a:extLst xmlns:a="http://schemas.openxmlformats.org/drawingml/2006/main">
+              <a:ext uri="{FF2B5EF4-FFF2-40B4-BE49-F238E27FC236}">
+                <a16:creationId xmlns:a16="http://schemas.microsoft.com/office/drawing/2014/main" id="{E6C7E214-CE49-432D-A6ED-84FB60003964}"/>
+              </a:ext>
+            </a:extLst>
+          </p:cNvPr>
+          <p:cNvSpPr>
+            <a:spLocks xmlns:a="http://schemas.openxmlformats.org/drawingml/2006/main" noGrp="1"/>
+          </p:cNvSpPr>
+          <p:nvPr/>
+        </p:nvSpPr>
+        <p:spPr>
+          <a:xfrm xmlns:a="http://schemas.openxmlformats.org/drawingml/2006/main">
+            <a:off x="838200" y="990600"/>
+            <a:ext cx="13525500" cy="1028700"/>
+          </a:xfrm>
+          <a:prstGeom xmlns:a="http://schemas.openxmlformats.org/drawingml/2006/main" prst="rect">
+            <a:avLst/>
+          </a:prstGeom>
+          <a:noFill xmlns:a="http://schemas.openxmlformats.org/drawingml/2006/main"/>
+          <a:ln xmlns:a="http://schemas.openxmlformats.org/drawingml/2006/main" w="0">
+            <a:noFill/>
+            <a:prstDash val="solid"/>
+          </a:ln>
+        </p:spPr>
+        <p:txBody>
+          <a:bodyPr xmlns:a="http://schemas.openxmlformats.org/drawingml/2006/main" wrap="square" lIns="0" tIns="0" rIns="0" bIns="0">
+            <a:noAutofit/>
+          </a:bodyPr>
+          <a:lstStyle xmlns:a="http://schemas.openxmlformats.org/drawingml/2006/main"/>
+          <a:p xmlns:a="http://schemas.openxmlformats.org/drawingml/2006/main">
+            <a:pPr>
+              <a:lnSpc>
+                <a:spcPct val="95000"/>
+              </a:lnSpc>
+              <a:buNone/>
+              <a:defRPr sz="4650" b="1">
+                <a:solidFill>
+                  <a:srgbClr val="0E4B3B"/>
+                </a:solidFill>
+                <a:latin typeface="Georgia"/>
+                <a:ea typeface="Georgia"/>
+                <a:cs typeface="Georgia"/>
+              </a:defRPr>
+            </a:pPr>
+            <a:r>
+              <a:rPr sz="4650" b="1">
+                <a:solidFill>
+                  <a:srgbClr val="0E4B3B"/>
+                </a:solidFill>
+                <a:latin typeface="Georgia"/>
+                <a:ea typeface="Georgia"/>
+                <a:cs typeface="Georgia"/>
+              </a:rPr>
+              <a:t>Trust is enforced at the purchase boundary.</a:t>
+            </a:r>
+          </a:p>
+        </p:txBody>
+      </p:sp>
+      <p:sp>
+        <p:nvSpPr>
+          <p:cNvPr id="3" name="boundary-statement">
+            <a:extLst xmlns:a="http://schemas.openxmlformats.org/drawingml/2006/main">
+              <a:ext uri="{FF2B5EF4-FFF2-40B4-BE49-F238E27FC236}">
+                <a16:creationId xmlns:a16="http://schemas.microsoft.com/office/drawing/2014/main" id="{64039A6F-00FA-4C7A-8407-F1FA78BFDFA5}"/>
+              </a:ext>
+            </a:extLst>
+          </p:cNvPr>
+          <p:cNvSpPr>
+            <a:spLocks xmlns:a="http://schemas.openxmlformats.org/drawingml/2006/main" noGrp="1"/>
+          </p:cNvSpPr>
+          <p:nvPr/>
+        </p:nvSpPr>
+        <p:spPr>
+          <a:xfrm xmlns:a="http://schemas.openxmlformats.org/drawingml/2006/main">
+            <a:off x="838200" y="2895600"/>
+            <a:ext cx="4191000" cy="1371600"/>
+          </a:xfrm>
+          <a:prstGeom xmlns:a="http://schemas.openxmlformats.org/drawingml/2006/main" prst="rect">
+            <a:avLst/>
+          </a:prstGeom>
+          <a:noFill xmlns:a="http://schemas.openxmlformats.org/drawingml/2006/main"/>
+          <a:ln xmlns:a="http://schemas.openxmlformats.org/drawingml/2006/main" w="0">
+            <a:noFill/>
+            <a:prstDash val="solid"/>
+          </a:ln>
+        </p:spPr>
+        <p:txBody>
+          <a:bodyPr xmlns:a="http://schemas.openxmlformats.org/drawingml/2006/main" wrap="square" lIns="0" tIns="0" rIns="0" bIns="0">
+            <a:noAutofit/>
+          </a:bodyPr>
+          <a:lstStyle xmlns:a="http://schemas.openxmlformats.org/drawingml/2006/main"/>
+          <a:p xmlns:a="http://schemas.openxmlformats.org/drawingml/2006/main">
+            <a:pPr>
+              <a:lnSpc>
+                <a:spcPct val="95000"/>
+              </a:lnSpc>
+              <a:buNone/>
+              <a:defRPr sz="3150" b="1">
+                <a:solidFill>
+                  <a:srgbClr val="0E4B3B"/>
+                </a:solidFill>
+                <a:latin typeface="Georgia"/>
+                <a:ea typeface="Georgia"/>
+                <a:cs typeface="Georgia"/>
+              </a:defRPr>
+            </a:pPr>
+            <a:r>
+              <a:rPr sz="3150" b="1">
+                <a:solidFill>
+                  <a:srgbClr val="0E4B3B"/>
+                </a:solidFill>
+                <a:latin typeface="Georgia"/>
+                <a:ea typeface="Georgia"/>
+                <a:cs typeface="Georgia"/>
+              </a:rPr>
+              <a:t>Exact terms are bound.</a:t>
+            </a:r>
+          </a:p>
+          <a:p xmlns:a="http://schemas.openxmlformats.org/drawingml/2006/main">
+            <a:pPr>
+              <a:lnSpc>
+                <a:spcPct val="95000"/>
+              </a:lnSpc>
+              <a:buNone/>
+              <a:defRPr sz="3150" b="1">
+                <a:solidFill>
+                  <a:srgbClr val="0E4B3B"/>
+                </a:solidFill>
+                <a:latin typeface="Georgia"/>
+                <a:ea typeface="Georgia"/>
+                <a:cs typeface="Georgia"/>
+              </a:defRPr>
+            </a:pPr>
+            <a:r>
+              <a:rPr sz="3150" b="1">
+                <a:solidFill>
+                  <a:srgbClr val="0E4B3B"/>
+                </a:solidFill>
+                <a:latin typeface="Georgia"/>
+                <a:ea typeface="Georgia"/>
+                <a:cs typeface="Georgia"/>
+              </a:rPr>
+              <a:t>Only the user confirms.</a:t>
+            </a:r>
+          </a:p>
+        </p:txBody>
+      </p:sp>
+      <p:sp>
+        <p:nvSpPr>
+          <p:cNvPr id="4" name="simulated-label">
+            <a:extLst xmlns:a="http://schemas.openxmlformats.org/drawingml/2006/main">
+              <a:ext uri="{FF2B5EF4-FFF2-40B4-BE49-F238E27FC236}">
+                <a16:creationId xmlns:a16="http://schemas.microsoft.com/office/drawing/2014/main" id="{906B7775-6C73-4936-919D-C949C0ED9DEE}"/>
+              </a:ext>
+            </a:extLst>
+          </p:cNvPr>
+          <p:cNvSpPr>
+            <a:spLocks xmlns:a="http://schemas.openxmlformats.org/drawingml/2006/main" noGrp="1"/>
+          </p:cNvSpPr>
+          <p:nvPr/>
+        </p:nvSpPr>
+        <p:spPr>
+          <a:xfrm xmlns:a="http://schemas.openxmlformats.org/drawingml/2006/main">
+            <a:off x="838200" y="4724400"/>
+            <a:ext cx="3143250" cy="514350"/>
+          </a:xfrm>
+          <a:prstGeom xmlns:a="http://schemas.openxmlformats.org/drawingml/2006/main" prst="roundRect">
+            <a:avLst>
+              <a:gd name="adj" fmla="val 50000"/>
+            </a:avLst>
+          </a:prstGeom>
+          <a:solidFill xmlns:a="http://schemas.openxmlformats.org/drawingml/2006/main">
+            <a:srgbClr val="1545E8"/>
+          </a:solidFill>
+          <a:ln xmlns:a="http://schemas.openxmlformats.org/drawingml/2006/main" w="0">
+            <a:noFill/>
+            <a:prstDash val="solid"/>
+          </a:ln>
+        </p:spPr>
+      </p:sp>
+      <p:sp>
+        <p:nvSpPr>
+          <p:cNvPr id="5" name="simulated-label-text">
+            <a:extLst xmlns:a="http://schemas.openxmlformats.org/drawingml/2006/main">
+              <a:ext uri="{FF2B5EF4-FFF2-40B4-BE49-F238E27FC236}">
+                <a16:creationId xmlns:a16="http://schemas.microsoft.com/office/drawing/2014/main" id="{0DCF3A62-833F-4EDD-B0B4-4EEFB00BFC41}"/>
+              </a:ext>
+            </a:extLst>
+          </p:cNvPr>
+          <p:cNvSpPr>
+            <a:spLocks xmlns:a="http://schemas.openxmlformats.org/drawingml/2006/main" noGrp="1"/>
+          </p:cNvSpPr>
+          <p:nvPr/>
+        </p:nvSpPr>
+        <p:spPr>
+          <a:xfrm xmlns:a="http://schemas.openxmlformats.org/drawingml/2006/main">
+            <a:off x="1028700" y="4876800"/>
+            <a:ext cx="2762250" cy="228600"/>
+          </a:xfrm>
+          <a:prstGeom xmlns:a="http://schemas.openxmlformats.org/drawingml/2006/main" prst="rect">
+            <a:avLst/>
+          </a:prstGeom>
+          <a:noFill xmlns:a="http://schemas.openxmlformats.org/drawingml/2006/main"/>
+          <a:ln xmlns:a="http://schemas.openxmlformats.org/drawingml/2006/main" w="0">
+            <a:noFill/>
+            <a:prstDash val="solid"/>
+          </a:ln>
+        </p:spPr>
+        <p:txBody>
+          <a:bodyPr xmlns:a="http://schemas.openxmlformats.org/drawingml/2006/main" wrap="square" lIns="0" tIns="0" rIns="0" bIns="0">
+            <a:noAutofit/>
+          </a:bodyPr>
+          <a:lstStyle xmlns:a="http://schemas.openxmlformats.org/drawingml/2006/main"/>
+          <a:p xmlns:a="http://schemas.openxmlformats.org/drawingml/2006/main">
+            <a:pPr algn="ctr">
+              <a:buNone/>
+              <a:defRPr sz="1275" b="1">
+                <a:solidFill>
+                  <a:srgbClr val="FFFFFF"/>
+                </a:solidFill>
+                <a:latin typeface="Menlo"/>
+                <a:ea typeface="Menlo"/>
+                <a:cs typeface="Menlo"/>
+              </a:defRPr>
+            </a:pPr>
+            <a:r>
+              <a:rPr sz="1275" b="1">
+                <a:solidFill>
+                  <a:srgbClr val="FFFFFF"/>
+                </a:solidFill>
+                <a:latin typeface="Menlo"/>
+                <a:ea typeface="Menlo"/>
+                <a:cs typeface="Menlo"/>
+              </a:rPr>
+              <a:t>IDENTITY · SIMULATED / ENFORCED</a:t>
+            </a:r>
+          </a:p>
+        </p:txBody>
+      </p:sp>
+      <p:sp>
+        <p:nvSpPr>
+          <p:cNvPr id="6" name="exact-terms">
+            <a:extLst xmlns:a="http://schemas.openxmlformats.org/drawingml/2006/main">
+              <a:ext uri="{FF2B5EF4-FFF2-40B4-BE49-F238E27FC236}">
+                <a16:creationId xmlns:a16="http://schemas.microsoft.com/office/drawing/2014/main" id="{24D4E798-F7E3-4205-9A3C-908586EEA799}"/>
+              </a:ext>
+            </a:extLst>
+          </p:cNvPr>
+          <p:cNvSpPr>
+            <a:spLocks xmlns:a="http://schemas.openxmlformats.org/drawingml/2006/main" noGrp="1"/>
+          </p:cNvSpPr>
+          <p:nvPr/>
+        </p:nvSpPr>
+        <p:spPr>
+          <a:xfrm xmlns:a="http://schemas.openxmlformats.org/drawingml/2006/main">
+            <a:off x="838200" y="5638800"/>
+            <a:ext cx="3810000" cy="1104900"/>
+          </a:xfrm>
+          <a:prstGeom xmlns:a="http://schemas.openxmlformats.org/drawingml/2006/main" prst="rect">
+            <a:avLst/>
+          </a:prstGeom>
+          <a:noFill xmlns:a="http://schemas.openxmlformats.org/drawingml/2006/main"/>
+          <a:ln xmlns:a="http://schemas.openxmlformats.org/drawingml/2006/main" w="0">
+            <a:noFill/>
+            <a:prstDash val="solid"/>
+          </a:ln>
+        </p:spPr>
+        <p:txBody>
+          <a:bodyPr xmlns:a="http://schemas.openxmlformats.org/drawingml/2006/main" wrap="square" lIns="0" tIns="0" rIns="0" bIns="0">
+            <a:noAutofit/>
+          </a:bodyPr>
+          <a:lstStyle xmlns:a="http://schemas.openxmlformats.org/drawingml/2006/main"/>
+          <a:p xmlns:a="http://schemas.openxmlformats.org/drawingml/2006/main">
+            <a:pPr>
+              <a:lnSpc>
+                <a:spcPct val="118000"/>
+              </a:lnSpc>
+              <a:buNone/>
+              <a:defRPr sz="1800">
+                <a:solidFill>
+                  <a:srgbClr val="6D7974"/>
+                </a:solidFill>
+                <a:latin typeface="Avenir Next"/>
+                <a:ea typeface="Avenir Next"/>
+                <a:cs typeface="Avenir Next"/>
+              </a:defRPr>
+            </a:pPr>
+            <a:r>
+              <a:rPr sz="1800">
+                <a:solidFill>
+                  <a:srgbClr val="6D7974"/>
+                </a:solidFill>
+                <a:latin typeface="Avenir Next"/>
+                <a:ea typeface="Avenir Next"/>
+                <a:cs typeface="Avenir Next"/>
+              </a:rPr>
+              <a:t>Price + stock rechecked · mandate expires · private nonce
+Idempotent order · simulated reversal</a:t>
+            </a:r>
+          </a:p>
+        </p:txBody>
+      </p:sp>
+      <p:sp>
+        <p:nvSpPr>
+          <p:cNvPr id="7" name="Woven checkout mandate showing exact terms and explicit confirmation-backplate">
+            <a:extLst xmlns:a="http://schemas.openxmlformats.org/drawingml/2006/main">
+              <a:ext uri="{FF2B5EF4-FFF2-40B4-BE49-F238E27FC236}">
+                <a16:creationId xmlns:a16="http://schemas.microsoft.com/office/drawing/2014/main" id="{8ADD3CA5-C1ED-4601-B88F-C6932A9AEDCB}"/>
+              </a:ext>
+            </a:extLst>
+          </p:cNvPr>
+          <p:cNvSpPr>
+            <a:spLocks xmlns:a="http://schemas.openxmlformats.org/drawingml/2006/main" noGrp="1"/>
+          </p:cNvSpPr>
+          <p:nvPr/>
+        </p:nvSpPr>
+        <p:spPr>
+          <a:xfrm xmlns:a="http://schemas.openxmlformats.org/drawingml/2006/main">
+            <a:off x="5095875" y="2362200"/>
+            <a:ext cx="9191625" cy="5257800"/>
+          </a:xfrm>
+          <a:prstGeom xmlns:a="http://schemas.openxmlformats.org/drawingml/2006/main" prst="roundRect">
+            <a:avLst>
+              <a:gd name="adj" fmla="val 4348"/>
+            </a:avLst>
+          </a:prstGeom>
+          <a:solidFill xmlns:a="http://schemas.openxmlformats.org/drawingml/2006/main">
+            <a:srgbClr val="FFFFFF"/>
+          </a:solidFill>
+          <a:ln xmlns:a="http://schemas.openxmlformats.org/drawingml/2006/main" w="0">
+            <a:noFill/>
+            <a:prstDash val="solid"/>
+          </a:ln>
+        </p:spPr>
+        <p:style>
+          <a:lnRef xmlns:a="http://schemas.openxmlformats.org/drawingml/2006/main" idx="0"/>
+          <a:fillRef xmlns:a="http://schemas.openxmlformats.org/drawingml/2006/main" idx="0"/>
+          <a:effectRef xmlns:a="http://schemas.openxmlformats.org/drawingml/2006/main" idx="7"/>
+          <a:fontRef xmlns:a="http://schemas.openxmlformats.org/drawingml/2006/main" idx="major"/>
+        </p:style>
+      </p:sp>
       <p:pic>
         <p:nvPicPr>
-          <p:cNvPr id="2" name=""/>
+          <p:cNvPr id="20" name=""/>
           <p:cNvPicPr>
             <a:picLocks xmlns:a="http://schemas.openxmlformats.org/drawingml/2006/main" noChangeAspect="1"/>
           </p:cNvPicPr>
           <p:nvPr/>
         </p:nvPicPr>
         <p:blipFill>
-          <a:blip xmlns:r="http://schemas.openxmlformats.org/officeDocument/2006/relationships" xmlns:a="http://schemas.openxmlformats.org/drawingml/2006/main" r:embed="R9bffdb01cf344feb"/>
-          <a:srcRect xmlns:a="http://schemas.openxmlformats.org/drawingml/2006/main" l="0" t="0" r="0" b="0"/>
-          <a:stretch xmlns:a="http://schemas.openxmlformats.org/drawingml/2006/main">
-            <a:fillRect l="0" t="0" r="0" b="0"/>
-          </a:stretch>
+          <a:blip xmlns:r="http://schemas.openxmlformats.org/officeDocument/2006/relationships" xmlns:a="http://schemas.openxmlformats.org/drawingml/2006/main" r:embed="R074f1bc9237c42c5"/>
+          <a:stretch xmlns:a="http://schemas.openxmlformats.org/drawingml/2006/main"/>
         </p:blipFill>
         <p:spPr>
           <a:xfrm xmlns:a="http://schemas.openxmlformats.org/drawingml/2006/main" flipH="0" flipV="0">
-            <a:off x="0" y="0"/>
-            <a:ext cx="15240000" cy="8572500"/>
-          </a:xfrm>
-          <a:prstGeom xmlns:a="http://schemas.openxmlformats.org/drawingml/2006/main" prst="rect">
+            <a:off x="5191125" y="2459534"/>
+            <a:ext cx="9001125" cy="5063133"/>
+          </a:xfrm>
+          <a:prstGeom xmlns:a="http://schemas.openxmlformats.org/drawingml/2006/main" prst="roundRect">
             <a:avLst/>
           </a:prstGeom>
         </p:spPr>
       </p:pic>
+      <p:sp>
+        <p:nvSpPr>
+          <p:cNvPr id="9" name="footer-label-6">
+            <a:extLst xmlns:a="http://schemas.openxmlformats.org/drawingml/2006/main">
+              <a:ext uri="{FF2B5EF4-FFF2-40B4-BE49-F238E27FC236}">
+                <a16:creationId xmlns:a16="http://schemas.microsoft.com/office/drawing/2014/main" id="{180E82C5-4959-4CB6-9B7C-CA48FE5A4C58}"/>
+              </a:ext>
+            </a:extLst>
+          </p:cNvPr>
+          <p:cNvSpPr>
+            <a:spLocks xmlns:a="http://schemas.openxmlformats.org/drawingml/2006/main" noGrp="1"/>
+          </p:cNvSpPr>
+          <p:nvPr/>
+        </p:nvSpPr>
+        <p:spPr>
+          <a:xfrm xmlns:a="http://schemas.openxmlformats.org/drawingml/2006/main">
+            <a:off x="838200" y="8020050"/>
+            <a:ext cx="5334000" cy="228600"/>
+          </a:xfrm>
+          <a:prstGeom xmlns:a="http://schemas.openxmlformats.org/drawingml/2006/main" prst="rect">
+            <a:avLst/>
+          </a:prstGeom>
+          <a:noFill xmlns:a="http://schemas.openxmlformats.org/drawingml/2006/main"/>
+          <a:ln xmlns:a="http://schemas.openxmlformats.org/drawingml/2006/main" w="0">
+            <a:noFill/>
+            <a:prstDash val="solid"/>
+          </a:ln>
+        </p:spPr>
+        <p:txBody>
+          <a:bodyPr xmlns:a="http://schemas.openxmlformats.org/drawingml/2006/main" wrap="square" lIns="0" tIns="0" rIns="0" bIns="0">
+            <a:noAutofit/>
+          </a:bodyPr>
+          <a:lstStyle xmlns:a="http://schemas.openxmlformats.org/drawingml/2006/main"/>
+          <a:p xmlns:a="http://schemas.openxmlformats.org/drawingml/2006/main">
+            <a:pPr>
+              <a:buNone/>
+              <a:defRPr sz="1200" b="1">
+                <a:solidFill>
+                  <a:srgbClr val="6D7974"/>
+                </a:solidFill>
+                <a:latin typeface="Menlo"/>
+                <a:ea typeface="Menlo"/>
+                <a:cs typeface="Menlo"/>
+              </a:defRPr>
+            </a:pPr>
+            <a:r>
+              <a:rPr sz="1200" b="1">
+                <a:solidFill>
+                  <a:srgbClr val="6D7974"/>
+                </a:solidFill>
+                <a:latin typeface="Menlo"/>
+                <a:ea typeface="Menlo"/>
+                <a:cs typeface="Menlo"/>
+              </a:rPr>
+              <a:t>WOVEN  /  LIFEHACK 2026</a:t>
+            </a:r>
+          </a:p>
+        </p:txBody>
+      </p:sp>
+      <p:sp>
+        <p:nvSpPr>
+          <p:cNvPr id="10" name="footer-number-6">
+            <a:extLst xmlns:a="http://schemas.openxmlformats.org/drawingml/2006/main">
+              <a:ext uri="{FF2B5EF4-FFF2-40B4-BE49-F238E27FC236}">
+                <a16:creationId xmlns:a16="http://schemas.microsoft.com/office/drawing/2014/main" id="{573541B3-83F3-4ADA-A401-90AC23E83D47}"/>
+              </a:ext>
+            </a:extLst>
+          </p:cNvPr>
+          <p:cNvSpPr>
+            <a:spLocks xmlns:a="http://schemas.openxmlformats.org/drawingml/2006/main" noGrp="1"/>
+          </p:cNvSpPr>
+          <p:nvPr/>
+        </p:nvSpPr>
+        <p:spPr>
+          <a:xfrm xmlns:a="http://schemas.openxmlformats.org/drawingml/2006/main">
+            <a:off x="13620750" y="8001000"/>
+            <a:ext cx="762000" cy="247650"/>
+          </a:xfrm>
+          <a:prstGeom xmlns:a="http://schemas.openxmlformats.org/drawingml/2006/main" prst="rect">
+            <a:avLst/>
+          </a:prstGeom>
+          <a:noFill xmlns:a="http://schemas.openxmlformats.org/drawingml/2006/main"/>
+          <a:ln xmlns:a="http://schemas.openxmlformats.org/drawingml/2006/main" w="0">
+            <a:noFill/>
+            <a:prstDash val="solid"/>
+          </a:ln>
+        </p:spPr>
+        <p:txBody>
+          <a:bodyPr xmlns:a="http://schemas.openxmlformats.org/drawingml/2006/main" wrap="square" lIns="0" tIns="0" rIns="0" bIns="0">
+            <a:noAutofit/>
+          </a:bodyPr>
+          <a:lstStyle xmlns:a="http://schemas.openxmlformats.org/drawingml/2006/main"/>
+          <a:p xmlns:a="http://schemas.openxmlformats.org/drawingml/2006/main">
+            <a:pPr algn="r">
+              <a:buNone/>
+              <a:defRPr sz="1350" b="1">
+                <a:solidFill>
+                  <a:srgbClr val="6D7974"/>
+                </a:solidFill>
+                <a:latin typeface="Menlo"/>
+                <a:ea typeface="Menlo"/>
+                <a:cs typeface="Menlo"/>
+              </a:defRPr>
+            </a:pPr>
+            <a:r>
+              <a:rPr sz="1350" b="1">
+                <a:solidFill>
+                  <a:srgbClr val="6D7974"/>
+                </a:solidFill>
+                <a:latin typeface="Menlo"/>
+                <a:ea typeface="Menlo"/>
+                <a:cs typeface="Menlo"/>
+              </a:rPr>
+              <a:t>11</a:t>
+            </a:r>
+          </a:p>
+        </p:txBody>
+      </p:sp>
     </p:spTree>
     <p:extLst>
       <p:ext uri="{BB962C8B-B14F-4D97-AF65-F5344CB8AC3E}">
-        <p14:creationId xmlns:p14="http://schemas.microsoft.com/office/powerpoint/2010/main" val="614777387"/>
+        <p14:creationId xmlns:p14="http://schemas.microsoft.com/office/powerpoint/2010/main" val="2091917452"/>
       </p:ext>
     </p:extLst>
   </p:cSld>
@@ -5432,7 +5574,7 @@
           <p:nvPr/>
         </p:nvPicPr>
         <p:blipFill>
-          <a:blip xmlns:r="http://schemas.openxmlformats.org/officeDocument/2006/relationships" xmlns:a="http://schemas.openxmlformats.org/drawingml/2006/main" r:embed="R815bc04db61343b4"/>
+          <a:blip xmlns:r="http://schemas.openxmlformats.org/officeDocument/2006/relationships" xmlns:a="http://schemas.openxmlformats.org/drawingml/2006/main" r:embed="Rb2673b238a614f90"/>
           <a:stretch xmlns:a="http://schemas.openxmlformats.org/drawingml/2006/main"/>
         </p:blipFill>
         <p:spPr>
@@ -6684,8 +6826,8 @@
                 <a:ea typeface="Georgia"/>
                 <a:cs typeface="Georgia"/>
               </a:rPr>
-              <a:t>Identity is the
-next integration.</a:t>
+              <a:t>Two separate
+trust gates.</a:t>
             </a:r>
           </a:p>
         </p:txBody>
@@ -6834,7 +6976,7 @@
                 <a:ea typeface="Avenir Next"/>
                 <a:cs typeface="Avenir Next"/>
               </a:rPr>
-              <a:t>Verify identity</a:t>
+              <a:t>Verify demo identity</a:t>
             </a:r>
           </a:p>
         </p:txBody>
@@ -6896,7 +7038,7 @@
                 <a:ea typeface="Avenir Next"/>
                 <a:cs typeface="Avenir Next"/>
               </a:rPr>
-              <a:t>PLANNED — server-enforced before checkout; not in the live demo.</a:t>
+              <a:t>WORKING · SIMULATED — server-enforced before checkout.</a:t>
             </a:r>
           </a:p>
         </p:txBody>
@@ -8111,7 +8253,7 @@
           <p:nvPr/>
         </p:nvPicPr>
         <p:blipFill>
-          <a:blip xmlns:r="http://schemas.openxmlformats.org/officeDocument/2006/relationships" xmlns:a="http://schemas.openxmlformats.org/drawingml/2006/main" r:embed="Rf6c24c0f2c7d4d70"/>
+          <a:blip xmlns:r="http://schemas.openxmlformats.org/officeDocument/2006/relationships" xmlns:a="http://schemas.openxmlformats.org/drawingml/2006/main" r:embed="R0813db945132474f"/>
           <a:stretch xmlns:a="http://schemas.openxmlformats.org/drawingml/2006/main"/>
         </p:blipFill>
         <p:spPr>
@@ -8761,7 +8903,7 @@
           <p:nvPr/>
         </p:nvPicPr>
         <p:blipFill>
-          <a:blip xmlns:r="http://schemas.openxmlformats.org/officeDocument/2006/relationships" xmlns:a="http://schemas.openxmlformats.org/drawingml/2006/main" r:embed="R442128613b45476b"/>
+          <a:blip xmlns:r="http://schemas.openxmlformats.org/officeDocument/2006/relationships" xmlns:a="http://schemas.openxmlformats.org/drawingml/2006/main" r:embed="Rc12bc406cbad4e09"/>
           <a:stretch xmlns:a="http://schemas.openxmlformats.org/drawingml/2006/main"/>
         </p:blipFill>
         <p:spPr>
@@ -8828,7 +8970,7 @@
                 <a:ea typeface="Menlo"/>
                 <a:cs typeface="Menlo"/>
               </a:rPr>
-              <a:t>IDENTITY PLANNED · VISA AUTHORIZATION SIMULATED</a:t>
+              <a:t>DEMO IDENTITY · VISA AUTHORIZATION · SIMULATED</a:t>
             </a:r>
           </a:p>
         </p:txBody>
@@ -9525,7 +9667,7 @@
                 <a:ea typeface="Avenir Next"/>
                 <a:cs typeface="Avenir Next"/>
               </a:rPr>
-              <a:t>Expiring exact terms.
+              <a:t>Demo identity + expiring exact terms.
 Direct confirmation · idempotency.</a:t>
             </a:r>
           </a:p>
@@ -10101,7 +10243,8 @@
                 <a:ea typeface="Georgia"/>
                 <a:cs typeface="Georgia"/>
               </a:rPr>
-              <a:t>The prototype never claims live identity, inventory or payments.</a:t>
+              <a:t>No live Visa identity,
+inventory, or payments.</a:t>
             </a:r>
           </a:p>
         </p:txBody>
@@ -10468,7 +10611,7 @@
                 <a:ea typeface="Georgia"/>
                 <a:cs typeface="Georgia"/>
               </a:rPr>
-              <a:t>Identity direction</a:t>
+              <a:t>Demo identity</a:t>
             </a:r>
           </a:p>
         </p:txBody>
@@ -10530,8 +10673,8 @@
                 <a:ea typeface="Avenir Next"/>
                 <a:cs typeface="Avenir Next"/>
               </a:rPr>
-              <a:t>Connector-style check is planned
-and not in the live demo.</a:t>
+              <a:t>Server-enforced before checkout.
+Clearly simulated; no credentials.</a:t>
             </a:r>
           </a:p>
         </p:txBody>

</xml_diff>

<commit_message>
docs(chore): preserve choice-suite submission assets
Summary:
- preserve the judge deck, Devpost copy, screenshots, and campaign artwork
- retain the matching stage script and architecture visual source

Rationale:
- capture the original presentation work before reconciling it with current main

Tests:
- not run (preservation commit before rebase)
</commit_message>
<xml_diff>
--- a/docs/Woven-Hackathon-Pitch.pptx
+++ b/docs/Woven-Hackathon-Pitch.pptx
@@ -2,25 +2,23 @@
 <file path=ppt/presentation.xml><?xml version="1.0" encoding="utf-8"?>
 <p:presentation xmlns:p="http://schemas.openxmlformats.org/presentationml/2006/main">
   <p:sldMasterIdLst>
-    <p:sldMasterId xmlns:r="http://schemas.openxmlformats.org/officeDocument/2006/relationships" id="2147483648" r:id="Rbd7b917bceef459a"/>
+    <p:sldMasterId xmlns:r="http://schemas.openxmlformats.org/officeDocument/2006/relationships" id="2147483648" r:id="R2fc6e8e20c084646"/>
   </p:sldMasterIdLst>
   <p:notesMasterIdLst>
-    <p:notesMasterId xmlns:r="http://schemas.openxmlformats.org/officeDocument/2006/relationships" r:id="Reb6cee3a506b43cf"/>
+    <p:notesMasterId xmlns:r="http://schemas.openxmlformats.org/officeDocument/2006/relationships" r:id="R91b2626ac2ad4dc0"/>
   </p:notesMasterIdLst>
   <p:sldIdLst>
-    <p:sldId xmlns:r="http://schemas.openxmlformats.org/officeDocument/2006/relationships" id="256" r:id="R5326ca9495684228"/>
-    <p:sldId xmlns:r="http://schemas.openxmlformats.org/officeDocument/2006/relationships" id="257" r:id="R7129933df5f84180"/>
-    <p:sldId xmlns:r="http://schemas.openxmlformats.org/officeDocument/2006/relationships" id="258" r:id="Ree048974157b4473"/>
-    <p:sldId xmlns:r="http://schemas.openxmlformats.org/officeDocument/2006/relationships" id="259" r:id="Rfbc0c85f698f4fa6"/>
-    <p:sldId xmlns:r="http://schemas.openxmlformats.org/officeDocument/2006/relationships" id="260" r:id="R4aba994753af4d4e"/>
-    <p:sldId xmlns:r="http://schemas.openxmlformats.org/officeDocument/2006/relationships" id="261" r:id="R1293d76b0bb24c15"/>
-    <p:sldId xmlns:r="http://schemas.openxmlformats.org/officeDocument/2006/relationships" id="262" r:id="R7b5ce42f81a54f6f"/>
-    <p:sldId xmlns:r="http://schemas.openxmlformats.org/officeDocument/2006/relationships" id="263" r:id="R42e87175a6a34fd9"/>
-    <p:sldId xmlns:r="http://schemas.openxmlformats.org/officeDocument/2006/relationships" id="264" r:id="R37dfb12e7e61470d"/>
-    <p:sldId xmlns:r="http://schemas.openxmlformats.org/officeDocument/2006/relationships" id="267" r:id="Rab12cd34ef567801"/>
-    <p:sldId xmlns:r="http://schemas.openxmlformats.org/officeDocument/2006/relationships" id="268" r:id="Rab12cd34ef567802"/>
-    <p:sldId xmlns:r="http://schemas.openxmlformats.org/officeDocument/2006/relationships" id="265" r:id="R43bbd7ed52b947d6"/>
-    <p:sldId xmlns:r="http://schemas.openxmlformats.org/officeDocument/2006/relationships" id="266" r:id="R6026b644a94e4a72"/>
+    <p:sldId xmlns:r="http://schemas.openxmlformats.org/officeDocument/2006/relationships" id="256" r:id="Rb4039db9e0344b88"/>
+    <p:sldId xmlns:r="http://schemas.openxmlformats.org/officeDocument/2006/relationships" id="257" r:id="R95ec7d74113a47dd"/>
+    <p:sldId xmlns:r="http://schemas.openxmlformats.org/officeDocument/2006/relationships" id="258" r:id="R727ef281f7534dd1"/>
+    <p:sldId xmlns:r="http://schemas.openxmlformats.org/officeDocument/2006/relationships" id="259" r:id="Rc2184f7aa1004714"/>
+    <p:sldId xmlns:r="http://schemas.openxmlformats.org/officeDocument/2006/relationships" id="260" r:id="Rf88b69f22c664df3"/>
+    <p:sldId xmlns:r="http://schemas.openxmlformats.org/officeDocument/2006/relationships" id="261" r:id="Rc86b445fd6774c61"/>
+    <p:sldId xmlns:r="http://schemas.openxmlformats.org/officeDocument/2006/relationships" id="262" r:id="R58dfaf1ab8e04ed8"/>
+    <p:sldId xmlns:r="http://schemas.openxmlformats.org/officeDocument/2006/relationships" id="263" r:id="Rd6ca70c8c5dd45fa"/>
+    <p:sldId xmlns:r="http://schemas.openxmlformats.org/officeDocument/2006/relationships" id="264" r:id="Ra37853021f864bc4"/>
+    <p:sldId xmlns:r="http://schemas.openxmlformats.org/officeDocument/2006/relationships" id="265" r:id="R015fd678ca324916"/>
+    <p:sldId xmlns:r="http://schemas.openxmlformats.org/officeDocument/2006/relationships" id="266" r:id="R4006603162ad4636"/>
   </p:sldIdLst>
   <p:sldSz cx="15240000" cy="8572500"/>
   <p:notesSz cx="6858000" cy="9144000"/>
@@ -1009,7 +1007,7 @@
           </a:p>
           <a:p xmlns:a="http://schemas.openxmlformats.org/drawingml/2006/main">
             <a:r>
-              <a:t>“Woven understands the complete request, eliminates incompatible combinations, and creates ready-to-buy carts. Every cart comes from one merchant and one location, with an explanation of why every component works.”</a:t>
+              <a:t>“Woven understands the complete request, eliminates incompatible combinations, and creates five ready-to-buy choices in one comparison workspace. Every cart comes from one merchant and one location, with an explanation of why every component works.”</a:t>
             </a:r>
           </a:p>
           <a:p xmlns:a="http://schemas.openxmlformats.org/drawingml/2006/main">
@@ -1024,7 +1022,7 @@
           </a:p>
           <a:p xmlns:a="http://schemas.openxmlformats.org/drawingml/2006/main">
             <a:r>
-              <a:t>One merchant and pickup point. Four compatible components. S$133 total. Pickup today.</a:t>
+              <a:t>Compare priorities and pickup areas. One merchant and pickup point. Four compatible components. S$133 total. Pickup today.</a:t>
             </a:r>
           </a:p>
           <a:p xmlns:a="http://schemas.openxmlformats.org/drawingml/2006/main">
@@ -1174,17 +1172,17 @@
           </a:p>
           <a:p xmlns:a="http://schemas.openxmlformats.org/drawingml/2006/main">
             <a:r>
-              <a:t>1. Show the three ranked, one-merchant carts.</a:t>
-            </a:r>
-          </a:p>
-          <a:p xmlns:a="http://schemas.openxmlformats.org/drawingml/2006/main">
-            <a:r>
-              <a:t>2. Select ByteRoute.</a:t>
-            </a:r>
-          </a:p>
-          <a:p xmlns:a="http://schemas.openxmlformats.org/drawingml/2006/main">
-            <a:r>
-              <a:t>3. Point to charger wattage and voltage, both required cables, the Japan adapter, one pickup location, seeded demo stock, and the S$133 total.</a:t>
+              <a:t>1. Open the five-choice Choice Center.</a:t>
+            </a:r>
+          </a:p>
+          <a:p xmlns:a="http://schemas.openxmlformats.org/drawingml/2006/main">
+            <a:r>
+              <a:t>2. Compare carts, rerank by pickup or value, and return to Best match.</a:t>
+            </a:r>
+          </a:p>
+          <a:p xmlns:a="http://schemas.openxmlformats.org/drawingml/2006/main">
+            <a:r>
+              <a:t>3. Select ByteRoute, point to “Why this works,” make the approved cable swap, and show the pickup planner.</a:t>
             </a:r>
           </a:p>
           <a:p xmlns:a="http://schemas.openxmlformats.org/drawingml/2006/main">
@@ -1199,7 +1197,7 @@
           </a:p>
           <a:p xmlns:a="http://schemas.openxmlformats.org/drawingml/2006/main">
             <a:r>
-              <a:t>“Woven returned three complete options—not loose product links. This S$133 cart includes the charger, both required cables, and the Japan adapter. Everything is compatible, under budget, available in our demo inventory, and ready at one pickup location.”</a:t>
+              <a:t>“Woven returned five complete choices—not loose product links. I can compare exact carts, change priorities, and make only merchant-approved compatible swaps without rebuilding the request.”</a:t>
             </a:r>
           </a:p>
           <a:p xmlns:a="http://schemas.openxmlformats.org/drawingml/2006/main">
@@ -1214,7 +1212,7 @@
           </a:p>
           <a:p xmlns:a="http://schemas.openxmlformats.org/drawingml/2006/main">
             <a:r>
-              <a:t>Do not explain the ranking algorithm unless asked. If the MCP host fails, move immediately to /demo; it uses the same backend.</a:t>
+              <a:t>If the MCP host fails, move immediately to /demo; it uses the same backend.</a:t>
             </a:r>
           </a:p>
           <a:p xmlns:a="http://schemas.openxmlformats.org/drawingml/2006/main">
@@ -1349,7 +1347,7 @@
           </a:p>
           <a:p xmlns:a="http://schemas.openxmlformats.org/drawingml/2006/main">
             <a:r>
-              <a:t>4. Confirm and show the simulated Visa authorization result and pickup receipt.</a:t>
+              <a:t>4. Confirm and show the simulated Visa result and exact signed receipt.</a:t>
             </a:r>
           </a:p>
           <a:p xmlns:a="http://schemas.openxmlformats.org/drawingml/2006/main">
@@ -1364,7 +1362,7 @@
           </a:p>
           <a:p xmlns:a="http://schemas.openxmlformats.org/drawingml/2006/main">
             <a:r>
-              <a:t>“Woven rechecks the price and stock, then creates an exact ten-minute checkout preview. The AI recommended this cart, but it cannot approve it. The user sees the merchant, every item, the pickup location, and the S$133 total before one direct confirmation.”</a:t>
+              <a:t>“Woven rechecks price and stock, then creates an exact ten-minute checkout preview. The AI recommended this cart, but it cannot approve it. Only one direct click can confirm the displayed terms.”</a:t>
             </a:r>
           </a:p>
           <a:p xmlns:a="http://schemas.openxmlformats.org/drawingml/2006/main">
@@ -1374,7 +1372,7 @@
           </a:p>
           <a:p xmlns:a="http://schemas.openxmlformats.org/drawingml/2006/main">
             <a:r>
-              <a:t>“Only after that click does Woven produce a simulated Visa authorization and pickup receipt. No card details enter Woven, and no live charge occurs.”</a:t>
+              <a:t>“Only after that click does Woven return a simulated Visa result and a server-verifiable receipt. No card details enter Woven, and no live charge occurs.”</a:t>
             </a:r>
           </a:p>
           <a:p xmlns:a="http://schemas.openxmlformats.org/drawingml/2006/main">
@@ -1389,7 +1387,7 @@
           </a:p>
           <a:p xmlns:a="http://schemas.openxmlformats.org/drawingml/2006/main">
             <a:r>
-              <a:t>Identity verification is planned and not in the live build. Do not show a static identity mock as verification. After server enforcement exists, insert the connector-style demo identity check before exact-term review and keep it separate from final confirmation.</a:t>
+              <a:t>Identity verification is planned and not in the live build. Do not show a static identity mock as verification.</a:t>
             </a:r>
           </a:p>
           <a:p xmlns:a="http://schemas.openxmlformats.org/drawingml/2006/main">
@@ -1424,7 +1422,7 @@
           </a:p>
           <a:p xmlns:a="http://schemas.openxmlformats.org/drawingml/2006/main">
             <a:r>
-              <a:t>- docs/architecture.md — Confirmation boundary and mandate binding</a:t>
+              <a:t>- docs/architecture.md — Confirmation boundary, mandate binding, and receipt signing</a:t>
             </a:r>
           </a:p>
           <a:p xmlns:a="http://schemas.openxmlformats.org/drawingml/2006/main">
@@ -1509,7 +1507,7 @@
           </a:p>
           <a:p xmlns:a="http://schemas.openxmlformats.org/drawingml/2006/main">
             <a:r>
-              <a:t>Prove that merchants control inventory, scenarios, orders, and auditability.</a:t>
+              <a:t>Prove that merchants control what the AI may offer and can test recovery live.</a:t>
             </a:r>
           </a:p>
           <a:p xmlns:a="http://schemas.openxmlformats.org/drawingml/2006/main">
@@ -1524,7 +1522,7 @@
           </a:p>
           <a:p xmlns:a="http://schemas.openxmlformats.org/drawingml/2006/main">
             <a:r>
-              <a:t>Open the Merchant Desk. Show inventory and price controls, confirmed orders, the audit trail, and the stockout, price-change, decline, and reversal scenarios.</a:t>
+              <a:t>Open the Merchant Desk. Show approved alternatives, inventory and price controls, confirmed orders, the audit trail, and the stockout, price-change, decline, and reversal scenarios.</a:t>
             </a:r>
           </a:p>
           <a:p xmlns:a="http://schemas.openxmlformats.org/drawingml/2006/main">
@@ -1539,7 +1537,7 @@
           </a:p>
           <a:p xmlns:a="http://schemas.openxmlformats.org/drawingml/2006/main">
             <a:r>
-              <a:t>“On the merchant side, Woven already supports inventory import, price and stock controls, orders, and an audit trail. Merchants can simulate a price change, stockout, authorization decline, or reversal without changing code.”</a:t>
+              <a:t>“Merchants publish compatible alternatives, control price and stock, and see exact confirmed orders. Withdrawing a swap invalidates dependent unconfirmed carts, so Woven rebuilds fresh choices instead of silently substituting.”</a:t>
             </a:r>
           </a:p>
           <a:p xmlns:a="http://schemas.openxmlformats.org/drawingml/2006/main">
@@ -1554,7 +1552,7 @@
           </a:p>
           <a:p xmlns:a="http://schemas.openxmlformats.org/drawingml/2006/main">
             <a:r>
-              <a:t>Call the current values seeded demo data. Do not call the CSV workflow a production merchant integration or imply a live payment rail.</a:t>
+              <a:t>Call the current values seeded demo data. Do not imply a production merchant integration or live payment rail.</a:t>
             </a:r>
           </a:p>
           <a:p xmlns:a="http://schemas.openxmlformats.org/drawingml/2006/main">
@@ -1594,7 +1592,7 @@
           </a:p>
           <a:p xmlns:a="http://schemas.openxmlformats.org/drawingml/2006/main">
             <a:r>
-              <a:t>- docs/architecture.md — Merchant state and failure paths</a:t>
+              <a:t>- docs/architecture.md — Merchant state and recovery paths</a:t>
             </a:r>
           </a:p>
         </p:txBody>
@@ -1689,7 +1687,7 @@
           </a:p>
           <a:p xmlns:a="http://schemas.openxmlformats.org/drawingml/2006/main">
             <a:r>
-              <a:t>“Why ChatGPT? Because that is where the user’s request already exists. Why a plugin? Because Woven can turn that conversation into merchant actions and a reviewable checkout without asking the user to start again.”</a:t>
+              <a:t>“Why ChatGPT? Because that is where the user’s request already exists. Woven turns that conversation into comparable merchant actions, an exact checkout, and a signed receipt without asking the user to start again.”</a:t>
             </a:r>
           </a:p>
           <a:p xmlns:a="http://schemas.openxmlformats.org/drawingml/2006/main">
@@ -1839,7 +1837,7 @@
           </a:p>
           <a:p xmlns:a="http://schemas.openxmlformats.org/drawingml/2006/main">
             <a:r>
-              <a:t>The working prototype includes the MCP App and browser fallback, complete one-merchant carts, compatibility and budget proof, exact expiring checkout terms, direct confirmation, idempotency, merchant operations, failure scenarios, and an audit trail.</a:t>
+              <a:t>The working prototype includes the MCP App and browser fallback, five ranked complete carts, comparison and preference controls, compatible merchant-approved swaps, pickup planning, stale-cart recovery, exact expiring checkout terms, direct confirmation, idempotency, signed receipts, merchant controls, failure scenarios, and an audit trail.</a:t>
             </a:r>
           </a:p>
           <a:p xmlns:a="http://schemas.openxmlformats.org/drawingml/2006/main">
@@ -2062,7 +2060,7 @@
   </p:cSld>
   <p:clrMap bg1="lt1" tx1="dk1" bg2="lt2" tx2="dk2" accent1="accent1" accent2="accent2" accent3="accent3" accent4="accent4" accent5="accent5" accent6="accent6" hlink="hlink" folHlink="folHlink"/>
   <p:sldLayoutIdLst>
-    <p:sldLayoutId xmlns:r="http://schemas.openxmlformats.org/officeDocument/2006/relationships" id="2147483649" r:id="R02831dc36adb413d"/>
+    <p:sldLayoutId xmlns:r="http://schemas.openxmlformats.org/officeDocument/2006/relationships" id="2147483649" r:id="R41e51d75fcdc47d2"/>
   </p:sldLayoutIdLst>
   <p:txStyles>
     <p:titleStyle>
@@ -3179,14 +3177,14 @@
       </p:sp>
       <p:pic>
         <p:nvPicPr>
-          <p:cNvPr id="21" name=""/>
+          <p:cNvPr id="20" name=""/>
           <p:cNvPicPr>
             <a:picLocks xmlns:a="http://schemas.openxmlformats.org/drawingml/2006/main" noChangeAspect="1"/>
           </p:cNvPicPr>
           <p:nvPr/>
         </p:nvPicPr>
         <p:blipFill>
-          <a:blip xmlns:r="http://schemas.openxmlformats.org/officeDocument/2006/relationships" xmlns:a="http://schemas.openxmlformats.org/drawingml/2006/main" r:embed="R64deff9c5da942be"/>
+          <a:blip xmlns:r="http://schemas.openxmlformats.org/officeDocument/2006/relationships" xmlns:a="http://schemas.openxmlformats.org/drawingml/2006/main" r:embed="R14f3d1fe560b423d"/>
           <a:srcRect xmlns:a="http://schemas.openxmlformats.org/drawingml/2006/main" l="12000" t="0" r="2000" b="0"/>
           <a:stretch xmlns:a="http://schemas.openxmlformats.org/drawingml/2006/main">
             <a:fillRect l="0" t="0" r="0" b="0"/>
@@ -3233,7 +3231,7 @@
           <p:nvPr/>
         </p:nvPicPr>
         <p:blipFill>
-          <a:blip xmlns:r="http://schemas.openxmlformats.org/officeDocument/2006/relationships" xmlns:a="http://schemas.openxmlformats.org/drawingml/2006/main" r:embed="R9bffdb01cf344feb"/>
+          <a:blip xmlns:r="http://schemas.openxmlformats.org/officeDocument/2006/relationships" xmlns:a="http://schemas.openxmlformats.org/drawingml/2006/main" r:embed="Ra4bfcb8d8a184bbe"/>
           <a:srcRect xmlns:a="http://schemas.openxmlformats.org/drawingml/2006/main" l="0" t="0" r="0" b="0"/>
           <a:stretch xmlns:a="http://schemas.openxmlformats.org/drawingml/2006/main">
             <a:fillRect l="0" t="0" r="0" b="0"/>
@@ -3691,7 +3689,7 @@
           <p:nvPr/>
         </p:nvPicPr>
         <p:blipFill>
-          <a:blip xmlns:r="http://schemas.openxmlformats.org/officeDocument/2006/relationships" xmlns:a="http://schemas.openxmlformats.org/drawingml/2006/main" r:embed="R3785bd862f514d5a"/>
+          <a:blip xmlns:r="http://schemas.openxmlformats.org/officeDocument/2006/relationships" xmlns:a="http://schemas.openxmlformats.org/drawingml/2006/main" r:embed="R4b901183a5ee44a0"/>
           <a:stretch xmlns:a="http://schemas.openxmlformats.org/drawingml/2006/main"/>
         </p:blipFill>
         <p:spPr>
@@ -3826,100 +3824,6 @@
     <p:extLst>
       <p:ext uri="{BB962C8B-B14F-4D97-AF65-F5344CB8AC3E}">
         <p14:creationId xmlns:p14="http://schemas.microsoft.com/office/powerpoint/2010/main" val="2091917452"/>
-      </p:ext>
-    </p:extLst>
-  </p:cSld>
-</p:sld>
-</file>
-
-<file path=ppt/slides/slide12.xml><?xml version="1.0" encoding="utf-8"?>
-<p:sld xmlns:p="http://schemas.openxmlformats.org/presentationml/2006/main">
-  <p:cSld>
-    <p:spTree>
-      <p:nvGrpSpPr>
-        <p:cNvPr id="1" name=""/>
-        <p:cNvGrpSpPr/>
-        <p:nvPr/>
-      </p:nvGrpSpPr>
-      <p:grpSpPr>
-        <a:xfrm xmlns:a="http://schemas.openxmlformats.org/drawingml/2006/main"/>
-      </p:grpSpPr>
-      <p:pic>
-        <p:nvPicPr>
-          <p:cNvPr id="2" name=""/>
-          <p:cNvPicPr>
-            <a:picLocks xmlns:a="http://schemas.openxmlformats.org/drawingml/2006/main" noChangeAspect="1"/>
-          </p:cNvPicPr>
-          <p:nvPr/>
-        </p:nvPicPr>
-        <p:blipFill>
-          <a:blip xmlns:r="http://schemas.openxmlformats.org/officeDocument/2006/relationships" xmlns:a="http://schemas.openxmlformats.org/drawingml/2006/main" r:embed="R9bffdb01cf344feb"/>
-          <a:srcRect xmlns:a="http://schemas.openxmlformats.org/drawingml/2006/main" l="0" t="0" r="0" b="0"/>
-          <a:stretch xmlns:a="http://schemas.openxmlformats.org/drawingml/2006/main">
-            <a:fillRect l="0" t="0" r="0" b="0"/>
-          </a:stretch>
-        </p:blipFill>
-        <p:spPr>
-          <a:xfrm xmlns:a="http://schemas.openxmlformats.org/drawingml/2006/main" flipH="0" flipV="0">
-            <a:off x="0" y="0"/>
-            <a:ext cx="15240000" cy="8572500"/>
-          </a:xfrm>
-          <a:prstGeom xmlns:a="http://schemas.openxmlformats.org/drawingml/2006/main" prst="rect">
-            <a:avLst/>
-          </a:prstGeom>
-        </p:spPr>
-      </p:pic>
-    </p:spTree>
-    <p:extLst>
-      <p:ext uri="{BB962C8B-B14F-4D97-AF65-F5344CB8AC3E}">
-        <p14:creationId xmlns:p14="http://schemas.microsoft.com/office/powerpoint/2010/main" val="614777387"/>
-      </p:ext>
-    </p:extLst>
-  </p:cSld>
-</p:sld>
-</file>
-
-<file path=ppt/slides/slide13.xml><?xml version="1.0" encoding="utf-8"?>
-<p:sld xmlns:p="http://schemas.openxmlformats.org/presentationml/2006/main">
-  <p:cSld>
-    <p:spTree>
-      <p:nvGrpSpPr>
-        <p:cNvPr id="1" name=""/>
-        <p:cNvGrpSpPr/>
-        <p:nvPr/>
-      </p:nvGrpSpPr>
-      <p:grpSpPr>
-        <a:xfrm xmlns:a="http://schemas.openxmlformats.org/drawingml/2006/main"/>
-      </p:grpSpPr>
-      <p:pic>
-        <p:nvPicPr>
-          <p:cNvPr id="2" name=""/>
-          <p:cNvPicPr>
-            <a:picLocks xmlns:a="http://schemas.openxmlformats.org/drawingml/2006/main" noChangeAspect="1"/>
-          </p:cNvPicPr>
-          <p:nvPr/>
-        </p:nvPicPr>
-        <p:blipFill>
-          <a:blip xmlns:r="http://schemas.openxmlformats.org/officeDocument/2006/relationships" xmlns:a="http://schemas.openxmlformats.org/drawingml/2006/main" r:embed="R9bffdb01cf344feb"/>
-          <a:srcRect xmlns:a="http://schemas.openxmlformats.org/drawingml/2006/main" l="0" t="0" r="0" b="0"/>
-          <a:stretch xmlns:a="http://schemas.openxmlformats.org/drawingml/2006/main">
-            <a:fillRect l="0" t="0" r="0" b="0"/>
-          </a:stretch>
-        </p:blipFill>
-        <p:spPr>
-          <a:xfrm xmlns:a="http://schemas.openxmlformats.org/drawingml/2006/main" flipH="0" flipV="0">
-            <a:off x="0" y="0"/>
-            <a:ext cx="15240000" cy="8572500"/>
-          </a:xfrm>
-          <a:prstGeom xmlns:a="http://schemas.openxmlformats.org/drawingml/2006/main" prst="rect">
-            <a:avLst/>
-          </a:prstGeom>
-        </p:spPr>
-      </p:pic>
-    </p:spTree>
-    <p:extLst>
-      <p:ext uri="{BB962C8B-B14F-4D97-AF65-F5344CB8AC3E}">
-        <p14:creationId xmlns:p14="http://schemas.microsoft.com/office/powerpoint/2010/main" val="614777387"/>
       </p:ext>
     </p:extLst>
   </p:cSld>
@@ -5432,7 +5336,7 @@
           <p:nvPr/>
         </p:nvPicPr>
         <p:blipFill>
-          <a:blip xmlns:r="http://schemas.openxmlformats.org/officeDocument/2006/relationships" xmlns:a="http://schemas.openxmlformats.org/drawingml/2006/main" r:embed="R815bc04db61343b4"/>
+          <a:blip xmlns:r="http://schemas.openxmlformats.org/officeDocument/2006/relationships" xmlns:a="http://schemas.openxmlformats.org/drawingml/2006/main" r:embed="Rdcf38bad2e744351"/>
           <a:stretch xmlns:a="http://schemas.openxmlformats.org/drawingml/2006/main"/>
         </p:blipFill>
         <p:spPr>
@@ -6354,7 +6258,7 @@
                 <a:ea typeface="Menlo"/>
                 <a:cs typeface="Menlo"/>
               </a:rPr>
-              <a:t>3 complete carts. 1 natural sentence.</a:t>
+              <a:t>5 complete choices. 1 natural sentence.</a:t>
             </a:r>
           </a:p>
         </p:txBody>
@@ -7645,7 +7549,7 @@
                 <a:ea typeface="Menlo"/>
                 <a:cs typeface="Menlo"/>
               </a:rPr>
-              <a:t>CATALOGUE</a:t>
+              <a:t>ALTERNATIVES</a:t>
             </a:r>
           </a:p>
         </p:txBody>
@@ -7704,7 +7608,7 @@
                 <a:ea typeface="Avenir Next"/>
                 <a:cs typeface="Avenir Next"/>
               </a:rPr>
-              <a:t>Import validated inventory</a:t>
+              <a:t>Publish compatible swaps</a:t>
             </a:r>
           </a:p>
         </p:txBody>
@@ -7822,7 +7726,7 @@
                 <a:ea typeface="Avenir Next"/>
                 <a:cs typeface="Avenir Next"/>
               </a:rPr>
-              <a:t>Update availability in seconds</a:t>
+              <a:t>Invalidate stale buyer carts</a:t>
             </a:r>
           </a:p>
         </p:txBody>
@@ -8111,7 +8015,7 @@
           <p:nvPr/>
         </p:nvPicPr>
         <p:blipFill>
-          <a:blip xmlns:r="http://schemas.openxmlformats.org/officeDocument/2006/relationships" xmlns:a="http://schemas.openxmlformats.org/drawingml/2006/main" r:embed="Rf6c24c0f2c7d4d70"/>
+          <a:blip xmlns:r="http://schemas.openxmlformats.org/officeDocument/2006/relationships" xmlns:a="http://schemas.openxmlformats.org/drawingml/2006/main" r:embed="Re5c79d57683c468c"/>
           <a:stretch xmlns:a="http://schemas.openxmlformats.org/drawingml/2006/main"/>
         </p:blipFill>
         <p:spPr>
@@ -8761,8 +8665,11 @@
           <p:nvPr/>
         </p:nvPicPr>
         <p:blipFill>
-          <a:blip xmlns:r="http://schemas.openxmlformats.org/officeDocument/2006/relationships" xmlns:a="http://schemas.openxmlformats.org/drawingml/2006/main" r:embed="R442128613b45476b"/>
-          <a:stretch xmlns:a="http://schemas.openxmlformats.org/drawingml/2006/main"/>
+          <a:blip xmlns:r="http://schemas.openxmlformats.org/officeDocument/2006/relationships" xmlns:a="http://schemas.openxmlformats.org/drawingml/2006/main" r:embed="Rce2a89a156cd4888"/>
+          <a:srcRect xmlns:a="http://schemas.openxmlformats.org/drawingml/2006/main" l="0" t="0" r="0" b="0"/>
+          <a:stretch xmlns:a="http://schemas.openxmlformats.org/drawingml/2006/main">
+            <a:fillRect l="0" t="0" r="0" b="0"/>
+          </a:stretch>
         </p:blipFill>
         <p:spPr>
           <a:xfrm xmlns:a="http://schemas.openxmlformats.org/drawingml/2006/main" flipH="0" flipV="0">
@@ -8828,7 +8735,7 @@
                 <a:ea typeface="Menlo"/>
                 <a:cs typeface="Menlo"/>
               </a:rPr>
-              <a:t>IDENTITY PLANNED · VISA AUTHORIZATION SIMULATED</a:t>
+              <a:t>IDENTITY PLANNED · VISA SIMULATED · RECEIPT VERIFIED</a:t>
             </a:r>
           </a:p>
         </p:txBody>
@@ -9310,8 +9217,8 @@
                 <a:ea typeface="Avenir Next"/>
                 <a:cs typeface="Avenir Next"/>
               </a:rPr>
-              <a:t>Complete one-merchant carts.
-Compatibility · budget · pickup.</a:t>
+              <a:t>Five ranked complete carts.
+Compare · preferences · safe swaps.</a:t>
             </a:r>
           </a:p>
         </p:txBody>
@@ -9526,7 +9433,7 @@
                 <a:cs typeface="Avenir Next"/>
               </a:rPr>
               <a:t>Expiring exact terms.
-Direct confirmation · idempotency.</a:t>
+Direct confirmation · signed receipt.</a:t>
             </a:r>
           </a:p>
         </p:txBody>
@@ -9740,8 +9647,8 @@
                 <a:ea typeface="Avenir Next"/>
                 <a:cs typeface="Avenir Next"/>
               </a:rPr>
-              <a:t>Inventory · scenarios · orders.
-Audit trail.</a:t>
+              <a:t>Alternatives · inventory · scenarios.
+Orders · audit trail.</a:t>
             </a:r>
           </a:p>
         </p:txBody>

</xml_diff>

<commit_message>
archive(chore): preserve choice-suite stash
Archive the exact 30 August choice-suite stash before local repository cleanup. A later preservation branch exists, but this retains the original snapshot independently.
</commit_message>
<xml_diff>
--- a/docs/Woven-Hackathon-Pitch.pptx
+++ b/docs/Woven-Hackathon-Pitch.pptx
@@ -2,23 +2,23 @@
 <file path=ppt/presentation.xml><?xml version="1.0" encoding="utf-8"?>
 <p:presentation xmlns:p="http://schemas.openxmlformats.org/presentationml/2006/main">
   <p:sldMasterIdLst>
-    <p:sldMasterId xmlns:r="http://schemas.openxmlformats.org/officeDocument/2006/relationships" id="2147483648" r:id="Rbd7b917bceef459a"/>
+    <p:sldMasterId xmlns:r="http://schemas.openxmlformats.org/officeDocument/2006/relationships" id="2147483648" r:id="R2fc6e8e20c084646"/>
   </p:sldMasterIdLst>
   <p:notesMasterIdLst>
-    <p:notesMasterId xmlns:r="http://schemas.openxmlformats.org/officeDocument/2006/relationships" r:id="Reb6cee3a506b43cf"/>
+    <p:notesMasterId xmlns:r="http://schemas.openxmlformats.org/officeDocument/2006/relationships" r:id="R91b2626ac2ad4dc0"/>
   </p:notesMasterIdLst>
   <p:sldIdLst>
-    <p:sldId xmlns:r="http://schemas.openxmlformats.org/officeDocument/2006/relationships" id="256" r:id="R5326ca9495684228"/>
-    <p:sldId xmlns:r="http://schemas.openxmlformats.org/officeDocument/2006/relationships" id="257" r:id="R7129933df5f84180"/>
-    <p:sldId xmlns:r="http://schemas.openxmlformats.org/officeDocument/2006/relationships" id="258" r:id="Ree048974157b4473"/>
-    <p:sldId xmlns:r="http://schemas.openxmlformats.org/officeDocument/2006/relationships" id="259" r:id="Rfbc0c85f698f4fa6"/>
-    <p:sldId xmlns:r="http://schemas.openxmlformats.org/officeDocument/2006/relationships" id="260" r:id="R4aba994753af4d4e"/>
-    <p:sldId xmlns:r="http://schemas.openxmlformats.org/officeDocument/2006/relationships" id="261" r:id="R1293d76b0bb24c15"/>
-    <p:sldId xmlns:r="http://schemas.openxmlformats.org/officeDocument/2006/relationships" id="262" r:id="R7b5ce42f81a54f6f"/>
-    <p:sldId xmlns:r="http://schemas.openxmlformats.org/officeDocument/2006/relationships" id="263" r:id="R42e87175a6a34fd9"/>
-    <p:sldId xmlns:r="http://schemas.openxmlformats.org/officeDocument/2006/relationships" id="264" r:id="R37dfb12e7e61470d"/>
-    <p:sldId xmlns:r="http://schemas.openxmlformats.org/officeDocument/2006/relationships" id="265" r:id="R43bbd7ed52b947d6"/>
-    <p:sldId xmlns:r="http://schemas.openxmlformats.org/officeDocument/2006/relationships" id="266" r:id="R6026b644a94e4a72"/>
+    <p:sldId xmlns:r="http://schemas.openxmlformats.org/officeDocument/2006/relationships" id="256" r:id="Rb4039db9e0344b88"/>
+    <p:sldId xmlns:r="http://schemas.openxmlformats.org/officeDocument/2006/relationships" id="257" r:id="R95ec7d74113a47dd"/>
+    <p:sldId xmlns:r="http://schemas.openxmlformats.org/officeDocument/2006/relationships" id="258" r:id="R727ef281f7534dd1"/>
+    <p:sldId xmlns:r="http://schemas.openxmlformats.org/officeDocument/2006/relationships" id="259" r:id="Rc2184f7aa1004714"/>
+    <p:sldId xmlns:r="http://schemas.openxmlformats.org/officeDocument/2006/relationships" id="260" r:id="Rf88b69f22c664df3"/>
+    <p:sldId xmlns:r="http://schemas.openxmlformats.org/officeDocument/2006/relationships" id="261" r:id="Rc86b445fd6774c61"/>
+    <p:sldId xmlns:r="http://schemas.openxmlformats.org/officeDocument/2006/relationships" id="262" r:id="R58dfaf1ab8e04ed8"/>
+    <p:sldId xmlns:r="http://schemas.openxmlformats.org/officeDocument/2006/relationships" id="263" r:id="Rd6ca70c8c5dd45fa"/>
+    <p:sldId xmlns:r="http://schemas.openxmlformats.org/officeDocument/2006/relationships" id="264" r:id="Ra37853021f864bc4"/>
+    <p:sldId xmlns:r="http://schemas.openxmlformats.org/officeDocument/2006/relationships" id="265" r:id="R015fd678ca324916"/>
+    <p:sldId xmlns:r="http://schemas.openxmlformats.org/officeDocument/2006/relationships" id="266" r:id="R4006603162ad4636"/>
   </p:sldIdLst>
   <p:sldSz cx="15240000" cy="8572500"/>
   <p:notesSz cx="6858000" cy="9144000"/>
@@ -1007,7 +1007,7 @@
           </a:p>
           <a:p xmlns:a="http://schemas.openxmlformats.org/drawingml/2006/main">
             <a:r>
-              <a:t>“Woven understands the complete request, eliminates incompatible combinations, and creates ready-to-buy carts. Every cart comes from one merchant and one location, with an explanation of why every component works.”</a:t>
+              <a:t>“Woven understands the complete request, eliminates incompatible combinations, and creates five ready-to-buy choices in one comparison workspace. Every cart comes from one merchant and one location, with an explanation of why every component works.”</a:t>
             </a:r>
           </a:p>
           <a:p xmlns:a="http://schemas.openxmlformats.org/drawingml/2006/main">
@@ -1022,7 +1022,7 @@
           </a:p>
           <a:p xmlns:a="http://schemas.openxmlformats.org/drawingml/2006/main">
             <a:r>
-              <a:t>One merchant and pickup point. Four compatible components. S$133 total. Pickup today.</a:t>
+              <a:t>Compare priorities and pickup areas. One merchant and pickup point. Four compatible components. S$133 total. Pickup today.</a:t>
             </a:r>
           </a:p>
           <a:p xmlns:a="http://schemas.openxmlformats.org/drawingml/2006/main">
@@ -1172,17 +1172,17 @@
           </a:p>
           <a:p xmlns:a="http://schemas.openxmlformats.org/drawingml/2006/main">
             <a:r>
-              <a:t>1. Show the three ranked, one-merchant carts.</a:t>
-            </a:r>
-          </a:p>
-          <a:p xmlns:a="http://schemas.openxmlformats.org/drawingml/2006/main">
-            <a:r>
-              <a:t>2. Select ByteRoute.</a:t>
-            </a:r>
-          </a:p>
-          <a:p xmlns:a="http://schemas.openxmlformats.org/drawingml/2006/main">
-            <a:r>
-              <a:t>3. Point to charger wattage and voltage, both required cables, the Japan adapter, one pickup location, seeded demo stock, and the S$133 total.</a:t>
+              <a:t>1. Open the five-choice Choice Center.</a:t>
+            </a:r>
+          </a:p>
+          <a:p xmlns:a="http://schemas.openxmlformats.org/drawingml/2006/main">
+            <a:r>
+              <a:t>2. Compare carts, rerank by pickup or value, and return to Best match.</a:t>
+            </a:r>
+          </a:p>
+          <a:p xmlns:a="http://schemas.openxmlformats.org/drawingml/2006/main">
+            <a:r>
+              <a:t>3. Select ByteRoute, point to “Why this works,” make the approved cable swap, and show the pickup planner.</a:t>
             </a:r>
           </a:p>
           <a:p xmlns:a="http://schemas.openxmlformats.org/drawingml/2006/main">
@@ -1197,7 +1197,7 @@
           </a:p>
           <a:p xmlns:a="http://schemas.openxmlformats.org/drawingml/2006/main">
             <a:r>
-              <a:t>“Woven returned three complete options—not loose product links. This S$133 cart includes the charger, both required cables, and the Japan adapter. Everything is compatible, under budget, available in our demo inventory, and ready at one pickup location.”</a:t>
+              <a:t>“Woven returned five complete choices—not loose product links. I can compare exact carts, change priorities, and make only merchant-approved compatible swaps without rebuilding the request.”</a:t>
             </a:r>
           </a:p>
           <a:p xmlns:a="http://schemas.openxmlformats.org/drawingml/2006/main">
@@ -1212,7 +1212,7 @@
           </a:p>
           <a:p xmlns:a="http://schemas.openxmlformats.org/drawingml/2006/main">
             <a:r>
-              <a:t>Do not explain the ranking algorithm unless asked. If the MCP host fails, move immediately to /demo; it uses the same backend.</a:t>
+              <a:t>If the MCP host fails, move immediately to /demo; it uses the same backend.</a:t>
             </a:r>
           </a:p>
           <a:p xmlns:a="http://schemas.openxmlformats.org/drawingml/2006/main">
@@ -1347,7 +1347,7 @@
           </a:p>
           <a:p xmlns:a="http://schemas.openxmlformats.org/drawingml/2006/main">
             <a:r>
-              <a:t>4. Confirm and show the simulated Visa authorization result and pickup receipt.</a:t>
+              <a:t>4. Confirm and show the simulated Visa result and exact signed receipt.</a:t>
             </a:r>
           </a:p>
           <a:p xmlns:a="http://schemas.openxmlformats.org/drawingml/2006/main">
@@ -1362,7 +1362,7 @@
           </a:p>
           <a:p xmlns:a="http://schemas.openxmlformats.org/drawingml/2006/main">
             <a:r>
-              <a:t>“Woven rechecks the price and stock, then creates an exact ten-minute checkout preview. The AI recommended this cart, but it cannot approve it. The user sees the merchant, every item, the pickup location, and the S$133 total before one direct confirmation.”</a:t>
+              <a:t>“Woven rechecks price and stock, then creates an exact ten-minute checkout preview. The AI recommended this cart, but it cannot approve it. Only one direct click can confirm the displayed terms.”</a:t>
             </a:r>
           </a:p>
           <a:p xmlns:a="http://schemas.openxmlformats.org/drawingml/2006/main">
@@ -1372,7 +1372,7 @@
           </a:p>
           <a:p xmlns:a="http://schemas.openxmlformats.org/drawingml/2006/main">
             <a:r>
-              <a:t>“Only after that click does Woven produce a simulated Visa authorization and pickup receipt. No card details enter Woven, and no live charge occurs.”</a:t>
+              <a:t>“Only after that click does Woven return a simulated Visa result and a server-verifiable receipt. No card details enter Woven, and no live charge occurs.”</a:t>
             </a:r>
           </a:p>
           <a:p xmlns:a="http://schemas.openxmlformats.org/drawingml/2006/main">
@@ -1387,7 +1387,7 @@
           </a:p>
           <a:p xmlns:a="http://schemas.openxmlformats.org/drawingml/2006/main">
             <a:r>
-              <a:t>Identity verification is planned and not in the live build. Do not show a static identity mock as verification. After server enforcement exists, insert the connector-style demo identity check before exact-term review and keep it separate from final confirmation.</a:t>
+              <a:t>Identity verification is planned and not in the live build. Do not show a static identity mock as verification.</a:t>
             </a:r>
           </a:p>
           <a:p xmlns:a="http://schemas.openxmlformats.org/drawingml/2006/main">
@@ -1422,7 +1422,7 @@
           </a:p>
           <a:p xmlns:a="http://schemas.openxmlformats.org/drawingml/2006/main">
             <a:r>
-              <a:t>- docs/architecture.md — Confirmation boundary and mandate binding</a:t>
+              <a:t>- docs/architecture.md — Confirmation boundary, mandate binding, and receipt signing</a:t>
             </a:r>
           </a:p>
           <a:p xmlns:a="http://schemas.openxmlformats.org/drawingml/2006/main">
@@ -1507,7 +1507,7 @@
           </a:p>
           <a:p xmlns:a="http://schemas.openxmlformats.org/drawingml/2006/main">
             <a:r>
-              <a:t>Prove that merchants control inventory, scenarios, orders, and auditability.</a:t>
+              <a:t>Prove that merchants control what the AI may offer and can test recovery live.</a:t>
             </a:r>
           </a:p>
           <a:p xmlns:a="http://schemas.openxmlformats.org/drawingml/2006/main">
@@ -1522,7 +1522,7 @@
           </a:p>
           <a:p xmlns:a="http://schemas.openxmlformats.org/drawingml/2006/main">
             <a:r>
-              <a:t>Open the Merchant Desk. Show inventory and price controls, confirmed orders, the audit trail, and the stockout, price-change, decline, and reversal scenarios.</a:t>
+              <a:t>Open the Merchant Desk. Show approved alternatives, inventory and price controls, confirmed orders, the audit trail, and the stockout, price-change, decline, and reversal scenarios.</a:t>
             </a:r>
           </a:p>
           <a:p xmlns:a="http://schemas.openxmlformats.org/drawingml/2006/main">
@@ -1537,7 +1537,7 @@
           </a:p>
           <a:p xmlns:a="http://schemas.openxmlformats.org/drawingml/2006/main">
             <a:r>
-              <a:t>“On the merchant side, Woven already supports inventory import, price and stock controls, orders, and an audit trail. Merchants can simulate a price change, stockout, authorization decline, or reversal without changing code.”</a:t>
+              <a:t>“Merchants publish compatible alternatives, control price and stock, and see exact confirmed orders. Withdrawing a swap invalidates dependent unconfirmed carts, so Woven rebuilds fresh choices instead of silently substituting.”</a:t>
             </a:r>
           </a:p>
           <a:p xmlns:a="http://schemas.openxmlformats.org/drawingml/2006/main">
@@ -1552,7 +1552,7 @@
           </a:p>
           <a:p xmlns:a="http://schemas.openxmlformats.org/drawingml/2006/main">
             <a:r>
-              <a:t>Call the current values seeded demo data. Do not call the CSV workflow a production merchant integration or imply a live payment rail.</a:t>
+              <a:t>Call the current values seeded demo data. Do not imply a production merchant integration or live payment rail.</a:t>
             </a:r>
           </a:p>
           <a:p xmlns:a="http://schemas.openxmlformats.org/drawingml/2006/main">
@@ -1592,7 +1592,7 @@
           </a:p>
           <a:p xmlns:a="http://schemas.openxmlformats.org/drawingml/2006/main">
             <a:r>
-              <a:t>- docs/architecture.md — Merchant state and failure paths</a:t>
+              <a:t>- docs/architecture.md — Merchant state and recovery paths</a:t>
             </a:r>
           </a:p>
         </p:txBody>
@@ -1687,7 +1687,7 @@
           </a:p>
           <a:p xmlns:a="http://schemas.openxmlformats.org/drawingml/2006/main">
             <a:r>
-              <a:t>“Why ChatGPT? Because that is where the user’s request already exists. Why a plugin? Because Woven can turn that conversation into merchant actions and a reviewable checkout without asking the user to start again.”</a:t>
+              <a:t>“Why ChatGPT? Because that is where the user’s request already exists. Woven turns that conversation into comparable merchant actions, an exact checkout, and a signed receipt without asking the user to start again.”</a:t>
             </a:r>
           </a:p>
           <a:p xmlns:a="http://schemas.openxmlformats.org/drawingml/2006/main">
@@ -1837,7 +1837,7 @@
           </a:p>
           <a:p xmlns:a="http://schemas.openxmlformats.org/drawingml/2006/main">
             <a:r>
-              <a:t>The working prototype includes the MCP App and browser fallback, complete one-merchant carts, compatibility and budget proof, exact expiring checkout terms, direct confirmation, idempotency, merchant operations, failure scenarios, and an audit trail.</a:t>
+              <a:t>The working prototype includes the MCP App and browser fallback, five ranked complete carts, comparison and preference controls, compatible merchant-approved swaps, pickup planning, stale-cart recovery, exact expiring checkout terms, direct confirmation, idempotency, signed receipts, merchant controls, failure scenarios, and an audit trail.</a:t>
             </a:r>
           </a:p>
           <a:p xmlns:a="http://schemas.openxmlformats.org/drawingml/2006/main">
@@ -2060,7 +2060,7 @@
   </p:cSld>
   <p:clrMap bg1="lt1" tx1="dk1" bg2="lt2" tx2="dk2" accent1="accent1" accent2="accent2" accent3="accent3" accent4="accent4" accent5="accent5" accent6="accent6" hlink="hlink" folHlink="folHlink"/>
   <p:sldLayoutIdLst>
-    <p:sldLayoutId xmlns:r="http://schemas.openxmlformats.org/officeDocument/2006/relationships" id="2147483649" r:id="R02831dc36adb413d"/>
+    <p:sldLayoutId xmlns:r="http://schemas.openxmlformats.org/officeDocument/2006/relationships" id="2147483649" r:id="R41e51d75fcdc47d2"/>
   </p:sldLayoutIdLst>
   <p:txStyles>
     <p:titleStyle>
@@ -3177,14 +3177,14 @@
       </p:sp>
       <p:pic>
         <p:nvPicPr>
-          <p:cNvPr id="21" name=""/>
+          <p:cNvPr id="20" name=""/>
           <p:cNvPicPr>
             <a:picLocks xmlns:a="http://schemas.openxmlformats.org/drawingml/2006/main" noChangeAspect="1"/>
           </p:cNvPicPr>
           <p:nvPr/>
         </p:nvPicPr>
         <p:blipFill>
-          <a:blip xmlns:r="http://schemas.openxmlformats.org/officeDocument/2006/relationships" xmlns:a="http://schemas.openxmlformats.org/drawingml/2006/main" r:embed="R64deff9c5da942be"/>
+          <a:blip xmlns:r="http://schemas.openxmlformats.org/officeDocument/2006/relationships" xmlns:a="http://schemas.openxmlformats.org/drawingml/2006/main" r:embed="R14f3d1fe560b423d"/>
           <a:srcRect xmlns:a="http://schemas.openxmlformats.org/drawingml/2006/main" l="12000" t="0" r="2000" b="0"/>
           <a:stretch xmlns:a="http://schemas.openxmlformats.org/drawingml/2006/main">
             <a:fillRect l="0" t="0" r="0" b="0"/>
@@ -3231,7 +3231,7 @@
           <p:nvPr/>
         </p:nvPicPr>
         <p:blipFill>
-          <a:blip xmlns:r="http://schemas.openxmlformats.org/officeDocument/2006/relationships" xmlns:a="http://schemas.openxmlformats.org/drawingml/2006/main" r:embed="R9bffdb01cf344feb"/>
+          <a:blip xmlns:r="http://schemas.openxmlformats.org/officeDocument/2006/relationships" xmlns:a="http://schemas.openxmlformats.org/drawingml/2006/main" r:embed="Ra4bfcb8d8a184bbe"/>
           <a:srcRect xmlns:a="http://schemas.openxmlformats.org/drawingml/2006/main" l="0" t="0" r="0" b="0"/>
           <a:stretch xmlns:a="http://schemas.openxmlformats.org/drawingml/2006/main">
             <a:fillRect l="0" t="0" r="0" b="0"/>
@@ -3689,7 +3689,7 @@
           <p:nvPr/>
         </p:nvPicPr>
         <p:blipFill>
-          <a:blip xmlns:r="http://schemas.openxmlformats.org/officeDocument/2006/relationships" xmlns:a="http://schemas.openxmlformats.org/drawingml/2006/main" r:embed="R3785bd862f514d5a"/>
+          <a:blip xmlns:r="http://schemas.openxmlformats.org/officeDocument/2006/relationships" xmlns:a="http://schemas.openxmlformats.org/drawingml/2006/main" r:embed="R4b901183a5ee44a0"/>
           <a:stretch xmlns:a="http://schemas.openxmlformats.org/drawingml/2006/main"/>
         </p:blipFill>
         <p:spPr>
@@ -5336,7 +5336,7 @@
           <p:nvPr/>
         </p:nvPicPr>
         <p:blipFill>
-          <a:blip xmlns:r="http://schemas.openxmlformats.org/officeDocument/2006/relationships" xmlns:a="http://schemas.openxmlformats.org/drawingml/2006/main" r:embed="R815bc04db61343b4"/>
+          <a:blip xmlns:r="http://schemas.openxmlformats.org/officeDocument/2006/relationships" xmlns:a="http://schemas.openxmlformats.org/drawingml/2006/main" r:embed="Rdcf38bad2e744351"/>
           <a:stretch xmlns:a="http://schemas.openxmlformats.org/drawingml/2006/main"/>
         </p:blipFill>
         <p:spPr>
@@ -6258,7 +6258,7 @@
                 <a:ea typeface="Menlo"/>
                 <a:cs typeface="Menlo"/>
               </a:rPr>
-              <a:t>3 complete carts. 1 natural sentence.</a:t>
+              <a:t>5 complete choices. 1 natural sentence.</a:t>
             </a:r>
           </a:p>
         </p:txBody>
@@ -7549,7 +7549,7 @@
                 <a:ea typeface="Menlo"/>
                 <a:cs typeface="Menlo"/>
               </a:rPr>
-              <a:t>CATALOGUE</a:t>
+              <a:t>ALTERNATIVES</a:t>
             </a:r>
           </a:p>
         </p:txBody>
@@ -7608,7 +7608,7 @@
                 <a:ea typeface="Avenir Next"/>
                 <a:cs typeface="Avenir Next"/>
               </a:rPr>
-              <a:t>Import validated inventory</a:t>
+              <a:t>Publish compatible swaps</a:t>
             </a:r>
           </a:p>
         </p:txBody>
@@ -7726,7 +7726,7 @@
                 <a:ea typeface="Avenir Next"/>
                 <a:cs typeface="Avenir Next"/>
               </a:rPr>
-              <a:t>Update availability in seconds</a:t>
+              <a:t>Invalidate stale buyer carts</a:t>
             </a:r>
           </a:p>
         </p:txBody>
@@ -8015,7 +8015,7 @@
           <p:nvPr/>
         </p:nvPicPr>
         <p:blipFill>
-          <a:blip xmlns:r="http://schemas.openxmlformats.org/officeDocument/2006/relationships" xmlns:a="http://schemas.openxmlformats.org/drawingml/2006/main" r:embed="Rf6c24c0f2c7d4d70"/>
+          <a:blip xmlns:r="http://schemas.openxmlformats.org/officeDocument/2006/relationships" xmlns:a="http://schemas.openxmlformats.org/drawingml/2006/main" r:embed="Re5c79d57683c468c"/>
           <a:stretch xmlns:a="http://schemas.openxmlformats.org/drawingml/2006/main"/>
         </p:blipFill>
         <p:spPr>
@@ -8665,8 +8665,11 @@
           <p:nvPr/>
         </p:nvPicPr>
         <p:blipFill>
-          <a:blip xmlns:r="http://schemas.openxmlformats.org/officeDocument/2006/relationships" xmlns:a="http://schemas.openxmlformats.org/drawingml/2006/main" r:embed="R442128613b45476b"/>
-          <a:stretch xmlns:a="http://schemas.openxmlformats.org/drawingml/2006/main"/>
+          <a:blip xmlns:r="http://schemas.openxmlformats.org/officeDocument/2006/relationships" xmlns:a="http://schemas.openxmlformats.org/drawingml/2006/main" r:embed="Rce2a89a156cd4888"/>
+          <a:srcRect xmlns:a="http://schemas.openxmlformats.org/drawingml/2006/main" l="0" t="0" r="0" b="0"/>
+          <a:stretch xmlns:a="http://schemas.openxmlformats.org/drawingml/2006/main">
+            <a:fillRect l="0" t="0" r="0" b="0"/>
+          </a:stretch>
         </p:blipFill>
         <p:spPr>
           <a:xfrm xmlns:a="http://schemas.openxmlformats.org/drawingml/2006/main" flipH="0" flipV="0">
@@ -8732,7 +8735,7 @@
                 <a:ea typeface="Menlo"/>
                 <a:cs typeface="Menlo"/>
               </a:rPr>
-              <a:t>IDENTITY PLANNED · VISA AUTHORIZATION SIMULATED</a:t>
+              <a:t>IDENTITY PLANNED · VISA SIMULATED · RECEIPT VERIFIED</a:t>
             </a:r>
           </a:p>
         </p:txBody>
@@ -9214,8 +9217,8 @@
                 <a:ea typeface="Avenir Next"/>
                 <a:cs typeface="Avenir Next"/>
               </a:rPr>
-              <a:t>Complete one-merchant carts.
-Compatibility · budget · pickup.</a:t>
+              <a:t>Five ranked complete carts.
+Compare · preferences · safe swaps.</a:t>
             </a:r>
           </a:p>
         </p:txBody>
@@ -9430,7 +9433,7 @@
                 <a:cs typeface="Avenir Next"/>
               </a:rPr>
               <a:t>Expiring exact terms.
-Direct confirmation · idempotency.</a:t>
+Direct confirmation · signed receipt.</a:t>
             </a:r>
           </a:p>
         </p:txBody>
@@ -9644,8 +9647,8 @@
                 <a:ea typeface="Avenir Next"/>
                 <a:cs typeface="Avenir Next"/>
               </a:rPr>
-              <a:t>Inventory · scenarios · orders.
-Audit trail.</a:t>
+              <a:t>Alternatives · inventory · scenarios.
+Orders · audit trail.</a:t>
             </a:r>
           </a:p>
         </p:txBody>

</xml_diff>